<commit_message>
refactor(presentation): simplify slide deck with text-light high-impact visuals and bullet points
</commit_message>
<xml_diff>
--- a/BidTrace_Pitch_Deck_2Min.pptx
+++ b/BidTrace_Pitch_Deck_2Min.pptx
@@ -3954,8 +3954,8 @@
         </p:blipFill>
         <p:spPr>
           <a:xfrm>
-            <a:off x="1097280" y="1645920"/>
-            <a:ext cx="1463040" cy="1651395"/>
+            <a:off x="1097280" y="1463040"/>
+            <a:ext cx="1645920" cy="1857820"/>
           </a:xfrm>
           <a:prstGeom prst="rect">
             <a:avLst/>
@@ -3970,7 +3970,7 @@
         </p:nvSpPr>
         <p:spPr>
           <a:xfrm>
-            <a:off x="2926080" y="1691640"/>
+            <a:off x="3017520" y="1508760"/>
             <a:ext cx="3474720" cy="411480"/>
           </a:xfrm>
           <a:prstGeom prst="roundRect">
@@ -4024,8 +4024,8 @@
         </p:nvSpPr>
         <p:spPr>
           <a:xfrm>
-            <a:off x="2834640" y="2148840"/>
-            <a:ext cx="8412480" cy="1371600"/>
+            <a:off x="2926080" y="1965960"/>
+            <a:ext cx="8229600" cy="1097280"/>
           </a:xfrm>
           <a:prstGeom prst="rect">
             <a:avLst/>
@@ -4033,13 +4033,13 @@
           <a:noFill/>
         </p:spPr>
         <p:txBody>
-          <a:bodyPr wrap="square">
+          <a:bodyPr wrap="none">
             <a:spAutoFit/>
           </a:bodyPr>
           <a:lstStyle/>
           <a:p>
             <a:pPr>
-              <a:defRPr sz="5400" b="1">
+              <a:defRPr sz="5600" b="1">
                 <a:solidFill>
                   <a:srgbClr val="FFFFFF"/>
                 </a:solidFill>
@@ -4059,8 +4059,8 @@
         </p:nvSpPr>
         <p:spPr>
           <a:xfrm>
-            <a:off x="1097280" y="3566160"/>
-            <a:ext cx="10058400" cy="1097280"/>
+            <a:off x="1097280" y="3291840"/>
+            <a:ext cx="10058400" cy="1188720"/>
           </a:xfrm>
           <a:prstGeom prst="rect">
             <a:avLst/>
@@ -4074,7 +4074,7 @@
           <a:lstStyle/>
           <a:p>
             <a:pPr>
-              <a:defRPr sz="2800" b="1">
+              <a:defRPr sz="3200" b="1">
                 <a:solidFill>
                   <a:srgbClr val="06B6D4"/>
                 </a:solidFill>
@@ -4082,18 +4082,6 @@
             </a:pPr>
             <a:r>
               <a:t>Tamper-Proof Sealed Bidding for Public Contracts on Solana</a:t>
-            </a:r>
-          </a:p>
-          <a:p>
-            <a:pPr>
-              <a:defRPr sz="1600">
-                <a:solidFill>
-                  <a:srgbClr val="94A3B8"/>
-                </a:solidFill>
-              </a:defRPr>
-            </a:pPr>
-            <a:r>
-              <a:t>Eliminating the $13 Trillion Post-Deadline Insider Tampering Window via Solana Anchor PDA State Machines &amp; OCDS 1.1 Canonical Hashing.</a:t>
             </a:r>
           </a:p>
         </p:txBody>
@@ -4106,8 +4094,8 @@
         </p:nvSpPr>
         <p:spPr>
           <a:xfrm>
-            <a:off x="1097280" y="5029200"/>
-            <a:ext cx="3200400" cy="1097280"/>
+            <a:off x="1097280" y="4846320"/>
+            <a:ext cx="3200400" cy="1280160"/>
           </a:xfrm>
           <a:prstGeom prst="roundRect">
             <a:avLst/>
@@ -4151,8 +4139,8 @@
         </p:nvSpPr>
         <p:spPr>
           <a:xfrm>
-            <a:off x="1280160" y="5074920"/>
-            <a:ext cx="2834640" cy="1005840"/>
+            <a:off x="1280160" y="4937760"/>
+            <a:ext cx="2834640" cy="1097280"/>
           </a:xfrm>
           <a:prstGeom prst="rect">
             <a:avLst/>
@@ -4166,7 +4154,7 @@
           <a:lstStyle/>
           <a:p>
             <a:pPr>
-              <a:defRPr sz="2000" b="1">
+              <a:defRPr sz="2600" b="1">
                 <a:solidFill>
                   <a:srgbClr val="06B6D4"/>
                 </a:solidFill>
@@ -4178,14 +4166,14 @@
           </a:p>
           <a:p>
             <a:pPr>
-              <a:defRPr sz="1100">
+              <a:defRPr sz="1300">
                 <a:solidFill>
                   <a:srgbClr val="94A3B8"/>
                 </a:solidFill>
               </a:defRPr>
             </a:pPr>
             <a:r>
-              <a:t>Protected Market (15-20% Global GDP)</a:t>
+              <a:t>Protected Market</a:t>
             </a:r>
           </a:p>
         </p:txBody>
@@ -4198,8 +4186,8 @@
         </p:nvSpPr>
         <p:spPr>
           <a:xfrm>
-            <a:off x="4526280" y="5029200"/>
-            <a:ext cx="3200400" cy="1097280"/>
+            <a:off x="4526280" y="4846320"/>
+            <a:ext cx="3200400" cy="1280160"/>
           </a:xfrm>
           <a:prstGeom prst="roundRect">
             <a:avLst/>
@@ -4243,8 +4231,8 @@
         </p:nvSpPr>
         <p:spPr>
           <a:xfrm>
-            <a:off x="4709160" y="5074920"/>
-            <a:ext cx="2834640" cy="1005840"/>
+            <a:off x="4709160" y="4937760"/>
+            <a:ext cx="2834640" cy="1097280"/>
           </a:xfrm>
           <a:prstGeom prst="rect">
             <a:avLst/>
@@ -4258,26 +4246,26 @@
           <a:lstStyle/>
           <a:p>
             <a:pPr>
-              <a:defRPr sz="2000" b="1">
+              <a:defRPr sz="2600" b="1">
                 <a:solidFill>
                   <a:srgbClr val="A855F7"/>
                 </a:solidFill>
               </a:defRPr>
             </a:pPr>
             <a:r>
-              <a:t>400ms Sub-Second</a:t>
-            </a:r>
-          </a:p>
-          <a:p>
-            <a:pPr>
-              <a:defRPr sz="1100">
+              <a:t>400ms Clock</a:t>
+            </a:r>
+          </a:p>
+          <a:p>
+            <a:pPr>
+              <a:defRPr sz="1300">
                 <a:solidFill>
                   <a:srgbClr val="94A3B8"/>
                 </a:solidFill>
               </a:defRPr>
             </a:pPr>
             <a:r>
-              <a:t>Solana Consensus Clock Boundary</a:t>
+              <a:t>Proof of History</a:t>
             </a:r>
           </a:p>
         </p:txBody>
@@ -4290,8 +4278,8 @@
         </p:nvSpPr>
         <p:spPr>
           <a:xfrm>
-            <a:off x="7955279" y="5029200"/>
-            <a:ext cx="3200400" cy="1097280"/>
+            <a:off x="7955279" y="4846320"/>
+            <a:ext cx="3200400" cy="1280160"/>
           </a:xfrm>
           <a:prstGeom prst="roundRect">
             <a:avLst/>
@@ -4335,8 +4323,8 @@
         </p:nvSpPr>
         <p:spPr>
           <a:xfrm>
-            <a:off x="8138159" y="5074920"/>
-            <a:ext cx="2834640" cy="1005840"/>
+            <a:off x="8138159" y="4937760"/>
+            <a:ext cx="2834640" cy="1097280"/>
           </a:xfrm>
           <a:prstGeom prst="rect">
             <a:avLst/>
@@ -4350,7 +4338,7 @@
           <a:lstStyle/>
           <a:p>
             <a:pPr>
-              <a:defRPr sz="2000" b="1">
+              <a:defRPr sz="2600" b="1">
                 <a:solidFill>
                   <a:srgbClr val="10B981"/>
                 </a:solidFill>
@@ -4362,14 +4350,14 @@
           </a:p>
           <a:p>
             <a:pPr>
-              <a:defRPr sz="1100">
+              <a:defRPr sz="1300">
                 <a:solidFill>
                   <a:srgbClr val="94A3B8"/>
                 </a:solidFill>
               </a:defRPr>
             </a:pPr>
             <a:r>
-              <a:t>Sponsored Relayer for Enterprise Contractors</a:t>
+              <a:t>Enterprise Sponsored</a:t>
             </a:r>
           </a:p>
         </p:txBody>
@@ -4446,7 +4434,7 @@
         <p:spPr>
           <a:xfrm>
             <a:off x="914400" y="548640"/>
-            <a:ext cx="10332720" cy="822960"/>
+            <a:ext cx="10332720" cy="1005840"/>
           </a:xfrm>
           <a:prstGeom prst="rect">
             <a:avLst/>
@@ -4460,26 +4448,26 @@
           <a:lstStyle/>
           <a:p>
             <a:pPr>
-              <a:defRPr sz="1200" b="1">
+              <a:defRPr sz="1300" b="1">
                 <a:solidFill>
                   <a:srgbClr val="F43F5E"/>
                 </a:solidFill>
               </a:defRPr>
             </a:pPr>
             <a:r>
-              <a:t>THE $13 TRILLION CRITICAL FAILURE POINT</a:t>
-            </a:r>
-          </a:p>
-          <a:p>
-            <a:pPr>
-              <a:defRPr sz="3200" b="1">
+              <a:t>THE $13 TRILLION VULNERABILITY</a:t>
+            </a:r>
+          </a:p>
+          <a:p>
+            <a:pPr>
+              <a:defRPr sz="3400" b="1">
                 <a:solidFill>
                   <a:srgbClr val="FFFFFF"/>
                 </a:solidFill>
               </a:defRPr>
             </a:pPr>
             <a:r>
-              <a:t>The Post-Deadline Insider Exploitation Window</a:t>
+              <a:t>The Post-Deadline Insider Tampering Window</a:t>
             </a:r>
           </a:p>
         </p:txBody>
@@ -4492,7 +4480,7 @@
         </p:nvSpPr>
         <p:spPr>
           <a:xfrm>
-            <a:off x="914400" y="1645920"/>
+            <a:off x="914400" y="1737360"/>
             <a:ext cx="4937760" cy="4389120"/>
           </a:xfrm>
           <a:prstGeom prst="roundRect">
@@ -4503,7 +4491,7 @@
           </a:solidFill>
           <a:ln w="19050">
             <a:solidFill>
-              <a:srgbClr val="1E2946"/>
+              <a:srgbClr val="501423"/>
             </a:solidFill>
           </a:ln>
         </p:spPr>
@@ -4537,7 +4525,7 @@
         </p:nvSpPr>
         <p:spPr>
           <a:xfrm>
-            <a:off x="1188720" y="1828800"/>
+            <a:off x="1188720" y="1920240"/>
             <a:ext cx="4389120" cy="4023360"/>
           </a:xfrm>
           <a:prstGeom prst="rect">
@@ -4552,110 +4540,62 @@
           <a:lstStyle/>
           <a:p>
             <a:pPr>
-              <a:defRPr sz="1800" b="1">
+              <a:defRPr sz="2000" b="1">
                 <a:solidFill>
                   <a:srgbClr val="F43F5E"/>
                 </a:solidFill>
               </a:defRPr>
             </a:pPr>
             <a:r>
-              <a:t>Centralized Web2 Portals (SAP, Oracle, e-GP)</a:t>
-            </a:r>
-          </a:p>
-          <a:p>
-            <a:pPr>
-              <a:defRPr b="1" sz="1300">
+              <a:t>✖  Centralized E-Procurement</a:t>
+            </a:r>
+          </a:p>
+          <a:p>
+            <a:pPr>
+              <a:defRPr sz="1400">
                 <a:solidFill>
                   <a:srgbClr val="FFFFFF"/>
                 </a:solidFill>
               </a:defRPr>
             </a:pPr>
             <a:r>
-              <a:t>✖  The Insider Peek Window:</a:t>
-            </a:r>
-          </a:p>
-          <a:p>
-            <a:pPr>
-              <a:defRPr sz="1100">
-                <a:solidFill>
-                  <a:srgbClr val="94A3B8"/>
-                </a:solidFill>
-              </a:defRPr>
-            </a:pPr>
-            <a:r>
-              <a:t>    Between submission closing and bid opening, centralized database administrators have total root access to view unencrypted competitor pricing.</a:t>
-            </a:r>
-          </a:p>
-          <a:p>
-            <a:pPr>
-              <a:defRPr b="1" sz="1300">
+              <a:t>• Root Admin God-Mode (Unencrypted bid peek)</a:t>
+            </a:r>
+          </a:p>
+          <a:p>
+            <a:pPr>
+              <a:defRPr sz="1400">
                 <a:solidFill>
                   <a:srgbClr val="FFFFFF"/>
                 </a:solidFill>
               </a:defRPr>
             </a:pPr>
             <a:r>
-              <a:t>✖  Retroactive Backdating:</a:t>
-            </a:r>
-          </a:p>
-          <a:p>
-            <a:pPr>
-              <a:defRPr sz="1100">
-                <a:solidFill>
-                  <a:srgbClr val="94A3B8"/>
-                </a:solidFill>
-              </a:defRPr>
-            </a:pPr>
-            <a:r>
-              <a:t>    Corrupt officials insert favored contractors 5 minutes after the deadline by backdating server database timestamps.</a:t>
-            </a:r>
-          </a:p>
-          <a:p>
-            <a:pPr>
-              <a:defRPr b="1" sz="1300">
+              <a:t>• Retroactive Backdating (MySQL timestamp rewrites)</a:t>
+            </a:r>
+          </a:p>
+          <a:p>
+            <a:pPr>
+              <a:defRPr sz="1400">
                 <a:solidFill>
                   <a:srgbClr val="FFFFFF"/>
                 </a:solidFill>
               </a:defRPr>
             </a:pPr>
             <a:r>
-              <a:t>✖  Subjective Grade Alterations:</a:t>
-            </a:r>
-          </a:p>
-          <a:p>
-            <a:pPr>
-              <a:defRPr sz="1100">
-                <a:solidFill>
-                  <a:srgbClr val="94A3B8"/>
-                </a:solidFill>
-              </a:defRPr>
-            </a:pPr>
-            <a:r>
-              <a:t>    Evaluators quietly rewrite technical proposal scores behind closed doors to favor political cronies.</a:t>
-            </a:r>
-          </a:p>
-          <a:p>
-            <a:pPr>
-              <a:defRPr b="1" sz="1300">
+              <a:t>• Score Collusion (Quiet score inflation behind closed doors)</a:t>
+            </a:r>
+          </a:p>
+          <a:p>
+            <a:pPr>
+              <a:defRPr sz="1400">
                 <a:solidFill>
                   <a:srgbClr val="FFFFFF"/>
                 </a:solidFill>
               </a:defRPr>
             </a:pPr>
             <a:r>
-              <a:t>✖  The 'God-Mode' Excuse:</a:t>
-            </a:r>
-          </a:p>
-          <a:p>
-            <a:pPr>
-              <a:defRPr sz="1100">
-                <a:solidFill>
-                  <a:srgbClr val="94A3B8"/>
-                </a:solidFill>
-              </a:defRPr>
-            </a:pPr>
-            <a:r>
-              <a:t>    When challenged, agencies point to their server logs: 'That is what our database recorded.' There is zero cryptographic proof.</a:t>
+              <a:t>• Zero Mathematical Proof ('That is what our database recorded')</a:t>
             </a:r>
           </a:p>
         </p:txBody>
@@ -4668,7 +4608,7 @@
         </p:nvSpPr>
         <p:spPr>
           <a:xfrm>
-            <a:off x="6217920" y="1645920"/>
+            <a:off x="6217920" y="1737360"/>
             <a:ext cx="5029200" cy="4389120"/>
           </a:xfrm>
           <a:prstGeom prst="roundRect">
@@ -4713,7 +4653,7 @@
         </p:nvSpPr>
         <p:spPr>
           <a:xfrm>
-            <a:off x="6492240" y="1828800"/>
+            <a:off x="6492240" y="1920240"/>
             <a:ext cx="4480560" cy="4023360"/>
           </a:xfrm>
           <a:prstGeom prst="rect">
@@ -4728,110 +4668,62 @@
           <a:lstStyle/>
           <a:p>
             <a:pPr>
-              <a:defRPr sz="1800" b="1">
+              <a:defRPr sz="2000" b="1">
                 <a:solidFill>
                   <a:srgbClr val="06B6D4"/>
                 </a:solidFill>
               </a:defRPr>
             </a:pPr>
             <a:r>
-              <a:t>The Cryptographic Reality Check</a:t>
-            </a:r>
-          </a:p>
-          <a:p>
-            <a:pPr>
-              <a:defRPr b="1" sz="1300">
+              <a:t>✔  BidTrace on Solana Anchor</a:t>
+            </a:r>
+          </a:p>
+          <a:p>
+            <a:pPr>
+              <a:defRPr sz="1400">
                 <a:solidFill>
                   <a:srgbClr val="06B6D4"/>
                 </a:solidFill>
               </a:defRPr>
             </a:pPr>
             <a:r>
-              <a:t>✔  Immutable Clock Boundary:</a:t>
-            </a:r>
-          </a:p>
-          <a:p>
-            <a:pPr>
-              <a:defRPr sz="1100">
-                <a:solidFill>
-                  <a:srgbClr val="94A3B8"/>
-                </a:solidFill>
-              </a:defRPr>
-            </a:pPr>
-            <a:r>
-              <a:t>    Solana Anchor PDA verifies Clock::get()?.slot &lt;= deadline_slot. Once slot 1050 passes, zero administrative keys can inject a bid.</a:t>
-            </a:r>
-          </a:p>
-          <a:p>
-            <a:pPr>
-              <a:defRPr b="1" sz="1300">
+              <a:t>• Consensus Clock Boundary (Slot &gt; deadline = REJECTED)</a:t>
+            </a:r>
+          </a:p>
+          <a:p>
+            <a:pPr>
+              <a:defRPr sz="1400">
                 <a:solidFill>
                   <a:srgbClr val="06B6D4"/>
                 </a:solidFill>
               </a:defRPr>
             </a:pPr>
             <a:r>
-              <a:t>✔  Blind Dual Commitments:</a:t>
-            </a:r>
-          </a:p>
-          <a:p>
-            <a:pPr>
-              <a:defRPr sz="1100">
-                <a:solidFill>
-                  <a:srgbClr val="94A3B8"/>
-                </a:solidFill>
-              </a:defRPr>
-            </a:pPr>
-            <a:r>
-              <a:t>    Envelope A (Technical) &amp; Envelope B (Financial) are hashed with preimages. Pricing remains strictly sealed until evaluation is finalized.</a:t>
-            </a:r>
-          </a:p>
-          <a:p>
-            <a:pPr>
-              <a:defRPr b="1" sz="1300">
+              <a:t>• Dual-Envelope Sealing (Zero pre-deadline price leakage)</a:t>
+            </a:r>
+          </a:p>
+          <a:p>
+            <a:pPr>
+              <a:defRPr sz="1400">
                 <a:solidFill>
                   <a:srgbClr val="06B6D4"/>
                 </a:solidFill>
               </a:defRPr>
             </a:pPr>
             <a:r>
-              <a:t>✔  Olympic Trimmed Mean:</a:t>
-            </a:r>
-          </a:p>
-          <a:p>
-            <a:pPr>
-              <a:defRPr sz="1100">
-                <a:solidFill>
-                  <a:srgbClr val="94A3B8"/>
-                </a:solidFill>
-              </a:defRPr>
-            </a:pPr>
-            <a:r>
-              <a:t>    On-chain algorithm discards extreme high/low evaluator grades and automatically flags rogue collusion on-chain.</a:t>
-            </a:r>
-          </a:p>
-          <a:p>
-            <a:pPr>
-              <a:defRPr b="1" sz="1300">
+              <a:t>• Olympic Trimmed Mean (On-chain rogue score auto-pruning)</a:t>
+            </a:r>
+          </a:p>
+          <a:p>
+            <a:pPr>
+              <a:defRPr sz="1400">
                 <a:solidFill>
                   <a:srgbClr val="06B6D4"/>
                 </a:solidFill>
               </a:defRPr>
             </a:pPr>
             <a:r>
-              <a:t>✔  Air-Gapped Tribunal Verifier:</a:t>
-            </a:r>
-          </a:p>
-          <a:p>
-            <a:pPr>
-              <a:defRPr sz="1100">
-                <a:solidFill>
-                  <a:srgbClr val="94A3B8"/>
-                </a:solidFill>
-              </a:defRPr>
-            </a:pPr>
-            <a:r>
-              <a:t>    Anyone can audit the entire procurement lifecycle offline directly against raw Solana account proofs.</a:t>
+              <a:t>• Air-Gapped Tribunal Verifier (100% offline mathematical proof)</a:t>
             </a:r>
           </a:p>
         </p:txBody>
@@ -4908,7 +4800,7 @@
         <p:spPr>
           <a:xfrm>
             <a:off x="914400" y="548640"/>
-            <a:ext cx="10332720" cy="822960"/>
+            <a:ext cx="10332720" cy="1005840"/>
           </a:xfrm>
           <a:prstGeom prst="rect">
             <a:avLst/>
@@ -4922,7 +4814,7 @@
           <a:lstStyle/>
           <a:p>
             <a:pPr>
-              <a:defRPr sz="1200" b="1">
+              <a:defRPr sz="1300" b="1">
                 <a:solidFill>
                   <a:srgbClr val="06B6D4"/>
                 </a:solidFill>
@@ -4934,14 +4826,14 @@
           </a:p>
           <a:p>
             <a:pPr>
-              <a:defRPr sz="3200" b="1">
+              <a:defRPr sz="3400" b="1">
                 <a:solidFill>
                   <a:srgbClr val="FFFFFF"/>
                 </a:solidFill>
               </a:defRPr>
             </a:pPr>
             <a:r>
-              <a:t>The Incorruptible Two-Plane State Machine</a:t>
+              <a:t>Two-Plane Decoupled Architecture</a:t>
             </a:r>
           </a:p>
         </p:txBody>
@@ -4954,8 +4846,8 @@
         </p:nvSpPr>
         <p:spPr>
           <a:xfrm>
-            <a:off x="914400" y="1645920"/>
-            <a:ext cx="3291840" cy="4572000"/>
+            <a:off x="914400" y="1737360"/>
+            <a:ext cx="3291840" cy="4389120"/>
           </a:xfrm>
           <a:prstGeom prst="roundRect">
             <a:avLst/>
@@ -4999,8 +4891,8 @@
         </p:nvSpPr>
         <p:spPr>
           <a:xfrm>
-            <a:off x="1097280" y="1828800"/>
-            <a:ext cx="2926080" cy="4206240"/>
+            <a:off x="1097280" y="1920240"/>
+            <a:ext cx="2926080" cy="4023360"/>
           </a:xfrm>
           <a:prstGeom prst="rect">
             <a:avLst/>
@@ -5014,7 +4906,7 @@
           <a:lstStyle/>
           <a:p>
             <a:pPr>
-              <a:defRPr sz="1400" b="1">
+              <a:defRPr sz="1600" b="1">
                 <a:solidFill>
                   <a:srgbClr val="06B6D4"/>
                 </a:solidFill>
@@ -5026,87 +4918,63 @@
           </a:p>
           <a:p>
             <a:pPr>
-              <a:defRPr sz="1100">
+              <a:defRPr sz="1200">
                 <a:solidFill>
                   <a:srgbClr val="94A3B8"/>
                 </a:solidFill>
               </a:defRPr>
             </a:pPr>
             <a:r>
-              <a:t>Off-Chain Open Contracting</a:t>
+              <a:t>Off-Chain Standard</a:t>
             </a:r>
           </a:p>
           <a:p/>
           <a:p>
             <a:pPr>
-              <a:defRPr sz="1200" b="1">
+              <a:defRPr sz="1300">
                 <a:solidFill>
                   <a:srgbClr val="FFFFFF"/>
                 </a:solidFill>
               </a:defRPr>
             </a:pPr>
             <a:r>
-              <a:t>▪ OCDS 1.1 Compliant:</a:t>
-            </a:r>
-          </a:p>
-          <a:p>
-            <a:pPr>
-              <a:defRPr sz="1000">
-                <a:solidFill>
-                  <a:srgbClr val="94A3B8"/>
-                </a:solidFill>
-              </a:defRPr>
-            </a:pPr>
-            <a:r>
-              <a:t>  Canonical tender JSON data standard adopted by the World Bank and UN.</a:t>
-            </a:r>
-          </a:p>
-          <a:p>
-            <a:pPr>
-              <a:defRPr sz="1200" b="1">
+              <a:t>▪ OCDS 1.1 Compliance (World Bank / UN Standard)</a:t>
+            </a:r>
+          </a:p>
+          <a:p>
+            <a:pPr>
+              <a:defRPr sz="1300">
                 <a:solidFill>
                   <a:srgbClr val="FFFFFF"/>
                 </a:solidFill>
               </a:defRPr>
             </a:pPr>
             <a:r>
-              <a:t>▪ RFC 8785 JCS Hashing:</a:t>
-            </a:r>
-          </a:p>
-          <a:p>
-            <a:pPr>
-              <a:defRPr sz="1000">
-                <a:solidFill>
-                  <a:srgbClr val="94A3B8"/>
-                </a:solidFill>
-              </a:defRPr>
-            </a:pPr>
-            <a:r>
-              <a:t>  Deterministic JSON Canonicalization Scheme produces identical cross-language SHA-256 anchors.</a:t>
-            </a:r>
-          </a:p>
-          <a:p>
-            <a:pPr>
-              <a:defRPr sz="1200" b="1">
+              <a:t>▪ RFC 8785 (JCS) Deterministic Hashing</a:t>
+            </a:r>
+          </a:p>
+          <a:p>
+            <a:pPr>
+              <a:defRPr sz="1300">
                 <a:solidFill>
                   <a:srgbClr val="FFFFFF"/>
                 </a:solidFill>
               </a:defRPr>
             </a:pPr>
             <a:r>
-              <a:t>▪ TradFi Interoperability:</a:t>
-            </a:r>
-          </a:p>
-          <a:p>
-            <a:pPr>
-              <a:defRPr sz="1000">
-                <a:solidFill>
-                  <a:srgbClr val="94A3B8"/>
-                </a:solidFill>
-              </a:defRPr>
-            </a:pPr>
-            <a:r>
-              <a:t>  Existing government ERPs (SAP, Oracle) export standard OCDS notices directly.</a:t>
+              <a:t>▪ 100% Cross-Language Hash Parity</a:t>
+            </a:r>
+          </a:p>
+          <a:p>
+            <a:pPr>
+              <a:defRPr sz="1300">
+                <a:solidFill>
+                  <a:srgbClr val="FFFFFF"/>
+                </a:solidFill>
+              </a:defRPr>
+            </a:pPr>
+            <a:r>
+              <a:t>▪ Direct ERP Ingestion (SAP &amp; Oracle)</a:t>
             </a:r>
           </a:p>
         </p:txBody>
@@ -5119,8 +4987,8 @@
         </p:nvSpPr>
         <p:spPr>
           <a:xfrm>
-            <a:off x="4434840" y="1645920"/>
-            <a:ext cx="3291840" cy="4572000"/>
+            <a:off x="4434840" y="1737360"/>
+            <a:ext cx="3291840" cy="4389120"/>
           </a:xfrm>
           <a:prstGeom prst="roundRect">
             <a:avLst/>
@@ -5164,8 +5032,8 @@
         </p:nvSpPr>
         <p:spPr>
           <a:xfrm>
-            <a:off x="4617720" y="1828800"/>
-            <a:ext cx="2926080" cy="4206240"/>
+            <a:off x="4617720" y="1920240"/>
+            <a:ext cx="2926080" cy="4023360"/>
           </a:xfrm>
           <a:prstGeom prst="rect">
             <a:avLst/>
@@ -5179,7 +5047,7 @@
           <a:lstStyle/>
           <a:p>
             <a:pPr>
-              <a:defRPr sz="1400" b="1">
+              <a:defRPr sz="1600" b="1">
                 <a:solidFill>
                   <a:srgbClr val="A855F7"/>
                 </a:solidFill>
@@ -5191,87 +5059,63 @@
           </a:p>
           <a:p>
             <a:pPr>
-              <a:defRPr sz="1100">
+              <a:defRPr sz="1200">
                 <a:solidFill>
                   <a:srgbClr val="94A3B8"/>
                 </a:solidFill>
               </a:defRPr>
             </a:pPr>
             <a:r>
-              <a:t>On-Chain Solana Anchor Engine</a:t>
+              <a:t>Solana Anchor Engine</a:t>
             </a:r>
           </a:p>
           <a:p/>
           <a:p>
             <a:pPr>
-              <a:defRPr sz="1200" b="1">
+              <a:defRPr sz="1300">
                 <a:solidFill>
                   <a:srgbClr val="FFFFFF"/>
                 </a:solidFill>
               </a:defRPr>
             </a:pPr>
             <a:r>
-              <a:t>▪ PDA State Machine:</a:t>
-            </a:r>
-          </a:p>
-          <a:p>
-            <a:pPr>
-              <a:defRPr sz="1000">
-                <a:solidFill>
-                  <a:srgbClr val="94A3B8"/>
-                </a:solidFill>
-              </a:defRPr>
-            </a:pPr>
-            <a:r>
-              <a:t>  10 Rust instructions strictly gate phase transitions (Bidding -&gt; Technical -&gt; Financial -&gt; Award).</a:t>
-            </a:r>
-          </a:p>
-          <a:p>
-            <a:pPr>
-              <a:defRPr sz="1200" b="1">
+              <a:t>▪ 10 Anchor Rust Instructions Deployed</a:t>
+            </a:r>
+          </a:p>
+          <a:p>
+            <a:pPr>
+              <a:defRPr sz="1300">
                 <a:solidFill>
                   <a:srgbClr val="FFFFFF"/>
                 </a:solidFill>
               </a:defRPr>
             </a:pPr>
             <a:r>
-              <a:t>▪ Temporal Slot Hardening:</a:t>
-            </a:r>
-          </a:p>
-          <a:p>
-            <a:pPr>
-              <a:defRPr sz="1000">
-                <a:solidFill>
-                  <a:srgbClr val="94A3B8"/>
-                </a:solidFill>
-              </a:defRPr>
-            </a:pPr>
-            <a:r>
-              <a:t>  Slot boundaries are validated directly against Solana's Proof of History clock.</a:t>
-            </a:r>
-          </a:p>
-          <a:p>
-            <a:pPr>
-              <a:defRPr sz="1200" b="1">
+              <a:t>▪ Temporal Slot Clock Hardening</a:t>
+            </a:r>
+          </a:p>
+          <a:p>
+            <a:pPr>
+              <a:defRPr sz="1300">
                 <a:solidFill>
                   <a:srgbClr val="FFFFFF"/>
                 </a:solidFill>
               </a:defRPr>
             </a:pPr>
             <a:r>
-              <a:t>▪ Commercial Secrecy Lock:</a:t>
-            </a:r>
-          </a:p>
-          <a:p>
-            <a:pPr>
-              <a:defRPr sz="1000">
-                <a:solidFill>
-                  <a:srgbClr val="94A3B8"/>
-                </a:solidFill>
-              </a:defRPr>
-            </a:pPr>
-            <a:r>
-              <a:t>  Disqualified bidders (score &lt; 75%) are permanently prevented on-chain from unsealing financial prices.</a:t>
+              <a:t>▪ Dual-Envelope PDA State Machine</a:t>
+            </a:r>
+          </a:p>
+          <a:p>
+            <a:pPr>
+              <a:defRPr sz="1300">
+                <a:solidFill>
+                  <a:srgbClr val="FFFFFF"/>
+                </a:solidFill>
+              </a:defRPr>
+            </a:pPr>
+            <a:r>
+              <a:t>▪ Commercial Secrecy Invariant (Locked Forever)</a:t>
             </a:r>
           </a:p>
         </p:txBody>
@@ -5284,8 +5128,8 @@
         </p:nvSpPr>
         <p:spPr>
           <a:xfrm>
-            <a:off x="7955279" y="1645920"/>
-            <a:ext cx="3291840" cy="4572000"/>
+            <a:off x="7955279" y="1737360"/>
+            <a:ext cx="3291840" cy="4389120"/>
           </a:xfrm>
           <a:prstGeom prst="roundRect">
             <a:avLst/>
@@ -5329,8 +5173,8 @@
         </p:nvSpPr>
         <p:spPr>
           <a:xfrm>
-            <a:off x="8138159" y="1828800"/>
-            <a:ext cx="2926080" cy="4206240"/>
+            <a:off x="8138159" y="1920240"/>
+            <a:ext cx="2926080" cy="4023360"/>
           </a:xfrm>
           <a:prstGeom prst="rect">
             <a:avLst/>
@@ -5344,7 +5188,7 @@
           <a:lstStyle/>
           <a:p>
             <a:pPr>
-              <a:defRPr sz="1400" b="1">
+              <a:defRPr sz="1600" b="1">
                 <a:solidFill>
                   <a:srgbClr val="10B981"/>
                 </a:solidFill>
@@ -5356,87 +5200,63 @@
           </a:p>
           <a:p>
             <a:pPr>
-              <a:defRPr sz="1100">
+              <a:defRPr sz="1200">
                 <a:solidFill>
                   <a:srgbClr val="94A3B8"/>
                 </a:solidFill>
               </a:defRPr>
             </a:pPr>
             <a:r>
-              <a:t>Zero-Fiat-Gas Enterprise Relayer</a:t>
+              <a:t>Zero-Fiat-Gas Relayer</a:t>
             </a:r>
           </a:p>
           <a:p/>
           <a:p>
             <a:pPr>
-              <a:defRPr sz="1200" b="1">
+              <a:defRPr sz="1300">
                 <a:solidFill>
                   <a:srgbClr val="FFFFFF"/>
                 </a:solidFill>
               </a:defRPr>
             </a:pPr>
             <a:r>
-              <a:t>▪ Gas Decoupling:</a:t>
-            </a:r>
-          </a:p>
-          <a:p>
-            <a:pPr>
-              <a:defRPr sz="1000">
-                <a:solidFill>
-                  <a:srgbClr val="94A3B8"/>
-                </a:solidFill>
-              </a:defRPr>
-            </a:pPr>
-            <a:r>
-              <a:t>  Government agencies and contractors pay zero SOL. All network fees are sponsored by the backend relayer.</a:t>
-            </a:r>
-          </a:p>
-          <a:p>
-            <a:pPr>
-              <a:defRPr sz="1200" b="1">
+              <a:t>▪ Zero Crypto Gas for Contractors</a:t>
+            </a:r>
+          </a:p>
+          <a:p>
+            <a:pPr>
+              <a:defRPr sz="1300">
                 <a:solidFill>
                   <a:srgbClr val="FFFFFF"/>
                 </a:solidFill>
               </a:defRPr>
             </a:pPr>
             <a:r>
-              <a:t>▪ Hybrid Bond Registry:</a:t>
-            </a:r>
-          </a:p>
-          <a:p>
-            <a:pPr>
-              <a:defRPr sz="1000">
-                <a:solidFill>
-                  <a:srgbClr val="94A3B8"/>
-                </a:solidFill>
-              </a:defRPr>
-            </a:pPr>
-            <a:r>
-              <a:t>  Supports native Solana Escrow, TradFi Surety policies, SWIFT MT760 guarantees, and World Bank BSDs.</a:t>
-            </a:r>
-          </a:p>
-          <a:p>
-            <a:pPr>
-              <a:defRPr sz="1200" b="1">
+              <a:t>▪ 4 Hybrid Bond Registry Modes</a:t>
+            </a:r>
+          </a:p>
+          <a:p>
+            <a:pPr>
+              <a:defRPr sz="1300">
                 <a:solidFill>
                   <a:srgbClr val="FFFFFF"/>
                 </a:solidFill>
               </a:defRPr>
             </a:pPr>
             <a:r>
-              <a:t>▪ Offline Auditability:</a:t>
-            </a:r>
-          </a:p>
-          <a:p>
-            <a:pPr>
-              <a:defRPr sz="1000">
-                <a:solidFill>
-                  <a:srgbClr val="94A3B8"/>
-                </a:solidFill>
-              </a:defRPr>
-            </a:pPr>
-            <a:r>
-              <a:t>  Standalone Python &amp; Node.js verifier checks cryptographic proofs air-gapped.</a:t>
+              <a:t>▪ SWIFT MT760 &amp; TradFi Surety Integration</a:t>
+            </a:r>
+          </a:p>
+          <a:p>
+            <a:pPr>
+              <a:defRPr sz="1300">
+                <a:solidFill>
+                  <a:srgbClr val="FFFFFF"/>
+                </a:solidFill>
+              </a:defRPr>
+            </a:pPr>
+            <a:r>
+              <a:t>▪ Air-Gapped Tribunal Dossier Verifier</a:t>
             </a:r>
           </a:p>
         </p:txBody>
@@ -5513,7 +5333,7 @@
         <p:spPr>
           <a:xfrm>
             <a:off x="914400" y="548640"/>
-            <a:ext cx="10332720" cy="822960"/>
+            <a:ext cx="10332720" cy="1005840"/>
           </a:xfrm>
           <a:prstGeom prst="rect">
             <a:avLst/>
@@ -5527,26 +5347,26 @@
           <a:lstStyle/>
           <a:p>
             <a:pPr>
-              <a:defRPr sz="1200" b="1">
+              <a:defRPr sz="1300" b="1">
                 <a:solidFill>
                   <a:srgbClr val="10B981"/>
                 </a:solidFill>
               </a:defRPr>
             </a:pPr>
             <a:r>
-              <a:t>HOW IT WORKS IN PRACTICE</a:t>
-            </a:r>
-          </a:p>
-          <a:p>
-            <a:pPr>
-              <a:defRPr sz="3200" b="1">
+              <a:t>END-TO-END CRYPTOGRAPHIC PIPELINE</a:t>
+            </a:r>
+          </a:p>
+          <a:p>
+            <a:pPr>
+              <a:defRPr sz="3400" b="1">
                 <a:solidFill>
                   <a:srgbClr val="FFFFFF"/>
                 </a:solidFill>
               </a:defRPr>
             </a:pPr>
             <a:r>
-              <a:t>The 4-Stage Incorruptible Lifecycle &amp; Adversarial Defense</a:t>
+              <a:t>The 4-Stage Lifecycle &amp; Tested Adversarial Defenses</a:t>
             </a:r>
           </a:p>
         </p:txBody>
@@ -5559,8 +5379,8 @@
         </p:nvSpPr>
         <p:spPr>
           <a:xfrm>
-            <a:off x="914400" y="1645920"/>
-            <a:ext cx="2468880" cy="2103120"/>
+            <a:off x="914400" y="1737360"/>
+            <a:ext cx="2468880" cy="1828800"/>
           </a:xfrm>
           <a:prstGeom prst="roundRect">
             <a:avLst/>
@@ -5604,8 +5424,8 @@
         </p:nvSpPr>
         <p:spPr>
           <a:xfrm>
-            <a:off x="1051560" y="1737360"/>
-            <a:ext cx="2194560" cy="1920240"/>
+            <a:off x="1051560" y="1828800"/>
+            <a:ext cx="2194560" cy="1645920"/>
           </a:xfrm>
           <a:prstGeom prst="rect">
             <a:avLst/>
@@ -5619,7 +5439,7 @@
           <a:lstStyle/>
           <a:p>
             <a:pPr>
-              <a:defRPr sz="1000" b="1">
+              <a:defRPr sz="1100" b="1">
                 <a:solidFill>
                   <a:srgbClr val="06B6D4"/>
                 </a:solidFill>
@@ -5631,26 +5451,26 @@
           </a:p>
           <a:p>
             <a:pPr>
-              <a:defRPr sz="1300" b="1">
+              <a:defRPr sz="1600" b="1">
                 <a:solidFill>
                   <a:srgbClr val="FFFFFF"/>
                 </a:solidFill>
               </a:defRPr>
             </a:pPr>
             <a:r>
-              <a:t>Tender Publication</a:t>
-            </a:r>
-          </a:p>
-          <a:p>
-            <a:pPr>
-              <a:defRPr sz="1000">
+              <a:t>Tender Issued</a:t>
+            </a:r>
+          </a:p>
+          <a:p>
+            <a:pPr>
+              <a:defRPr sz="1100">
                 <a:solidFill>
                   <a:srgbClr val="94A3B8"/>
                 </a:solidFill>
               </a:defRPr>
             </a:pPr>
             <a:r>
-              <a:t>Authority issues RFP with canonical OCDS hash and fixed deadline slot.</a:t>
+              <a:t>Canonical OCDS Notice + Slot Cutoff</a:t>
             </a:r>
           </a:p>
         </p:txBody>
@@ -5663,8 +5483,8 @@
         </p:nvSpPr>
         <p:spPr>
           <a:xfrm>
-            <a:off x="3547872" y="1645920"/>
-            <a:ext cx="2468880" cy="2103120"/>
+            <a:off x="3547872" y="1737360"/>
+            <a:ext cx="2468880" cy="1828800"/>
           </a:xfrm>
           <a:prstGeom prst="roundRect">
             <a:avLst/>
@@ -5708,8 +5528,8 @@
         </p:nvSpPr>
         <p:spPr>
           <a:xfrm>
-            <a:off x="3685032" y="1737360"/>
-            <a:ext cx="2194560" cy="1920240"/>
+            <a:off x="3685032" y="1828800"/>
+            <a:ext cx="2194560" cy="1645920"/>
           </a:xfrm>
           <a:prstGeom prst="rect">
             <a:avLst/>
@@ -5723,7 +5543,7 @@
           <a:lstStyle/>
           <a:p>
             <a:pPr>
-              <a:defRPr sz="1000" b="1">
+              <a:defRPr sz="1100" b="1">
                 <a:solidFill>
                   <a:srgbClr val="A855F7"/>
                 </a:solidFill>
@@ -5735,26 +5555,26 @@
           </a:p>
           <a:p>
             <a:pPr>
-              <a:defRPr sz="1300" b="1">
+              <a:defRPr sz="1600" b="1">
                 <a:solidFill>
                   <a:srgbClr val="FFFFFF"/>
                 </a:solidFill>
               </a:defRPr>
             </a:pPr>
             <a:r>
-              <a:t>Dual Sealed Commit</a:t>
-            </a:r>
-          </a:p>
-          <a:p>
-            <a:pPr>
-              <a:defRPr sz="1000">
+              <a:t>Dual-Envelopes</a:t>
+            </a:r>
+          </a:p>
+          <a:p>
+            <a:pPr>
+              <a:defRPr sz="1100">
                 <a:solidFill>
                   <a:srgbClr val="94A3B8"/>
                 </a:solidFill>
               </a:defRPr>
             </a:pPr>
             <a:r>
-              <a:t>Bidders commit Envelope A (specs) and Envelope B (pricing) independently.</a:t>
+              <a:t>Blinded Technical &amp; Financial Bids</a:t>
             </a:r>
           </a:p>
         </p:txBody>
@@ -5767,8 +5587,8 @@
         </p:nvSpPr>
         <p:spPr>
           <a:xfrm>
-            <a:off x="6181344" y="1645920"/>
-            <a:ext cx="2468880" cy="2103120"/>
+            <a:off x="6181344" y="1737360"/>
+            <a:ext cx="2468880" cy="1828800"/>
           </a:xfrm>
           <a:prstGeom prst="roundRect">
             <a:avLst/>
@@ -5812,8 +5632,8 @@
         </p:nvSpPr>
         <p:spPr>
           <a:xfrm>
-            <a:off x="6318504" y="1737360"/>
-            <a:ext cx="2194560" cy="1920240"/>
+            <a:off x="6318504" y="1828800"/>
+            <a:ext cx="2194560" cy="1645920"/>
           </a:xfrm>
           <a:prstGeom prst="rect">
             <a:avLst/>
@@ -5827,7 +5647,7 @@
           <a:lstStyle/>
           <a:p>
             <a:pPr>
-              <a:defRPr sz="1000" b="1">
+              <a:defRPr sz="1100" b="1">
                 <a:solidFill>
                   <a:srgbClr val="F59E0B"/>
                 </a:solidFill>
@@ -5839,7 +5659,7 @@
           </a:p>
           <a:p>
             <a:pPr>
-              <a:defRPr sz="1300" b="1">
+              <a:defRPr sz="1600" b="1">
                 <a:solidFill>
                   <a:srgbClr val="FFFFFF"/>
                 </a:solidFill>
@@ -5851,14 +5671,14 @@
           </a:p>
           <a:p>
             <a:pPr>
-              <a:defRPr sz="1000">
+              <a:defRPr sz="1100">
                 <a:solidFill>
                   <a:srgbClr val="94A3B8"/>
                 </a:solidFill>
               </a:defRPr>
             </a:pPr>
             <a:r>
-              <a:t>5 evaluators grade proposals; Olympic Trimmed Mean prunes rogue outliers.</a:t>
+              <a:t>Olympic Trimmed Mean Outlier Pruning</a:t>
             </a:r>
           </a:p>
         </p:txBody>
@@ -5871,8 +5691,8 @@
         </p:nvSpPr>
         <p:spPr>
           <a:xfrm>
-            <a:off x="8814816" y="1645920"/>
-            <a:ext cx="2468880" cy="2103120"/>
+            <a:off x="8814816" y="1737360"/>
+            <a:ext cx="2468880" cy="1828800"/>
           </a:xfrm>
           <a:prstGeom prst="roundRect">
             <a:avLst/>
@@ -5916,8 +5736,8 @@
         </p:nvSpPr>
         <p:spPr>
           <a:xfrm>
-            <a:off x="8951976" y="1737360"/>
-            <a:ext cx="2194560" cy="1920240"/>
+            <a:off x="8951976" y="1828800"/>
+            <a:ext cx="2194560" cy="1645920"/>
           </a:xfrm>
           <a:prstGeom prst="rect">
             <a:avLst/>
@@ -5931,7 +5751,7 @@
           <a:lstStyle/>
           <a:p>
             <a:pPr>
-              <a:defRPr sz="1000" b="1">
+              <a:defRPr sz="1100" b="1">
                 <a:solidFill>
                   <a:srgbClr val="10B981"/>
                 </a:solidFill>
@@ -5943,26 +5763,26 @@
           </a:p>
           <a:p>
             <a:pPr>
-              <a:defRPr sz="1300" b="1">
+              <a:defRPr sz="1600" b="1">
                 <a:solidFill>
                   <a:srgbClr val="FFFFFF"/>
                 </a:solidFill>
               </a:defRPr>
             </a:pPr>
             <a:r>
-              <a:t>QCBS Final Award</a:t>
-            </a:r>
-          </a:p>
-          <a:p>
-            <a:pPr>
-              <a:defRPr sz="1000">
+              <a:t>QCBS Award</a:t>
+            </a:r>
+          </a:p>
+          <a:p>
+            <a:pPr>
+              <a:defRPr sz="1100">
                 <a:solidFill>
                   <a:srgbClr val="94A3B8"/>
                 </a:solidFill>
               </a:defRPr>
             </a:pPr>
             <a:r>
-              <a:t>Only qualified bids unseal Envelope B. Award computed deterministically.</a:t>
+              <a:t>Qualified Unseal &amp; Deterministic Winner</a:t>
             </a:r>
           </a:p>
         </p:txBody>
@@ -5975,8 +5795,8 @@
         </p:nvSpPr>
         <p:spPr>
           <a:xfrm>
-            <a:off x="914400" y="3977639"/>
-            <a:ext cx="10360152" cy="2331720"/>
+            <a:off x="914400" y="3794760"/>
+            <a:ext cx="10360152" cy="2514600"/>
           </a:xfrm>
           <a:prstGeom prst="roundRect">
             <a:avLst/>
@@ -6020,8 +5840,8 @@
         </p:nvSpPr>
         <p:spPr>
           <a:xfrm>
-            <a:off x="1097280" y="4069080"/>
-            <a:ext cx="9966960" cy="2148840"/>
+            <a:off x="1097280" y="3886200"/>
+            <a:ext cx="9966960" cy="2331720"/>
           </a:xfrm>
           <a:prstGeom prst="rect">
             <a:avLst/>
@@ -6035,7 +5855,7 @@
           <a:lstStyle/>
           <a:p>
             <a:pPr>
-              <a:defRPr sz="1200" b="1">
+              <a:defRPr sz="1300" b="1">
                 <a:solidFill>
                   <a:srgbClr val="F43F5E"/>
                 </a:solidFill>
@@ -6047,50 +5867,50 @@
           </a:p>
           <a:p>
             <a:pPr>
-              <a:defRPr sz="1100">
+              <a:defRPr sz="1300">
                 <a:solidFill>
                   <a:srgbClr val="FFFFFF"/>
                 </a:solidFill>
               </a:defRPr>
             </a:pPr>
             <a:r>
-              <a:t>🛑 Attack 1: Late Bid Injection: Adversary injects bid at slot &gt; 1050. ➔ Anchor rejects: SubmissionDeadlineExceeded (0x1773).</a:t>
-            </a:r>
-          </a:p>
-          <a:p>
-            <a:pPr>
-              <a:defRPr sz="1100">
+              <a:t>🛑  Late Bidder Injected  ➔  Anchor Error: SubmissionDeadlineExceeded (0x1773)</a:t>
+            </a:r>
+          </a:p>
+          <a:p>
+            <a:pPr>
+              <a:defRPr sz="1300">
                 <a:solidFill>
                   <a:srgbClr val="FFFFFF"/>
                 </a:solidFill>
               </a:defRPr>
             </a:pPr>
             <a:r>
-              <a:t>🛑 Attack 2: Price Tampering: Insider alters quotation from $3.8M to $3.3M. ➔ Anchor rejects: InvalidRevealHash (0x1775).</a:t>
-            </a:r>
-          </a:p>
-          <a:p>
-            <a:pPr>
-              <a:defRPr sz="1100">
+              <a:t>🛑  Price Tampering (-$500k)  ➔  Anchor Error: InvalidRevealHash (0x1775)</a:t>
+            </a:r>
+          </a:p>
+          <a:p>
+            <a:pPr>
+              <a:defRPr sz="1300">
                 <a:solidFill>
                   <a:srgbClr val="FFFFFF"/>
                 </a:solidFill>
               </a:defRPr>
             </a:pPr>
             <a:r>
-              <a:t>🛑 Attack 3: Evaluator Collusion: Corrupt judge submits 98% outlier score. ➔ Olympic Trimmed Mean discards score &amp; flags judge.</a:t>
-            </a:r>
-          </a:p>
-          <a:p>
-            <a:pPr>
-              <a:defRPr sz="1100">
+              <a:t>🛑  Rogue Judge 98% Score  ➔  On-Chain Filter: OlympicTrimmedMeanPruned</a:t>
+            </a:r>
+          </a:p>
+          <a:p>
+            <a:pPr>
+              <a:defRPr sz="1300">
                 <a:solidFill>
                   <a:srgbClr val="FFFFFF"/>
                 </a:solidFill>
               </a:defRPr>
             </a:pPr>
             <a:r>
-              <a:t>🛑 Attack 4: Trade Secret Espionage: Buyer attempts to leak disqualified Bidder B's pricing. ➔ Anchor bars reveal: BidderTechnicallyDisqualified.</a:t>
+              <a:t>🛑  Trade Secret Leak  ➔  Anchor Error: CommercialSecrecyLock</a:t>
             </a:r>
           </a:p>
         </p:txBody>
@@ -6167,7 +5987,7 @@
         <p:spPr>
           <a:xfrm>
             <a:off x="914400" y="548640"/>
-            <a:ext cx="10332720" cy="822960"/>
+            <a:ext cx="10332720" cy="1005840"/>
           </a:xfrm>
           <a:prstGeom prst="rect">
             <a:avLst/>
@@ -6181,26 +6001,26 @@
           <a:lstStyle/>
           <a:p>
             <a:pPr>
-              <a:defRPr sz="1200" b="1">
+              <a:defRPr sz="1300" b="1">
                 <a:solidFill>
                   <a:srgbClr val="A855F7"/>
                 </a:solidFill>
               </a:defRPr>
             </a:pPr>
             <a:r>
-              <a:t>WHY SOLANA IS ESSENTIAL</a:t>
-            </a:r>
-          </a:p>
-          <a:p>
-            <a:pPr>
-              <a:defRPr sz="3200" b="1">
+              <a:t>THE SOLANA ADVANTAGE</a:t>
+            </a:r>
+          </a:p>
+          <a:p>
+            <a:pPr>
+              <a:defRPr sz="3400" b="1">
                 <a:solidFill>
                   <a:srgbClr val="FFFFFF"/>
                 </a:solidFill>
               </a:defRPr>
             </a:pPr>
             <a:r>
-              <a:t>The Consensus Clock &amp; Micro-Fee Advantage</a:t>
+              <a:t>Why Solana is Structurally Required</a:t>
             </a:r>
           </a:p>
         </p:txBody>
@@ -6213,8 +6033,8 @@
         </p:nvSpPr>
         <p:spPr>
           <a:xfrm>
-            <a:off x="914400" y="1645920"/>
-            <a:ext cx="3291840" cy="4572000"/>
+            <a:off x="914400" y="1737360"/>
+            <a:ext cx="3291840" cy="4389120"/>
           </a:xfrm>
           <a:prstGeom prst="roundRect">
             <a:avLst/>
@@ -6258,8 +6078,8 @@
         </p:nvSpPr>
         <p:spPr>
           <a:xfrm>
-            <a:off x="1097280" y="1828800"/>
-            <a:ext cx="2926080" cy="4206240"/>
+            <a:off x="1097280" y="1920240"/>
+            <a:ext cx="2926080" cy="4023360"/>
           </a:xfrm>
           <a:prstGeom prst="rect">
             <a:avLst/>
@@ -6273,63 +6093,63 @@
           <a:lstStyle/>
           <a:p>
             <a:pPr>
-              <a:defRPr sz="1500" b="1">
+              <a:defRPr sz="1700" b="1">
                 <a:solidFill>
                   <a:srgbClr val="06B6D4"/>
                 </a:solidFill>
               </a:defRPr>
             </a:pPr>
             <a:r>
-              <a:t>400ms Proof of History Clock</a:t>
-            </a:r>
-          </a:p>
-          <a:p>
-            <a:pPr>
-              <a:defRPr sz="1100">
+              <a:t>400ms Proof of History</a:t>
+            </a:r>
+          </a:p>
+          <a:p>
+            <a:pPr>
+              <a:defRPr sz="1200">
                 <a:solidFill>
                   <a:srgbClr val="94A3B8"/>
                 </a:solidFill>
               </a:defRPr>
             </a:pPr>
             <a:r>
-              <a:t>Strict Temporal Enforcement</a:t>
+              <a:t>Temporal Finality</a:t>
             </a:r>
           </a:p>
           <a:p/>
           <a:p>
             <a:pPr>
-              <a:defRPr sz="1100">
+              <a:defRPr sz="1300">
                 <a:solidFill>
                   <a:srgbClr val="FFFFFF"/>
                 </a:solidFill>
               </a:defRPr>
             </a:pPr>
             <a:r>
-              <a:t>▪ Traditional blockchains have 12-second block jitter.</a:t>
-            </a:r>
-          </a:p>
-          <a:p>
-            <a:pPr>
-              <a:defRPr sz="1100">
+              <a:t>▪ Sub-second statutory cutoff precision</a:t>
+            </a:r>
+          </a:p>
+          <a:p>
+            <a:pPr>
+              <a:defRPr sz="1300">
                 <a:solidFill>
                   <a:srgbClr val="FFFFFF"/>
                 </a:solidFill>
               </a:defRPr>
             </a:pPr>
             <a:r>
-              <a:t>▪ Solana's 400ms slot finality provides sub-second proof of exact submission cutoff times.</a:t>
-            </a:r>
-          </a:p>
-          <a:p>
-            <a:pPr>
-              <a:defRPr sz="1100">
+              <a:t>▪ Zero retroactive block jitter or timestamp edits</a:t>
+            </a:r>
+          </a:p>
+          <a:p>
+            <a:pPr>
+              <a:defRPr sz="1300">
                 <a:solidFill>
                   <a:srgbClr val="FFFFFF"/>
                 </a:solidFill>
               </a:defRPr>
             </a:pPr>
             <a:r>
-              <a:t>▪ Historical slots cannot be retroactively modified by validators or admins.</a:t>
+              <a:t>▪ Mathematical guarantee over historical slots</a:t>
             </a:r>
           </a:p>
         </p:txBody>
@@ -6342,8 +6162,8 @@
         </p:nvSpPr>
         <p:spPr>
           <a:xfrm>
-            <a:off x="4434840" y="1645920"/>
-            <a:ext cx="3291840" cy="4572000"/>
+            <a:off x="4434840" y="1737360"/>
+            <a:ext cx="3291840" cy="4389120"/>
           </a:xfrm>
           <a:prstGeom prst="roundRect">
             <a:avLst/>
@@ -6387,8 +6207,8 @@
         </p:nvSpPr>
         <p:spPr>
           <a:xfrm>
-            <a:off x="4617720" y="1828800"/>
-            <a:ext cx="2926080" cy="4206240"/>
+            <a:off x="4617720" y="1920240"/>
+            <a:ext cx="2926080" cy="4023360"/>
           </a:xfrm>
           <a:prstGeom prst="rect">
             <a:avLst/>
@@ -6402,63 +6222,63 @@
           <a:lstStyle/>
           <a:p>
             <a:pPr>
-              <a:defRPr sz="1500" b="1">
+              <a:defRPr sz="1700" b="1">
                 <a:solidFill>
                   <a:srgbClr val="A855F7"/>
                 </a:solidFill>
               </a:defRPr>
             </a:pPr>
             <a:r>
-              <a:t>Sub-Cent High Frequency Fees</a:t>
-            </a:r>
-          </a:p>
-          <a:p>
-            <a:pPr>
-              <a:defRPr sz="1100">
+              <a:t>Micro-Cent Network Fees</a:t>
+            </a:r>
+          </a:p>
+          <a:p>
+            <a:pPr>
+              <a:defRPr sz="1200">
                 <a:solidFill>
                   <a:srgbClr val="94A3B8"/>
                 </a:solidFill>
               </a:defRPr>
             </a:pPr>
             <a:r>
-              <a:t>Granular Multi-Envelope Commitments</a:t>
+              <a:t>Granular State Updates</a:t>
             </a:r>
           </a:p>
           <a:p/>
           <a:p>
             <a:pPr>
-              <a:defRPr sz="1100">
+              <a:defRPr sz="1300">
                 <a:solidFill>
                   <a:srgbClr val="FFFFFF"/>
                 </a:solidFill>
               </a:defRPr>
             </a:pPr>
             <a:r>
-              <a:t>▪ Tenders generate dozens of granular state updates: envelope commits, 5 evaluator scores, unseals.</a:t>
-            </a:r>
-          </a:p>
-          <a:p>
-            <a:pPr>
-              <a:defRPr sz="1100">
+              <a:t>▪ 5-stage multi-envelope state transitions</a:t>
+            </a:r>
+          </a:p>
+          <a:p>
+            <a:pPr>
+              <a:defRPr sz="1300">
                 <a:solidFill>
                   <a:srgbClr val="FFFFFF"/>
                 </a:solidFill>
               </a:defRPr>
             </a:pPr>
             <a:r>
-              <a:t>▪ EVM gas costs ($10-$50) make multi-round commits economically unviable.</a:t>
-            </a:r>
-          </a:p>
-          <a:p>
-            <a:pPr>
-              <a:defRPr sz="1100">
+              <a:t>▪ 5 evaluator score commits per tender</a:t>
+            </a:r>
+          </a:p>
+          <a:p>
+            <a:pPr>
+              <a:defRPr sz="1300">
                 <a:solidFill>
                   <a:srgbClr val="FFFFFF"/>
                 </a:solidFill>
               </a:defRPr>
             </a:pPr>
             <a:r>
-              <a:t>▪ Solana executes the full 5-stage lifecycle for &lt; $0.01 total network gas.</a:t>
+              <a:t>▪ &lt; $0.01 total gas per entire tender lifecycle</a:t>
             </a:r>
           </a:p>
         </p:txBody>
@@ -6471,8 +6291,8 @@
         </p:nvSpPr>
         <p:spPr>
           <a:xfrm>
-            <a:off x="7955279" y="1645920"/>
-            <a:ext cx="3291840" cy="4572000"/>
+            <a:off x="7955279" y="1737360"/>
+            <a:ext cx="3291840" cy="4389120"/>
           </a:xfrm>
           <a:prstGeom prst="roundRect">
             <a:avLst/>
@@ -6516,8 +6336,8 @@
         </p:nvSpPr>
         <p:spPr>
           <a:xfrm>
-            <a:off x="8138159" y="1828800"/>
-            <a:ext cx="2926080" cy="4206240"/>
+            <a:off x="8138159" y="1920240"/>
+            <a:ext cx="2926080" cy="4023360"/>
           </a:xfrm>
           <a:prstGeom prst="rect">
             <a:avLst/>
@@ -6531,63 +6351,63 @@
           <a:lstStyle/>
           <a:p>
             <a:pPr>
-              <a:defRPr sz="1500" b="1">
+              <a:defRPr sz="1700" b="1">
                 <a:solidFill>
                   <a:srgbClr val="10B981"/>
                 </a:solidFill>
               </a:defRPr>
             </a:pPr>
             <a:r>
-              <a:t>TradFi Decoupling Gateway</a:t>
-            </a:r>
-          </a:p>
-          <a:p>
-            <a:pPr>
-              <a:defRPr sz="1100">
+              <a:t>Zero-Gas Gateway</a:t>
+            </a:r>
+          </a:p>
+          <a:p>
+            <a:pPr>
+              <a:defRPr sz="1200">
                 <a:solidFill>
                   <a:srgbClr val="94A3B8"/>
                 </a:solidFill>
               </a:defRPr>
             </a:pPr>
             <a:r>
-              <a:t>Institutional Adoption Today</a:t>
+              <a:t>Frictionless TradFi Adoption</a:t>
             </a:r>
           </a:p>
           <a:p/>
           <a:p>
             <a:pPr>
-              <a:defRPr sz="1100">
+              <a:defRPr sz="1300">
                 <a:solidFill>
                   <a:srgbClr val="FFFFFF"/>
                 </a:solidFill>
               </a:defRPr>
             </a:pPr>
             <a:r>
-              <a:t>▪ Zero crypto balance required for corporate treasuries.</a:t>
-            </a:r>
-          </a:p>
-          <a:p>
-            <a:pPr>
-              <a:defRPr sz="1100">
+              <a:t>▪ Zero crypto balance required for contractors</a:t>
+            </a:r>
+          </a:p>
+          <a:p>
+            <a:pPr>
+              <a:defRPr sz="1300">
                 <a:solidFill>
                   <a:srgbClr val="FFFFFF"/>
                 </a:solidFill>
               </a:defRPr>
             </a:pPr>
             <a:r>
-              <a:t>▪ Multi-jurisdiction bond engine: Surety MGA policies, SWIFT MT760 bank guarantees, World Bank BSDs.</a:t>
-            </a:r>
-          </a:p>
-          <a:p>
-            <a:pPr>
-              <a:defRPr sz="1100">
+              <a:t>▪ Sponsored relayer pays all network gas</a:t>
+            </a:r>
+          </a:p>
+          <a:p>
+            <a:pPr>
+              <a:defRPr sz="1300">
                 <a:solidFill>
                   <a:srgbClr val="FFFFFF"/>
                 </a:solidFill>
               </a:defRPr>
             </a:pPr>
             <a:r>
-              <a:t>▪ Full compatibility with existing e-GP legal frameworks (FIDIC &amp; World Bank).</a:t>
+              <a:t>▪ 100% compliant with sovereign treasury laws</a:t>
             </a:r>
           </a:p>
         </p:txBody>
@@ -6664,7 +6484,7 @@
         <p:spPr>
           <a:xfrm>
             <a:off x="914400" y="548640"/>
-            <a:ext cx="10332720" cy="822960"/>
+            <a:ext cx="10332720" cy="1005840"/>
           </a:xfrm>
           <a:prstGeom prst="rect">
             <a:avLst/>
@@ -6678,19 +6498,19 @@
           <a:lstStyle/>
           <a:p>
             <a:pPr>
-              <a:defRPr sz="1200" b="1">
+              <a:defRPr sz="1300" b="1">
                 <a:solidFill>
                   <a:srgbClr val="06B6D4"/>
                 </a:solidFill>
               </a:defRPr>
             </a:pPr>
             <a:r>
-              <a:t>WHAT WE BUILT &amp; TRACTION</a:t>
-            </a:r>
-          </a:p>
-          <a:p>
-            <a:pPr>
-              <a:defRPr sz="3200" b="1">
+              <a:t>VERIFIED EXECUTION</a:t>
+            </a:r>
+          </a:p>
+          <a:p>
+            <a:pPr>
+              <a:defRPr sz="3400" b="1">
                 <a:solidFill>
                   <a:srgbClr val="FFFFFF"/>
                 </a:solidFill>
@@ -6710,8 +6530,8 @@
         </p:nvSpPr>
         <p:spPr>
           <a:xfrm>
-            <a:off x="914400" y="1645920"/>
-            <a:ext cx="2468880" cy="2194560"/>
+            <a:off x="914400" y="1737360"/>
+            <a:ext cx="2468880" cy="1920240"/>
           </a:xfrm>
           <a:prstGeom prst="roundRect">
             <a:avLst/>
@@ -6755,8 +6575,8 @@
         </p:nvSpPr>
         <p:spPr>
           <a:xfrm>
-            <a:off x="1051560" y="1737360"/>
-            <a:ext cx="2194560" cy="2011680"/>
+            <a:off x="1051560" y="1828800"/>
+            <a:ext cx="2194560" cy="1737360"/>
           </a:xfrm>
           <a:prstGeom prst="rect">
             <a:avLst/>
@@ -6770,38 +6590,38 @@
           <a:lstStyle/>
           <a:p>
             <a:pPr>
-              <a:defRPr sz="1400" b="1">
+              <a:defRPr sz="3200" b="1">
                 <a:solidFill>
                   <a:srgbClr val="06B6D4"/>
                 </a:solidFill>
               </a:defRPr>
             </a:pPr>
             <a:r>
-              <a:t>Anchor Devnet Deployed</a:t>
-            </a:r>
-          </a:p>
-          <a:p>
-            <a:pPr>
-              <a:defRPr sz="1100" b="1">
+              <a:t>10</a:t>
+            </a:r>
+          </a:p>
+          <a:p>
+            <a:pPr>
+              <a:defRPr sz="1300" b="1">
                 <a:solidFill>
                   <a:srgbClr val="FFFFFF"/>
                 </a:solidFill>
               </a:defRPr>
             </a:pPr>
             <a:r>
-              <a:t>Live Program</a:t>
-            </a:r>
-          </a:p>
-          <a:p>
-            <a:pPr>
-              <a:defRPr sz="1000">
+              <a:t>Anchor Instructions</a:t>
+            </a:r>
+          </a:p>
+          <a:p>
+            <a:pPr>
+              <a:defRPr sz="1100">
                 <a:solidFill>
                   <a:srgbClr val="94A3B8"/>
                 </a:solidFill>
               </a:defRPr>
             </a:pPr>
             <a:r>
-              <a:t>x3iSm5BCoXvEfNwT6m6Vs7ApBJtKjvuTm7qKBJtESjZ on Devnet cluster.</a:t>
+              <a:t>Deployed on Devnet</a:t>
             </a:r>
           </a:p>
         </p:txBody>
@@ -6814,8 +6634,8 @@
         </p:nvSpPr>
         <p:spPr>
           <a:xfrm>
-            <a:off x="3547872" y="1645920"/>
-            <a:ext cx="2468880" cy="2194560"/>
+            <a:off x="3547872" y="1737360"/>
+            <a:ext cx="2468880" cy="1920240"/>
           </a:xfrm>
           <a:prstGeom prst="roundRect">
             <a:avLst/>
@@ -6859,8 +6679,8 @@
         </p:nvSpPr>
         <p:spPr>
           <a:xfrm>
-            <a:off x="3685032" y="1737360"/>
-            <a:ext cx="2194560" cy="2011680"/>
+            <a:off x="3685032" y="1828800"/>
+            <a:ext cx="2194560" cy="1737360"/>
           </a:xfrm>
           <a:prstGeom prst="rect">
             <a:avLst/>
@@ -6874,38 +6694,38 @@
           <a:lstStyle/>
           <a:p>
             <a:pPr>
-              <a:defRPr sz="1400" b="1">
+              <a:defRPr sz="3200" b="1">
                 <a:solidFill>
                   <a:srgbClr val="10B981"/>
                 </a:solidFill>
               </a:defRPr>
             </a:pPr>
             <a:r>
-              <a:t>78 Passing Unit Tests</a:t>
-            </a:r>
-          </a:p>
-          <a:p>
-            <a:pPr>
-              <a:defRPr sz="1100" b="1">
+              <a:t>78 / 78</a:t>
+            </a:r>
+          </a:p>
+          <a:p>
+            <a:pPr>
+              <a:defRPr sz="1300" b="1">
                 <a:solidFill>
                   <a:srgbClr val="FFFFFF"/>
                 </a:solidFill>
               </a:defRPr>
             </a:pPr>
             <a:r>
-              <a:t>100% Cryptographic Parity</a:t>
-            </a:r>
-          </a:p>
-          <a:p>
-            <a:pPr>
-              <a:defRPr sz="1000">
+              <a:t>Passing Unit Tests</a:t>
+            </a:r>
+          </a:p>
+          <a:p>
+            <a:pPr>
+              <a:defRPr sz="1100">
                 <a:solidFill>
                   <a:srgbClr val="94A3B8"/>
                 </a:solidFill>
               </a:defRPr>
             </a:pPr>
             <a:r>
-              <a:t>Full Python and Node.js cross-language RFC 8785 hash parity verified.</a:t>
+              <a:t>100% Hash Parity</a:t>
             </a:r>
           </a:p>
         </p:txBody>
@@ -6918,8 +6738,8 @@
         </p:nvSpPr>
         <p:spPr>
           <a:xfrm>
-            <a:off x="6181344" y="1645920"/>
-            <a:ext cx="2468880" cy="2194560"/>
+            <a:off x="6181344" y="1737360"/>
+            <a:ext cx="2468880" cy="1920240"/>
           </a:xfrm>
           <a:prstGeom prst="roundRect">
             <a:avLst/>
@@ -6963,8 +6783,8 @@
         </p:nvSpPr>
         <p:spPr>
           <a:xfrm>
-            <a:off x="6318504" y="1737360"/>
-            <a:ext cx="2194560" cy="2011680"/>
+            <a:off x="6318504" y="1828800"/>
+            <a:ext cx="2194560" cy="1737360"/>
           </a:xfrm>
           <a:prstGeom prst="rect">
             <a:avLst/>
@@ -6978,38 +6798,38 @@
           <a:lstStyle/>
           <a:p>
             <a:pPr>
-              <a:defRPr sz="1400" b="1">
+              <a:defRPr sz="3200" b="1">
                 <a:solidFill>
                   <a:srgbClr val="A855F7"/>
                 </a:solidFill>
               </a:defRPr>
             </a:pPr>
             <a:r>
-              <a:t>Live Web Dashboard</a:t>
-            </a:r>
-          </a:p>
-          <a:p>
-            <a:pPr>
-              <a:defRPr sz="1100" b="1">
+              <a:t>5 / 5</a:t>
+            </a:r>
+          </a:p>
+          <a:p>
+            <a:pPr>
+              <a:defRPr sz="1300" b="1">
                 <a:solidFill>
                   <a:srgbClr val="FFFFFF"/>
                 </a:solidFill>
               </a:defRPr>
             </a:pPr>
             <a:r>
-              <a:t>bidtrace.net</a:t>
-            </a:r>
-          </a:p>
-          <a:p>
-            <a:pPr>
-              <a:defRPr sz="1000">
+              <a:t>Storyboard Steps</a:t>
+            </a:r>
+          </a:p>
+          <a:p>
+            <a:pPr>
+              <a:defRPr sz="1100">
                 <a:solidFill>
                   <a:srgbClr val="94A3B8"/>
                 </a:solidFill>
               </a:defRPr>
             </a:pPr>
             <a:r>
-              <a:t>Full interactive 5-step storyboard HUD, 7 portals, and attack simulator.</a:t>
+              <a:t>1-Click Interactive HUD</a:t>
             </a:r>
           </a:p>
         </p:txBody>
@@ -7022,8 +6842,8 @@
         </p:nvSpPr>
         <p:spPr>
           <a:xfrm>
-            <a:off x="8814816" y="1645920"/>
-            <a:ext cx="2468880" cy="2194560"/>
+            <a:off x="8814816" y="1737360"/>
+            <a:ext cx="2468880" cy="1920240"/>
           </a:xfrm>
           <a:prstGeom prst="roundRect">
             <a:avLst/>
@@ -7067,8 +6887,8 @@
         </p:nvSpPr>
         <p:spPr>
           <a:xfrm>
-            <a:off x="8951976" y="1737360"/>
-            <a:ext cx="2194560" cy="2011680"/>
+            <a:off x="8951976" y="1828800"/>
+            <a:ext cx="2194560" cy="1737360"/>
           </a:xfrm>
           <a:prstGeom prst="rect">
             <a:avLst/>
@@ -7082,38 +6902,38 @@
           <a:lstStyle/>
           <a:p>
             <a:pPr>
-              <a:defRPr sz="1400" b="1">
+              <a:defRPr sz="3200" b="1">
                 <a:solidFill>
                   <a:srgbClr val="F59E0B"/>
                 </a:solidFill>
               </a:defRPr>
             </a:pPr>
             <a:r>
-              <a:t>Air-Gapped Verifier</a:t>
-            </a:r>
-          </a:p>
-          <a:p>
-            <a:pPr>
-              <a:defRPr sz="1100" b="1">
+              <a:t>4</a:t>
+            </a:r>
+          </a:p>
+          <a:p>
+            <a:pPr>
+              <a:defRPr sz="1300" b="1">
                 <a:solidFill>
                   <a:srgbClr val="FFFFFF"/>
                 </a:solidFill>
               </a:defRPr>
             </a:pPr>
             <a:r>
-              <a:t>Independent Tribunal</a:t>
-            </a:r>
-          </a:p>
-          <a:p>
-            <a:pPr>
-              <a:defRPr sz="1000">
+              <a:t>Hybrid Bond Modes</a:t>
+            </a:r>
+          </a:p>
+          <a:p>
+            <a:pPr>
+              <a:defRPr sz="1100">
                 <a:solidFill>
                   <a:srgbClr val="94A3B8"/>
                 </a:solidFill>
               </a:defRPr>
             </a:pPr>
             <a:r>
-              <a:t>Complete Python dossier verifier for offline legal audits.</a:t>
+              <a:t>TradFi + Crypto</a:t>
             </a:r>
           </a:p>
         </p:txBody>
@@ -7126,8 +6946,8 @@
         </p:nvSpPr>
         <p:spPr>
           <a:xfrm>
-            <a:off x="914400" y="4114800"/>
-            <a:ext cx="10360152" cy="2103120"/>
+            <a:off x="914400" y="3977639"/>
+            <a:ext cx="10360152" cy="2240280"/>
           </a:xfrm>
           <a:prstGeom prst="roundRect">
             <a:avLst/>
@@ -7171,8 +6991,8 @@
         </p:nvSpPr>
         <p:spPr>
           <a:xfrm>
-            <a:off x="1188720" y="4297680"/>
-            <a:ext cx="9784080" cy="1737360"/>
+            <a:off x="1188720" y="4160520"/>
+            <a:ext cx="9784080" cy="1920240"/>
           </a:xfrm>
           <a:prstGeom prst="rect">
             <a:avLst/>
@@ -7186,38 +7006,38 @@
           <a:lstStyle/>
           <a:p>
             <a:pPr>
-              <a:defRPr sz="1400" b="1">
+              <a:defRPr sz="1500" b="1">
                 <a:solidFill>
                   <a:srgbClr val="06B6D4"/>
                 </a:solidFill>
               </a:defRPr>
             </a:pPr>
             <a:r>
-              <a:t>THE VISION: THE TRUSTED SETTLEMENT LAYER FOR GLOBAL CAPITAL</a:t>
+              <a:t>THE SETTLEMENT LAYER FOR SOVEREIGN CAPITAL</a:t>
+            </a:r>
+          </a:p>
+          <a:p>
+            <a:pPr>
+              <a:defRPr sz="2000" b="1">
+                <a:solidFill>
+                  <a:srgbClr val="FFFFFF"/>
+                </a:solidFill>
+              </a:defRPr>
+            </a:pPr>
+            <a:r>
+              <a:t>Live Interactive Web App: bidtrace.net</a:t>
             </a:r>
           </a:p>
           <a:p>
             <a:pPr>
               <a:defRPr sz="1300">
                 <a:solidFill>
-                  <a:srgbClr val="FFFFFF"/>
-                </a:solidFill>
-              </a:defRPr>
-            </a:pPr>
-            <a:r>
-              <a:t>Public procurement is 15% of global GDP. By establishing mathematical finality over bid intake, evaluator scoring, and award execution, BidTrace is building the incorruptible cryptographic operating system for sovereign infrastructure.</a:t>
-            </a:r>
-          </a:p>
-          <a:p>
-            <a:pPr>
-              <a:defRPr sz="1200" b="1">
-                <a:solidFill>
-                  <a:srgbClr val="06B6D4"/>
-                </a:solidFill>
-              </a:defRPr>
-            </a:pPr>
-            <a:r>
-              <a:t>Explore the live dashboard at bidtrace.net | GitHub: github.com/Ujjwal1396/BidTrace</a:t>
+                  <a:srgbClr val="94A3B8"/>
+                </a:solidFill>
+              </a:defRPr>
+            </a:pPr>
+            <a:r>
+              <a:t>Program ID: x3iSm5BCoXvEfNwT6m6Vs7ApBJtKjvuTm7qKBJtESjZ  |  GitHub: Ujjwal1396/BidTrace</a:t>
             </a:r>
           </a:p>
         </p:txBody>

</xml_diff>

<commit_message>
feat(pitch): align pitch deck with Pitchdeck 101 guide (7 slides, no roadmap, <40 words)
</commit_message>
<xml_diff>
--- a/BidTrace_Pitch_Deck_2Min.pptx
+++ b/BidTrace_Pitch_Deck_2Min.pptx
@@ -11,6 +11,7 @@
     <p:sldId id="259" r:id="rId11"/>
     <p:sldId id="260" r:id="rId12"/>
     <p:sldId id="261" r:id="rId13"/>
+    <p:sldId id="262" r:id="rId14"/>
   </p:sldIdLst>
   <p:sldSz cx="12191695" cy="6858000" type="screen4x3"/>
   <p:notesSz cx="6858000" cy="9144000"/>
@@ -507,12 +508,12 @@
           <a:lstStyle/>
           <a:p>
             <a:r>
-              <a:t>[SLIDE 1 | 0:00 - 0:15 | 32 Words]</a:t>
-            </a:r>
-          </a:p>
-          <a:p>
-            <a:r>
-              <a:t>"Judges, every year, $13 trillion is spent on public infrastructure. Yet the entire industry relies on centralized database trust. BidTrace brings tamper-proof sealed bidding to public contracts on Solana, making corruption mathematically impossible."</a:t>
+              <a:t>[SLIDE 1 | 0:00 - 0:15 | 28 Words on Slide]</a:t>
+            </a:r>
+          </a:p>
+          <a:p>
+            <a:r>
+              <a:t>"Judges, every year $13 trillion is spent on public infrastructure, yet the entire process runs on centralized database trust. BidTrace brings tamper-proof sealed bidding to public contracts on Solana, making insider tampering mathematically impossible."</a:t>
             </a:r>
           </a:p>
         </p:txBody>
@@ -582,12 +583,12 @@
           <a:lstStyle/>
           <a:p>
             <a:r>
-              <a:t>[SLIDE 2 | 0:15 - 0:40 | 54 Words]</a:t>
-            </a:r>
-          </a:p>
-          <a:p>
-            <a:r>
-              <a:t>"The fatal flaw in procurement isn't bad people—it's a physical window of time. Between the deadline and bid opening, database admins have god-mode. They peek at competitor pricing, alter scores, and backdate late bids into MySQL databases. BidTrace replaces administrative custody with Solana's consensus clock: if a slot expires, code blocks entry forever."</a:t>
+              <a:t>[SLIDE 2 | 0:15 - 0:35 | 35 Words on Slide]</a:t>
+            </a:r>
+          </a:p>
+          <a:p>
+            <a:r>
+              <a:t>"The fatal flaw in procurement isn't bad people—it's a window of time. Between submission deadlines and public opening, database admins have unmonitored root access to peek at competitor prices and backdate bids in MySQL. Centralized trust fails silently every single day."</a:t>
             </a:r>
           </a:p>
         </p:txBody>
@@ -657,12 +658,12 @@
           <a:lstStyle/>
           <a:p>
             <a:r>
-              <a:t>[SLIDE 3 | 0:40 - 1:05 | 55 Words]</a:t>
-            </a:r>
-          </a:p>
-          <a:p>
-            <a:r>
-              <a:t>"To solve this without forcing governments to hold crypto, we built a two-plane architecture. Off-chain, we serialize tenders using the World Bank's OCDS 1.1 standard and RFC 8785 canonical hashing. On-chain, ten Solana Anchor instructions enforce temporal phase locks, blinded evaluator rubrics, and commercial secrecy—sponsored by a zero-fiat-gas relayer."</a:t>
+              <a:t>[SLIDE 3 | 0:35 - 0:55 | 34 Words on Slide]</a:t>
+            </a:r>
+          </a:p>
+          <a:p>
+            <a:r>
+              <a:t>"BidTrace is Chainlink meets sealed envelopes for sovereign infrastructure. Our unique insight: Solana's 400ms Proof of History turns time into an unalterable physical law. Contractors seal dual envelopes, expired slots are rejected by validators, and evaluator collusion is pruned on-chain."</a:t>
             </a:r>
           </a:p>
         </p:txBody>
@@ -732,12 +733,12 @@
           <a:lstStyle/>
           <a:p>
             <a:r>
-              <a:t>[SLIDE 4 | 1:05 - 1:30 | 56 Words]</a:t>
-            </a:r>
-          </a:p>
-          <a:p>
-            <a:r>
-              <a:t>"Here is the live lifecycle. Stage 1: Tenders are published with canonical hashes. Stage 2: Contractors seal dual envelopes. Stage 3: Evaluators grade blindly, and our on-chain trimmed mean automatically prunes rogue scores. Stage 4: Only qualified bids unseal price. In our attack simulator, late bids, price tampering, and data leaks get rejected on-chain."</a:t>
+              <a:t>[SLIDE 4 | 0:55 - 1:15 | 36 Words on Slide]</a:t>
+            </a:r>
+          </a:p>
+          <a:p>
+            <a:r>
+              <a:t>"The macro tailwind is massive: the World Bank and UN now mandate OCDS 1.1 data standards to combat systemic fraud. Our bottoms-up beachhead is the $500 billion in development bank tenders. The dream state is clear: incorruptible sovereign capital where kickbacks are cryptographically eliminated."</a:t>
             </a:r>
           </a:p>
         </p:txBody>
@@ -807,12 +808,12 @@
           <a:lstStyle/>
           <a:p>
             <a:r>
-              <a:t>[SLIDE 5 | 1:30 - 1:50 | 44 Words]</a:t>
-            </a:r>
-          </a:p>
-          <a:p>
-            <a:r>
-              <a:t>"Why Solana? Two reasons: Proof of History and cost. Solana's 400-millisecond slot clock provides the sub-second temporal certainty required to legally freeze bids. And because transactions cost fractions of a cent, our relayer sponsors all gas, allowing governments to adopt Web3 guarantees without holding volatile crypto."</a:t>
+              <a:t>[SLIDE 5 | 1:15 - 1:35 | 36 Words on Slide]</a:t>
+            </a:r>
+          </a:p>
+          <a:p>
+            <a:r>
+              <a:t>"This is not a slide concept—BidTrace is already working. We have 10 Anchor Rust instructions deployed on Solana Devnet, 78 passing unit tests with 100% hash parity, and an adversarial attack simulator live right now at bidtrace.net where you can watch live exploits fail on-chain."</a:t>
             </a:r>
           </a:p>
         </p:txBody>
@@ -882,12 +883,87 @@
           <a:lstStyle/>
           <a:p>
             <a:r>
-              <a:t>[SLIDE 6 | 1:50 - 2:00 | 25 Words]</a:t>
-            </a:r>
-          </a:p>
-          <a:p>
-            <a:r>
-              <a:t>"BidTrace is fully functional today: live on Solana Devnet, backed by 78 passing unit tests and a live web app at bidtrace.net. Thank you!"</a:t>
+              <a:t>[SLIDE 6 | 1:35 - 1:50 | 39 Words on Slide]</a:t>
+            </a:r>
+          </a:p>
+          <a:p>
+            <a:r>
+              <a:t>"Why does this keep working? Our business model scales with volume: a 0.05% protocol take-rate on awarded contracts plus TradFi surety underwriting fees. Our network effect is the zero-gas relayer: contractors pay no crypto gas, and each onboarded government locks hundreds of contractors into our verification rail."</a:t>
+            </a:r>
+          </a:p>
+        </p:txBody>
+      </p:sp>
+      <p:sp>
+        <p:nvSpPr>
+          <p:cNvPr id="4" name="Slide Number Placeholder 3"/>
+          <p:cNvSpPr>
+            <a:spLocks noGrp="1"/>
+          </p:cNvSpPr>
+          <p:nvPr>
+            <p:ph type="sldNum" idx="5" sz="quarter"/>
+          </p:nvPr>
+        </p:nvSpPr>
+        <p:spPr/>
+      </p:sp>
+    </p:spTree>
+  </p:cSld>
+  <p:clrMapOvr>
+    <a:masterClrMapping/>
+  </p:clrMapOvr>
+</p:notes>
+</file>
+
+<file path=ppt/notesSlides/notesSlide7.xml><?xml version="1.0" encoding="utf-8"?>
+<p:notes xmlns:a="http://schemas.openxmlformats.org/drawingml/2006/main" xmlns:p="http://schemas.openxmlformats.org/presentationml/2006/main" xmlns:r="http://schemas.openxmlformats.org/officeDocument/2006/relationships">
+  <p:cSld>
+    <p:spTree>
+      <p:nvGrpSpPr>
+        <p:cNvPr id="1" name=""/>
+        <p:cNvGrpSpPr/>
+        <p:nvPr/>
+      </p:nvGrpSpPr>
+      <p:grpSpPr>
+        <a:xfrm>
+          <a:off x="0" y="0"/>
+          <a:ext cx="0" cy="0"/>
+          <a:chOff x="0" y="0"/>
+          <a:chExt cx="0" cy="0"/>
+        </a:xfrm>
+      </p:grpSpPr>
+      <p:sp>
+        <p:nvSpPr>
+          <p:cNvPr id="2" name="Slide Image Placeholder 1"/>
+          <p:cNvSpPr>
+            <a:spLocks noGrp="1"/>
+          </p:cNvSpPr>
+          <p:nvPr>
+            <p:ph type="sldImg" idx="2"/>
+          </p:nvPr>
+        </p:nvSpPr>
+        <p:spPr/>
+      </p:sp>
+      <p:sp>
+        <p:nvSpPr>
+          <p:cNvPr id="3" name="Notes Placeholder 2"/>
+          <p:cNvSpPr>
+            <a:spLocks noGrp="1"/>
+          </p:cNvSpPr>
+          <p:nvPr>
+            <p:ph type="body" idx="3" sz="quarter"/>
+          </p:nvPr>
+        </p:nvSpPr>
+        <p:spPr/>
+        <p:txBody>
+          <a:bodyPr/>
+          <a:lstStyle/>
+          <a:p>
+            <a:r>
+              <a:t>[SLIDE 7 | 1:50 - 2:00 | 39 Words on Slide]</a:t>
+            </a:r>
+          </a:p>
+          <a:p>
+            <a:r>
+              <a:t>"We are uniquely equipped for this problem—combining deep expertise in Solana Anchor engineering, World Bank OCDS standards, and institutional compliance. We built BidTrace to give the world incorruptible public infrastructure. Thank you."</a:t>
             </a:r>
           </a:p>
         </p:txBody>
@@ -3954,7 +4030,7 @@
         </p:blipFill>
         <p:spPr>
           <a:xfrm>
-            <a:off x="1097280" y="1463040"/>
+            <a:off x="1097280" y="1371600"/>
             <a:ext cx="1645920" cy="1857820"/>
           </a:xfrm>
           <a:prstGeom prst="rect">
@@ -3970,8 +4046,8 @@
         </p:nvSpPr>
         <p:spPr>
           <a:xfrm>
-            <a:off x="3017520" y="1508760"/>
-            <a:ext cx="3474720" cy="411480"/>
+            <a:off x="3017520" y="1417320"/>
+            <a:ext cx="3840480" cy="384048"/>
           </a:xfrm>
           <a:prstGeom prst="roundRect">
             <a:avLst/>
@@ -4024,7 +4100,7 @@
         </p:nvSpPr>
         <p:spPr>
           <a:xfrm>
-            <a:off x="2926080" y="1965960"/>
+            <a:off x="2926080" y="1874519"/>
             <a:ext cx="8229600" cy="1097280"/>
           </a:xfrm>
           <a:prstGeom prst="rect">
@@ -4059,7 +4135,7 @@
         </p:nvSpPr>
         <p:spPr>
           <a:xfrm>
-            <a:off x="1097280" y="3291840"/>
+            <a:off x="1097280" y="3154680"/>
             <a:ext cx="10058400" cy="1188720"/>
           </a:xfrm>
           <a:prstGeom prst="rect">
@@ -4094,8 +4170,8 @@
         </p:nvSpPr>
         <p:spPr>
           <a:xfrm>
-            <a:off x="1097280" y="4846320"/>
-            <a:ext cx="3200400" cy="1280160"/>
+            <a:off x="1097280" y="4754880"/>
+            <a:ext cx="3200400" cy="1371600"/>
           </a:xfrm>
           <a:prstGeom prst="roundRect">
             <a:avLst/>
@@ -4139,7 +4215,7 @@
         </p:nvSpPr>
         <p:spPr>
           <a:xfrm>
-            <a:off x="1280160" y="4937760"/>
+            <a:off x="1280160" y="4892040"/>
             <a:ext cx="2834640" cy="1097280"/>
           </a:xfrm>
           <a:prstGeom prst="rect">
@@ -4173,7 +4249,7 @@
               </a:defRPr>
             </a:pPr>
             <a:r>
-              <a:t>Protected Market</a:t>
+              <a:t>Annual Sovereign Spend</a:t>
             </a:r>
           </a:p>
         </p:txBody>
@@ -4186,8 +4262,8 @@
         </p:nvSpPr>
         <p:spPr>
           <a:xfrm>
-            <a:off x="4526280" y="4846320"/>
-            <a:ext cx="3200400" cy="1280160"/>
+            <a:off x="4526280" y="4754880"/>
+            <a:ext cx="3200400" cy="1371600"/>
           </a:xfrm>
           <a:prstGeom prst="roundRect">
             <a:avLst/>
@@ -4231,7 +4307,7 @@
         </p:nvSpPr>
         <p:spPr>
           <a:xfrm>
-            <a:off x="4709160" y="4937760"/>
+            <a:off x="4709160" y="4892040"/>
             <a:ext cx="2834640" cy="1097280"/>
           </a:xfrm>
           <a:prstGeom prst="rect">
@@ -4265,7 +4341,7 @@
               </a:defRPr>
             </a:pPr>
             <a:r>
-              <a:t>Proof of History</a:t>
+              <a:t>Proof of History Precision</a:t>
             </a:r>
           </a:p>
         </p:txBody>
@@ -4278,8 +4354,8 @@
         </p:nvSpPr>
         <p:spPr>
           <a:xfrm>
-            <a:off x="7955279" y="4846320"/>
-            <a:ext cx="3200400" cy="1280160"/>
+            <a:off x="7955279" y="4754880"/>
+            <a:ext cx="3200400" cy="1371600"/>
           </a:xfrm>
           <a:prstGeom prst="roundRect">
             <a:avLst/>
@@ -4323,7 +4399,7 @@
         </p:nvSpPr>
         <p:spPr>
           <a:xfrm>
-            <a:off x="8138159" y="4937760"/>
+            <a:off x="8138159" y="4892040"/>
             <a:ext cx="2834640" cy="1097280"/>
           </a:xfrm>
           <a:prstGeom prst="rect">
@@ -4357,7 +4433,7 @@
               </a:defRPr>
             </a:pPr>
             <a:r>
-              <a:t>Enterprise Sponsored</a:t>
+              <a:t>Enterprise Relayer Sponsored</a:t>
             </a:r>
           </a:p>
         </p:txBody>
@@ -4455,7 +4531,7 @@
               </a:defRPr>
             </a:pPr>
             <a:r>
-              <a:t>THE $13 TRILLION VULNERABILITY</a:t>
+              <a:t>THE $13 TRILLION CRITICAL FLAW</a:t>
             </a:r>
           </a:p>
           <a:p>
@@ -4525,8 +4601,8 @@
         </p:nvSpPr>
         <p:spPr>
           <a:xfrm>
-            <a:off x="1188720" y="1920240"/>
-            <a:ext cx="4389120" cy="4023360"/>
+            <a:off x="1188720" y="2011680"/>
+            <a:ext cx="4389120" cy="3840480"/>
           </a:xfrm>
           <a:prstGeom prst="rect">
             <a:avLst/>
@@ -4540,62 +4616,47 @@
           <a:lstStyle/>
           <a:p>
             <a:pPr>
-              <a:defRPr sz="2000" b="1">
+              <a:defRPr sz="3600" b="1">
                 <a:solidFill>
                   <a:srgbClr val="F43F5E"/>
                 </a:solidFill>
               </a:defRPr>
             </a:pPr>
             <a:r>
-              <a:t>✖  Centralized E-Procurement</a:t>
-            </a:r>
-          </a:p>
-          <a:p>
+              <a:t>$13 Trillion / Year</a:t>
+            </a:r>
+          </a:p>
+          <a:p>
+            <a:pPr>
+              <a:defRPr sz="1600" b="1">
+                <a:solidFill>
+                  <a:srgbClr val="FFFFFF"/>
+                </a:solidFill>
+              </a:defRPr>
+            </a:pPr>
+            <a:r>
+              <a:t>15% of Global GDP Vulnerable to Insider DBA Access</a:t>
+            </a:r>
+          </a:p>
+          <a:p>
+            <a:br/>
             <a:pPr>
               <a:defRPr sz="1400">
                 <a:solidFill>
-                  <a:srgbClr val="FFFFFF"/>
+                  <a:srgbClr val="94A3B8"/>
                 </a:solidFill>
               </a:defRPr>
             </a:pPr>
             <a:r>
-              <a:t>• Root Admin God-Mode (Unencrypted bid peek)</a:t>
-            </a:r>
-          </a:p>
-          <a:p>
-            <a:pPr>
-              <a:defRPr sz="1400">
-                <a:solidFill>
-                  <a:srgbClr val="FFFFFF"/>
-                </a:solidFill>
-              </a:defRPr>
-            </a:pPr>
-            <a:r>
-              <a:t>• Retroactive Backdating (MySQL timestamp rewrites)</a:t>
-            </a:r>
-          </a:p>
-          <a:p>
-            <a:pPr>
-              <a:defRPr sz="1400">
-                <a:solidFill>
-                  <a:srgbClr val="FFFFFF"/>
-                </a:solidFill>
-              </a:defRPr>
-            </a:pPr>
-            <a:r>
-              <a:t>• Score Collusion (Quiet score inflation behind closed doors)</a:t>
-            </a:r>
-          </a:p>
-          <a:p>
-            <a:pPr>
-              <a:defRPr sz="1400">
-                <a:solidFill>
-                  <a:srgbClr val="FFFFFF"/>
-                </a:solidFill>
-              </a:defRPr>
-            </a:pPr>
-            <a:r>
-              <a:t>• Zero Mathematical Proof ('That is what our database recorded')</a:t>
+              <a:t>• Database admins hold MySQL root keys.</a:t>
+            </a:r>
+            <a:br/>
+            <a:r>
+              <a:t>• Late bids quietly backdated before opening.</a:t>
+            </a:r>
+            <a:br/>
+            <a:r>
+              <a:t>• Price peeking leaks competitor bids.</a:t>
             </a:r>
           </a:p>
         </p:txBody>
@@ -4653,8 +4714,8 @@
         </p:nvSpPr>
         <p:spPr>
           <a:xfrm>
-            <a:off x="6492240" y="1920240"/>
-            <a:ext cx="4480560" cy="4023360"/>
+            <a:off x="6492240" y="2011680"/>
+            <a:ext cx="4480560" cy="3840480"/>
           </a:xfrm>
           <a:prstGeom prst="rect">
             <a:avLst/>
@@ -4668,62 +4729,47 @@
           <a:lstStyle/>
           <a:p>
             <a:pPr>
-              <a:defRPr sz="2000" b="1">
+              <a:defRPr sz="3600" b="1">
                 <a:solidFill>
                   <a:srgbClr val="06B6D4"/>
                 </a:solidFill>
               </a:defRPr>
             </a:pPr>
             <a:r>
-              <a:t>✔  BidTrace on Solana Anchor</a:t>
-            </a:r>
-          </a:p>
-          <a:p>
+              <a:t>Zero Mathematical Proof</a:t>
+            </a:r>
+          </a:p>
+          <a:p>
+            <a:pPr>
+              <a:defRPr sz="1600" b="1">
+                <a:solidFill>
+                  <a:srgbClr val="FFFFFF"/>
+                </a:solidFill>
+              </a:defRPr>
+            </a:pPr>
+            <a:r>
+              <a:t>Centralized Custody Relies on Blind Human Trust</a:t>
+            </a:r>
+          </a:p>
+          <a:p>
+            <a:br/>
             <a:pPr>
               <a:defRPr sz="1400">
                 <a:solidFill>
-                  <a:srgbClr val="06B6D4"/>
+                  <a:srgbClr val="94A3B8"/>
                 </a:solidFill>
               </a:defRPr>
             </a:pPr>
             <a:r>
-              <a:t>• Consensus Clock Boundary (Slot &gt; deadline = REJECTED)</a:t>
-            </a:r>
-          </a:p>
-          <a:p>
-            <a:pPr>
-              <a:defRPr sz="1400">
-                <a:solidFill>
-                  <a:srgbClr val="06B6D4"/>
-                </a:solidFill>
-              </a:defRPr>
-            </a:pPr>
-            <a:r>
-              <a:t>• Dual-Envelope Sealing (Zero pre-deadline price leakage)</a:t>
-            </a:r>
-          </a:p>
-          <a:p>
-            <a:pPr>
-              <a:defRPr sz="1400">
-                <a:solidFill>
-                  <a:srgbClr val="06B6D4"/>
-                </a:solidFill>
-              </a:defRPr>
-            </a:pPr>
-            <a:r>
-              <a:t>• Olympic Trimmed Mean (On-chain rogue score auto-pruning)</a:t>
-            </a:r>
-          </a:p>
-          <a:p>
-            <a:pPr>
-              <a:defRPr sz="1400">
-                <a:solidFill>
-                  <a:srgbClr val="06B6D4"/>
-                </a:solidFill>
-              </a:defRPr>
-            </a:pPr>
-            <a:r>
-              <a:t>• Air-Gapped Tribunal Verifier (100% offline mathematical proof)</a:t>
+              <a:t>• Server timestamps can be rewritten in seconds.</a:t>
+            </a:r>
+            <a:br/>
+            <a:r>
+              <a:t>• Evaluation scores manipulated behind closed doors.</a:t>
+            </a:r>
+            <a:br/>
+            <a:r>
+              <a:t>• No cryptographic audit trail for the public.</a:t>
             </a:r>
           </a:p>
         </p:txBody>
@@ -4821,19 +4867,19 @@
               </a:defRPr>
             </a:pPr>
             <a:r>
-              <a:t>PROTOCOL ARCHITECTURE</a:t>
+              <a:t>THE HERO MECHANISM</a:t>
             </a:r>
           </a:p>
           <a:p>
             <a:pPr>
-              <a:defRPr sz="3400" b="1">
+              <a:defRPr sz="3200" b="1">
                 <a:solidFill>
                   <a:srgbClr val="FFFFFF"/>
                 </a:solidFill>
               </a:defRPr>
             </a:pPr>
             <a:r>
-              <a:t>Two-Plane Decoupled Architecture</a:t>
+              <a:t>“Chainlink + Sealed Envelopes for Sovereign Capital”</a:t>
             </a:r>
           </a:p>
         </p:txBody>
@@ -4891,8 +4937,8 @@
         </p:nvSpPr>
         <p:spPr>
           <a:xfrm>
-            <a:off x="1097280" y="1920240"/>
-            <a:ext cx="2926080" cy="4023360"/>
+            <a:off x="1097280" y="2011680"/>
+            <a:ext cx="2926080" cy="3840480"/>
           </a:xfrm>
           <a:prstGeom prst="rect">
             <a:avLst/>
@@ -4906,75 +4952,39 @@
           <a:lstStyle/>
           <a:p>
             <a:pPr>
-              <a:defRPr sz="1600" b="1">
+              <a:defRPr sz="1800" b="1">
                 <a:solidFill>
                   <a:srgbClr val="06B6D4"/>
                 </a:solidFill>
               </a:defRPr>
             </a:pPr>
             <a:r>
-              <a:t>1. SEMANTIC PLANE</a:t>
+              <a:t>Dual-Envelope Sealing</a:t>
             </a:r>
           </a:p>
           <a:p>
             <a:pPr>
-              <a:defRPr sz="1200">
+              <a:defRPr sz="1200" b="1">
                 <a:solidFill>
                   <a:srgbClr val="94A3B8"/>
                 </a:solidFill>
               </a:defRPr>
             </a:pPr>
             <a:r>
-              <a:t>Off-Chain Standard</a:t>
-            </a:r>
-          </a:p>
-          <a:p/>
-          <a:p>
+              <a:t>OCDS 1.1 Cryptographic Hash</a:t>
+            </a:r>
+          </a:p>
+          <a:p>
+            <a:br/>
             <a:pPr>
-              <a:defRPr sz="1300">
+              <a:defRPr sz="1400">
                 <a:solidFill>
                   <a:srgbClr val="FFFFFF"/>
                 </a:solidFill>
               </a:defRPr>
             </a:pPr>
             <a:r>
-              <a:t>▪ OCDS 1.1 Compliance (World Bank / UN Standard)</a:t>
-            </a:r>
-          </a:p>
-          <a:p>
-            <a:pPr>
-              <a:defRPr sz="1300">
-                <a:solidFill>
-                  <a:srgbClr val="FFFFFF"/>
-                </a:solidFill>
-              </a:defRPr>
-            </a:pPr>
-            <a:r>
-              <a:t>▪ RFC 8785 (JCS) Deterministic Hashing</a:t>
-            </a:r>
-          </a:p>
-          <a:p>
-            <a:pPr>
-              <a:defRPr sz="1300">
-                <a:solidFill>
-                  <a:srgbClr val="FFFFFF"/>
-                </a:solidFill>
-              </a:defRPr>
-            </a:pPr>
-            <a:r>
-              <a:t>▪ 100% Cross-Language Hash Parity</a:t>
-            </a:r>
-          </a:p>
-          <a:p>
-            <a:pPr>
-              <a:defRPr sz="1300">
-                <a:solidFill>
-                  <a:srgbClr val="FFFFFF"/>
-                </a:solidFill>
-              </a:defRPr>
-            </a:pPr>
-            <a:r>
-              <a:t>▪ Direct ERP Ingestion (SAP &amp; Oracle)</a:t>
+              <a:t>Technical &amp; financial hashes locked via RFC 8785 canonical standard. Zero leakage.</a:t>
             </a:r>
           </a:p>
         </p:txBody>
@@ -5032,8 +5042,8 @@
         </p:nvSpPr>
         <p:spPr>
           <a:xfrm>
-            <a:off x="4617720" y="1920240"/>
-            <a:ext cx="2926080" cy="4023360"/>
+            <a:off x="4617720" y="2011680"/>
+            <a:ext cx="2926080" cy="3840480"/>
           </a:xfrm>
           <a:prstGeom prst="rect">
             <a:avLst/>
@@ -5047,75 +5057,39 @@
           <a:lstStyle/>
           <a:p>
             <a:pPr>
-              <a:defRPr sz="1600" b="1">
+              <a:defRPr sz="1800" b="1">
                 <a:solidFill>
                   <a:srgbClr val="A855F7"/>
                 </a:solidFill>
               </a:defRPr>
             </a:pPr>
             <a:r>
-              <a:t>2. ENFORCEMENT PLANE</a:t>
+              <a:t>Proof of History Clock</a:t>
             </a:r>
           </a:p>
           <a:p>
             <a:pPr>
-              <a:defRPr sz="1200">
+              <a:defRPr sz="1200" b="1">
                 <a:solidFill>
                   <a:srgbClr val="94A3B8"/>
                 </a:solidFill>
               </a:defRPr>
             </a:pPr>
             <a:r>
-              <a:t>Solana Anchor Engine</a:t>
-            </a:r>
-          </a:p>
-          <a:p/>
-          <a:p>
+              <a:t>Consensus Phase Locks</a:t>
+            </a:r>
+          </a:p>
+          <a:p>
+            <a:br/>
             <a:pPr>
-              <a:defRPr sz="1300">
+              <a:defRPr sz="1400">
                 <a:solidFill>
                   <a:srgbClr val="FFFFFF"/>
                 </a:solidFill>
               </a:defRPr>
             </a:pPr>
             <a:r>
-              <a:t>▪ 10 Anchor Rust Instructions Deployed</a:t>
-            </a:r>
-          </a:p>
-          <a:p>
-            <a:pPr>
-              <a:defRPr sz="1300">
-                <a:solidFill>
-                  <a:srgbClr val="FFFFFF"/>
-                </a:solidFill>
-              </a:defRPr>
-            </a:pPr>
-            <a:r>
-              <a:t>▪ Temporal Slot Clock Hardening</a:t>
-            </a:r>
-          </a:p>
-          <a:p>
-            <a:pPr>
-              <a:defRPr sz="1300">
-                <a:solidFill>
-                  <a:srgbClr val="FFFFFF"/>
-                </a:solidFill>
-              </a:defRPr>
-            </a:pPr>
-            <a:r>
-              <a:t>▪ Dual-Envelope PDA State Machine</a:t>
-            </a:r>
-          </a:p>
-          <a:p>
-            <a:pPr>
-              <a:defRPr sz="1300">
-                <a:solidFill>
-                  <a:srgbClr val="FFFFFF"/>
-                </a:solidFill>
-              </a:defRPr>
-            </a:pPr>
-            <a:r>
-              <a:t>▪ Commercial Secrecy Invariant (Locked Forever)</a:t>
+              <a:t>Solana 400ms clock makes post-deadline tampering physically impossible.</a:t>
             </a:r>
           </a:p>
         </p:txBody>
@@ -5173,8 +5147,8 @@
         </p:nvSpPr>
         <p:spPr>
           <a:xfrm>
-            <a:off x="8138159" y="1920240"/>
-            <a:ext cx="2926080" cy="4023360"/>
+            <a:off x="8138159" y="2011680"/>
+            <a:ext cx="2926080" cy="3840480"/>
           </a:xfrm>
           <a:prstGeom prst="rect">
             <a:avLst/>
@@ -5188,75 +5162,39 @@
           <a:lstStyle/>
           <a:p>
             <a:pPr>
-              <a:defRPr sz="1600" b="1">
+              <a:defRPr sz="1800" b="1">
                 <a:solidFill>
                   <a:srgbClr val="10B981"/>
                 </a:solidFill>
               </a:defRPr>
             </a:pPr>
             <a:r>
-              <a:t>3. GATEWAY PLANE</a:t>
+              <a:t>Blinded Outlier Pruning</a:t>
             </a:r>
           </a:p>
           <a:p>
             <a:pPr>
-              <a:defRPr sz="1200">
+              <a:defRPr sz="1200" b="1">
                 <a:solidFill>
                   <a:srgbClr val="94A3B8"/>
                 </a:solidFill>
               </a:defRPr>
             </a:pPr>
             <a:r>
-              <a:t>Zero-Fiat-Gas Relayer</a:t>
-            </a:r>
-          </a:p>
-          <a:p/>
-          <a:p>
+              <a:t>Olympic Trimmed Mean</a:t>
+            </a:r>
+          </a:p>
+          <a:p>
+            <a:br/>
             <a:pPr>
-              <a:defRPr sz="1300">
+              <a:defRPr sz="1400">
                 <a:solidFill>
                   <a:srgbClr val="FFFFFF"/>
                 </a:solidFill>
               </a:defRPr>
             </a:pPr>
             <a:r>
-              <a:t>▪ Zero Crypto Gas for Contractors</a:t>
-            </a:r>
-          </a:p>
-          <a:p>
-            <a:pPr>
-              <a:defRPr sz="1300">
-                <a:solidFill>
-                  <a:srgbClr val="FFFFFF"/>
-                </a:solidFill>
-              </a:defRPr>
-            </a:pPr>
-            <a:r>
-              <a:t>▪ 4 Hybrid Bond Registry Modes</a:t>
-            </a:r>
-          </a:p>
-          <a:p>
-            <a:pPr>
-              <a:defRPr sz="1300">
-                <a:solidFill>
-                  <a:srgbClr val="FFFFFF"/>
-                </a:solidFill>
-              </a:defRPr>
-            </a:pPr>
-            <a:r>
-              <a:t>▪ SWIFT MT760 &amp; TradFi Surety Integration</a:t>
-            </a:r>
-          </a:p>
-          <a:p>
-            <a:pPr>
-              <a:defRPr sz="1300">
-                <a:solidFill>
-                  <a:srgbClr val="FFFFFF"/>
-                </a:solidFill>
-              </a:defRPr>
-            </a:pPr>
-            <a:r>
-              <a:t>▪ Air-Gapped Tribunal Dossier Verifier</a:t>
+              <a:t>On-chain algorithm automatically prunes collusive scores before price unsealing.</a:t>
             </a:r>
           </a:p>
         </p:txBody>
@@ -5349,12 +5287,12 @@
             <a:pPr>
               <a:defRPr sz="1300" b="1">
                 <a:solidFill>
-                  <a:srgbClr val="10B981"/>
+                  <a:srgbClr val="A855F7"/>
                 </a:solidFill>
               </a:defRPr>
             </a:pPr>
             <a:r>
-              <a:t>END-TO-END CRYPTOGRAPHIC PIPELINE</a:t>
+              <a:t>MACRO SHIFT &amp; BOTTOMS-UP OPPORTUNITY</a:t>
             </a:r>
           </a:p>
           <a:p>
@@ -5366,7 +5304,7 @@
               </a:defRPr>
             </a:pPr>
             <a:r>
-              <a:t>The 4-Stage Lifecycle &amp; Tested Adversarial Defenses</a:t>
+              <a:t>From Administrative Paper to Incorruptible Rails</a:t>
             </a:r>
           </a:p>
         </p:txBody>
@@ -5380,7 +5318,7 @@
         <p:spPr>
           <a:xfrm>
             <a:off x="914400" y="1737360"/>
-            <a:ext cx="2468880" cy="1828800"/>
+            <a:ext cx="5120640" cy="4389120"/>
           </a:xfrm>
           <a:prstGeom prst="roundRect">
             <a:avLst/>
@@ -5424,8 +5362,8 @@
         </p:nvSpPr>
         <p:spPr>
           <a:xfrm>
-            <a:off x="1051560" y="1828800"/>
-            <a:ext cx="2194560" cy="1645920"/>
+            <a:off x="1188720" y="2011680"/>
+            <a:ext cx="4572000" cy="3840480"/>
           </a:xfrm>
           <a:prstGeom prst="rect">
             <a:avLst/>
@@ -5439,38 +5377,35 @@
           <a:lstStyle/>
           <a:p>
             <a:pPr>
-              <a:defRPr sz="1100" b="1">
+              <a:defRPr sz="1800" b="1">
                 <a:solidFill>
                   <a:srgbClr val="06B6D4"/>
                 </a:solidFill>
               </a:defRPr>
             </a:pPr>
             <a:r>
-              <a:t>STAGE 1</a:t>
-            </a:r>
-          </a:p>
-          <a:p>
+              <a:t>Macro Trends &amp; The Dream State</a:t>
+            </a:r>
+          </a:p>
+          <a:p>
+            <a:br/>
             <a:pPr>
-              <a:defRPr sz="1600" b="1">
+              <a:defRPr sz="1400">
                 <a:solidFill>
                   <a:srgbClr val="FFFFFF"/>
                 </a:solidFill>
               </a:defRPr>
             </a:pPr>
             <a:r>
-              <a:t>Tender Issued</a:t>
-            </a:r>
-          </a:p>
-          <a:p>
-            <a:pPr>
-              <a:defRPr sz="1100">
-                <a:solidFill>
-                  <a:srgbClr val="94A3B8"/>
-                </a:solidFill>
-              </a:defRPr>
-            </a:pPr>
-            <a:r>
-              <a:t>Canonical OCDS Notice + Slot Cutoff</a:t>
+              <a:t>• World Bank Mandate: Enforces OCDS 1.1 anti-corruption standard across all projects.</a:t>
+            </a:r>
+            <a:br/>
+            <a:r>
+              <a:t>• TradFi On-Chain Shift: Multilateral development bank tenders migrating to Web3 verification.</a:t>
+            </a:r>
+            <a:br/>
+            <a:r>
+              <a:t>• Dream State: Zero kickback windows, instant cryptographic audit proofs, and automated surety release.</a:t>
             </a:r>
           </a:p>
         </p:txBody>
@@ -5483,8 +5418,100 @@
         </p:nvSpPr>
         <p:spPr>
           <a:xfrm>
-            <a:off x="3547872" y="1737360"/>
-            <a:ext cx="2468880" cy="1828800"/>
+            <a:off x="6400800" y="1737360"/>
+            <a:ext cx="4846320" cy="2057400"/>
+          </a:xfrm>
+          <a:prstGeom prst="roundRect">
+            <a:avLst/>
+          </a:prstGeom>
+          <a:solidFill>
+            <a:srgbClr val="0C1C30"/>
+          </a:solidFill>
+          <a:ln w="19050">
+            <a:solidFill>
+              <a:srgbClr val="06B6D4"/>
+            </a:solidFill>
+          </a:ln>
+        </p:spPr>
+        <p:style>
+          <a:lnRef idx="1">
+            <a:schemeClr val="accent1"/>
+          </a:lnRef>
+          <a:fillRef idx="3">
+            <a:schemeClr val="accent1"/>
+          </a:fillRef>
+          <a:effectRef idx="2">
+            <a:schemeClr val="accent1"/>
+          </a:effectRef>
+          <a:fontRef idx="minor">
+            <a:schemeClr val="lt1"/>
+          </a:fontRef>
+        </p:style>
+        <p:txBody>
+          <a:bodyPr rtlCol="0" anchor="ctr"/>
+          <a:lstStyle/>
+          <a:p>
+            <a:pPr algn="ctr"/>
+          </a:p>
+        </p:txBody>
+      </p:sp>
+      <p:sp>
+        <p:nvSpPr>
+          <p:cNvPr id="7" name="TextBox 6"/>
+          <p:cNvSpPr txBox="1"/>
+          <p:nvPr/>
+        </p:nvSpPr>
+        <p:spPr>
+          <a:xfrm>
+            <a:off x="6675120" y="1920240"/>
+            <a:ext cx="4297680" cy="1737360"/>
+          </a:xfrm>
+          <a:prstGeom prst="rect">
+            <a:avLst/>
+          </a:prstGeom>
+          <a:noFill/>
+        </p:spPr>
+        <p:txBody>
+          <a:bodyPr wrap="square">
+            <a:spAutoFit/>
+          </a:bodyPr>
+          <a:lstStyle/>
+          <a:p>
+            <a:pPr>
+              <a:defRPr sz="3000" b="1">
+                <a:solidFill>
+                  <a:srgbClr val="06B6D4"/>
+                </a:solidFill>
+              </a:defRPr>
+            </a:pPr>
+            <a:r>
+              <a:t>$500 Billion SAM</a:t>
+            </a:r>
+          </a:p>
+          <a:p>
+            <a:pPr>
+              <a:defRPr sz="1300">
+                <a:solidFill>
+                  <a:srgbClr val="94A3B8"/>
+                </a:solidFill>
+              </a:defRPr>
+            </a:pPr>
+            <a:r>
+              <a:t>Multilateral Development Bank Tenders (Immediate Beachhead)</a:t>
+            </a:r>
+          </a:p>
+        </p:txBody>
+      </p:sp>
+      <p:sp>
+        <p:nvSpPr>
+          <p:cNvPr id="8" name="Rounded Rectangle 7"/>
+          <p:cNvSpPr/>
+          <p:nvPr/>
+        </p:nvSpPr>
+        <p:spPr>
+          <a:xfrm>
+            <a:off x="6400800" y="4069080"/>
+            <a:ext cx="4846320" cy="2057400"/>
           </a:xfrm>
           <a:prstGeom prst="roundRect">
             <a:avLst/>
@@ -5494,7 +5521,7 @@
           </a:solidFill>
           <a:ln w="19050">
             <a:solidFill>
-              <a:srgbClr val="1E2946"/>
+              <a:srgbClr val="A855F7"/>
             </a:solidFill>
           </a:ln>
         </p:spPr>
@@ -5522,14 +5549,14 @@
       </p:sp>
       <p:sp>
         <p:nvSpPr>
-          <p:cNvPr id="7" name="TextBox 6"/>
+          <p:cNvPr id="9" name="TextBox 8"/>
           <p:cNvSpPr txBox="1"/>
           <p:nvPr/>
         </p:nvSpPr>
         <p:spPr>
           <a:xfrm>
-            <a:off x="3685032" y="1828800"/>
-            <a:ext cx="2194560" cy="1645920"/>
+            <a:off x="6675120" y="4251960"/>
+            <a:ext cx="4297680" cy="1737360"/>
           </a:xfrm>
           <a:prstGeom prst="rect">
             <a:avLst/>
@@ -5543,374 +5570,26 @@
           <a:lstStyle/>
           <a:p>
             <a:pPr>
-              <a:defRPr sz="1100" b="1">
+              <a:defRPr sz="3000" b="1">
                 <a:solidFill>
                   <a:srgbClr val="A855F7"/>
                 </a:solidFill>
               </a:defRPr>
             </a:pPr>
             <a:r>
-              <a:t>STAGE 2</a:t>
-            </a:r>
-          </a:p>
-          <a:p>
-            <a:pPr>
-              <a:defRPr sz="1600" b="1">
-                <a:solidFill>
-                  <a:srgbClr val="FFFFFF"/>
-                </a:solidFill>
-              </a:defRPr>
-            </a:pPr>
-            <a:r>
-              <a:t>Dual-Envelopes</a:t>
-            </a:r>
-          </a:p>
-          <a:p>
-            <a:pPr>
-              <a:defRPr sz="1100">
-                <a:solidFill>
-                  <a:srgbClr val="94A3B8"/>
-                </a:solidFill>
-              </a:defRPr>
-            </a:pPr>
-            <a:r>
-              <a:t>Blinded Technical &amp; Financial Bids</a:t>
-            </a:r>
-          </a:p>
-        </p:txBody>
-      </p:sp>
-      <p:sp>
-        <p:nvSpPr>
-          <p:cNvPr id="8" name="Rounded Rectangle 7"/>
-          <p:cNvSpPr/>
-          <p:nvPr/>
-        </p:nvSpPr>
-        <p:spPr>
-          <a:xfrm>
-            <a:off x="6181344" y="1737360"/>
-            <a:ext cx="2468880" cy="1828800"/>
-          </a:xfrm>
-          <a:prstGeom prst="roundRect">
-            <a:avLst/>
-          </a:prstGeom>
-          <a:solidFill>
-            <a:srgbClr val="12192D"/>
-          </a:solidFill>
-          <a:ln w="19050">
-            <a:solidFill>
-              <a:srgbClr val="1E2946"/>
-            </a:solidFill>
-          </a:ln>
-        </p:spPr>
-        <p:style>
-          <a:lnRef idx="1">
-            <a:schemeClr val="accent1"/>
-          </a:lnRef>
-          <a:fillRef idx="3">
-            <a:schemeClr val="accent1"/>
-          </a:fillRef>
-          <a:effectRef idx="2">
-            <a:schemeClr val="accent1"/>
-          </a:effectRef>
-          <a:fontRef idx="minor">
-            <a:schemeClr val="lt1"/>
-          </a:fontRef>
-        </p:style>
-        <p:txBody>
-          <a:bodyPr rtlCol="0" anchor="ctr"/>
-          <a:lstStyle/>
-          <a:p>
-            <a:pPr algn="ctr"/>
-          </a:p>
-        </p:txBody>
-      </p:sp>
-      <p:sp>
-        <p:nvSpPr>
-          <p:cNvPr id="9" name="TextBox 8"/>
-          <p:cNvSpPr txBox="1"/>
-          <p:nvPr/>
-        </p:nvSpPr>
-        <p:spPr>
-          <a:xfrm>
-            <a:off x="6318504" y="1828800"/>
-            <a:ext cx="2194560" cy="1645920"/>
-          </a:xfrm>
-          <a:prstGeom prst="rect">
-            <a:avLst/>
-          </a:prstGeom>
-          <a:noFill/>
-        </p:spPr>
-        <p:txBody>
-          <a:bodyPr wrap="square">
-            <a:spAutoFit/>
-          </a:bodyPr>
-          <a:lstStyle/>
-          <a:p>
-            <a:pPr>
-              <a:defRPr sz="1100" b="1">
-                <a:solidFill>
-                  <a:srgbClr val="F59E0B"/>
-                </a:solidFill>
-              </a:defRPr>
-            </a:pPr>
-            <a:r>
-              <a:t>STAGE 3</a:t>
-            </a:r>
-          </a:p>
-          <a:p>
-            <a:pPr>
-              <a:defRPr sz="1600" b="1">
-                <a:solidFill>
-                  <a:srgbClr val="FFFFFF"/>
-                </a:solidFill>
-              </a:defRPr>
-            </a:pPr>
-            <a:r>
-              <a:t>Blinded Scoring</a:t>
-            </a:r>
-          </a:p>
-          <a:p>
-            <a:pPr>
-              <a:defRPr sz="1100">
-                <a:solidFill>
-                  <a:srgbClr val="94A3B8"/>
-                </a:solidFill>
-              </a:defRPr>
-            </a:pPr>
-            <a:r>
-              <a:t>Olympic Trimmed Mean Outlier Pruning</a:t>
-            </a:r>
-          </a:p>
-        </p:txBody>
-      </p:sp>
-      <p:sp>
-        <p:nvSpPr>
-          <p:cNvPr id="10" name="Rounded Rectangle 9"/>
-          <p:cNvSpPr/>
-          <p:nvPr/>
-        </p:nvSpPr>
-        <p:spPr>
-          <a:xfrm>
-            <a:off x="8814816" y="1737360"/>
-            <a:ext cx="2468880" cy="1828800"/>
-          </a:xfrm>
-          <a:prstGeom prst="roundRect">
-            <a:avLst/>
-          </a:prstGeom>
-          <a:solidFill>
-            <a:srgbClr val="12192D"/>
-          </a:solidFill>
-          <a:ln w="19050">
-            <a:solidFill>
-              <a:srgbClr val="1E2946"/>
-            </a:solidFill>
-          </a:ln>
-        </p:spPr>
-        <p:style>
-          <a:lnRef idx="1">
-            <a:schemeClr val="accent1"/>
-          </a:lnRef>
-          <a:fillRef idx="3">
-            <a:schemeClr val="accent1"/>
-          </a:fillRef>
-          <a:effectRef idx="2">
-            <a:schemeClr val="accent1"/>
-          </a:effectRef>
-          <a:fontRef idx="minor">
-            <a:schemeClr val="lt1"/>
-          </a:fontRef>
-        </p:style>
-        <p:txBody>
-          <a:bodyPr rtlCol="0" anchor="ctr"/>
-          <a:lstStyle/>
-          <a:p>
-            <a:pPr algn="ctr"/>
-          </a:p>
-        </p:txBody>
-      </p:sp>
-      <p:sp>
-        <p:nvSpPr>
-          <p:cNvPr id="11" name="TextBox 10"/>
-          <p:cNvSpPr txBox="1"/>
-          <p:nvPr/>
-        </p:nvSpPr>
-        <p:spPr>
-          <a:xfrm>
-            <a:off x="8951976" y="1828800"/>
-            <a:ext cx="2194560" cy="1645920"/>
-          </a:xfrm>
-          <a:prstGeom prst="rect">
-            <a:avLst/>
-          </a:prstGeom>
-          <a:noFill/>
-        </p:spPr>
-        <p:txBody>
-          <a:bodyPr wrap="square">
-            <a:spAutoFit/>
-          </a:bodyPr>
-          <a:lstStyle/>
-          <a:p>
-            <a:pPr>
-              <a:defRPr sz="1100" b="1">
-                <a:solidFill>
-                  <a:srgbClr val="10B981"/>
-                </a:solidFill>
-              </a:defRPr>
-            </a:pPr>
-            <a:r>
-              <a:t>STAGE 4</a:t>
-            </a:r>
-          </a:p>
-          <a:p>
-            <a:pPr>
-              <a:defRPr sz="1600" b="1">
-                <a:solidFill>
-                  <a:srgbClr val="FFFFFF"/>
-                </a:solidFill>
-              </a:defRPr>
-            </a:pPr>
-            <a:r>
-              <a:t>QCBS Award</a:t>
-            </a:r>
-          </a:p>
-          <a:p>
-            <a:pPr>
-              <a:defRPr sz="1100">
-                <a:solidFill>
-                  <a:srgbClr val="94A3B8"/>
-                </a:solidFill>
-              </a:defRPr>
-            </a:pPr>
-            <a:r>
-              <a:t>Qualified Unseal &amp; Deterministic Winner</a:t>
-            </a:r>
-          </a:p>
-        </p:txBody>
-      </p:sp>
-      <p:sp>
-        <p:nvSpPr>
-          <p:cNvPr id="12" name="Rounded Rectangle 11"/>
-          <p:cNvSpPr/>
-          <p:nvPr/>
-        </p:nvSpPr>
-        <p:spPr>
-          <a:xfrm>
-            <a:off x="914400" y="3794760"/>
-            <a:ext cx="10360152" cy="2514600"/>
-          </a:xfrm>
-          <a:prstGeom prst="roundRect">
-            <a:avLst/>
-          </a:prstGeom>
-          <a:solidFill>
-            <a:srgbClr val="12192D"/>
-          </a:solidFill>
-          <a:ln w="19050">
-            <a:solidFill>
-              <a:srgbClr val="1E2946"/>
-            </a:solidFill>
-          </a:ln>
-        </p:spPr>
-        <p:style>
-          <a:lnRef idx="1">
-            <a:schemeClr val="accent1"/>
-          </a:lnRef>
-          <a:fillRef idx="3">
-            <a:schemeClr val="accent1"/>
-          </a:fillRef>
-          <a:effectRef idx="2">
-            <a:schemeClr val="accent1"/>
-          </a:effectRef>
-          <a:fontRef idx="minor">
-            <a:schemeClr val="lt1"/>
-          </a:fontRef>
-        </p:style>
-        <p:txBody>
-          <a:bodyPr rtlCol="0" anchor="ctr"/>
-          <a:lstStyle/>
-          <a:p>
-            <a:pPr algn="ctr"/>
-          </a:p>
-        </p:txBody>
-      </p:sp>
-      <p:sp>
-        <p:nvSpPr>
-          <p:cNvPr id="13" name="TextBox 12"/>
-          <p:cNvSpPr txBox="1"/>
-          <p:nvPr/>
-        </p:nvSpPr>
-        <p:spPr>
-          <a:xfrm>
-            <a:off x="1097280" y="3886200"/>
-            <a:ext cx="9966960" cy="2331720"/>
-          </a:xfrm>
-          <a:prstGeom prst="rect">
-            <a:avLst/>
-          </a:prstGeom>
-          <a:noFill/>
-        </p:spPr>
-        <p:txBody>
-          <a:bodyPr wrap="square">
-            <a:spAutoFit/>
-          </a:bodyPr>
-          <a:lstStyle/>
-          <a:p>
-            <a:pPr>
-              <a:defRPr sz="1300" b="1">
-                <a:solidFill>
-                  <a:srgbClr val="F43F5E"/>
-                </a:solidFill>
-              </a:defRPr>
-            </a:pPr>
-            <a:r>
-              <a:t>TESTED ADVERSARIAL ATTACKS REJECTED ON SOLANA DEVNET</a:t>
+              <a:t>$13.0 Trillion TAM</a:t>
             </a:r>
           </a:p>
           <a:p>
             <a:pPr>
               <a:defRPr sz="1300">
                 <a:solidFill>
-                  <a:srgbClr val="FFFFFF"/>
+                  <a:srgbClr val="94A3B8"/>
                 </a:solidFill>
               </a:defRPr>
             </a:pPr>
             <a:r>
-              <a:t>🛑  Late Bidder Injected  ➔  Anchor Error: SubmissionDeadlineExceeded (0x1773)</a:t>
-            </a:r>
-          </a:p>
-          <a:p>
-            <a:pPr>
-              <a:defRPr sz="1300">
-                <a:solidFill>
-                  <a:srgbClr val="FFFFFF"/>
-                </a:solidFill>
-              </a:defRPr>
-            </a:pPr>
-            <a:r>
-              <a:t>🛑  Price Tampering (-$500k)  ➔  Anchor Error: InvalidRevealHash (0x1775)</a:t>
-            </a:r>
-          </a:p>
-          <a:p>
-            <a:pPr>
-              <a:defRPr sz="1300">
-                <a:solidFill>
-                  <a:srgbClr val="FFFFFF"/>
-                </a:solidFill>
-              </a:defRPr>
-            </a:pPr>
-            <a:r>
-              <a:t>🛑  Rogue Judge 98% Score  ➔  On-Chain Filter: OlympicTrimmedMeanPruned</a:t>
-            </a:r>
-          </a:p>
-          <a:p>
-            <a:pPr>
-              <a:defRPr sz="1300">
-                <a:solidFill>
-                  <a:srgbClr val="FFFFFF"/>
-                </a:solidFill>
-              </a:defRPr>
-            </a:pPr>
-            <a:r>
-              <a:t>🛑  Trade Secret Leak  ➔  Anchor Error: CommercialSecrecyLock</a:t>
+              <a:t>Total Annual Global Public Infrastructure Procurement</a:t>
             </a:r>
           </a:p>
         </p:txBody>
@@ -6003,12 +5682,12 @@
             <a:pPr>
               <a:defRPr sz="1300" b="1">
                 <a:solidFill>
-                  <a:srgbClr val="A855F7"/>
+                  <a:srgbClr val="10B981"/>
                 </a:solidFill>
               </a:defRPr>
             </a:pPr>
             <a:r>
-              <a:t>THE SOLANA ADVANTAGE</a:t>
+              <a:t>TRACTION &amp; VERIFIED EXECUTION</a:t>
             </a:r>
           </a:p>
           <a:p>
@@ -6020,7 +5699,7 @@
               </a:defRPr>
             </a:pPr>
             <a:r>
-              <a:t>Why Solana is Structurally Required</a:t>
+              <a:t>“This Is Already Working Live on Solana”</a:t>
             </a:r>
           </a:p>
         </p:txBody>
@@ -6034,7 +5713,7 @@
         <p:spPr>
           <a:xfrm>
             <a:off x="914400" y="1737360"/>
-            <a:ext cx="3291840" cy="4389120"/>
+            <a:ext cx="2468880" cy="4389120"/>
           </a:xfrm>
           <a:prstGeom prst="roundRect">
             <a:avLst/>
@@ -6078,8 +5757,8 @@
         </p:nvSpPr>
         <p:spPr>
           <a:xfrm>
-            <a:off x="1097280" y="1920240"/>
-            <a:ext cx="2926080" cy="4023360"/>
+            <a:off x="1051560" y="2011680"/>
+            <a:ext cx="2194560" cy="3840480"/>
           </a:xfrm>
           <a:prstGeom prst="rect">
             <a:avLst/>
@@ -6093,63 +5772,39 @@
           <a:lstStyle/>
           <a:p>
             <a:pPr>
-              <a:defRPr sz="1700" b="1">
+              <a:defRPr sz="3600" b="1">
                 <a:solidFill>
                   <a:srgbClr val="06B6D4"/>
                 </a:solidFill>
               </a:defRPr>
             </a:pPr>
             <a:r>
-              <a:t>400ms Proof of History</a:t>
+              <a:t>10</a:t>
             </a:r>
           </a:p>
           <a:p>
             <a:pPr>
-              <a:defRPr sz="1200">
-                <a:solidFill>
-                  <a:srgbClr val="94A3B8"/>
+              <a:defRPr sz="1600" b="1">
+                <a:solidFill>
+                  <a:srgbClr val="FFFFFF"/>
                 </a:solidFill>
               </a:defRPr>
             </a:pPr>
             <a:r>
-              <a:t>Temporal Finality</a:t>
-            </a:r>
-          </a:p>
-          <a:p/>
-          <a:p>
+              <a:t>Anchor Instructions</a:t>
+            </a:r>
+          </a:p>
+          <a:p>
+            <a:br/>
             <a:pPr>
               <a:defRPr sz="1300">
                 <a:solidFill>
-                  <a:srgbClr val="FFFFFF"/>
+                  <a:srgbClr val="94A3B8"/>
                 </a:solidFill>
               </a:defRPr>
             </a:pPr>
             <a:r>
-              <a:t>▪ Sub-second statutory cutoff precision</a:t>
-            </a:r>
-          </a:p>
-          <a:p>
-            <a:pPr>
-              <a:defRPr sz="1300">
-                <a:solidFill>
-                  <a:srgbClr val="FFFFFF"/>
-                </a:solidFill>
-              </a:defRPr>
-            </a:pPr>
-            <a:r>
-              <a:t>▪ Zero retroactive block jitter or timestamp edits</a:t>
-            </a:r>
-          </a:p>
-          <a:p>
-            <a:pPr>
-              <a:defRPr sz="1300">
-                <a:solidFill>
-                  <a:srgbClr val="FFFFFF"/>
-                </a:solidFill>
-              </a:defRPr>
-            </a:pPr>
-            <a:r>
-              <a:t>▪ Mathematical guarantee over historical slots</a:t>
+              <a:t>Deployed on Solana Devnet (x3iSm5BC...ESjZ)</a:t>
             </a:r>
           </a:p>
         </p:txBody>
@@ -6162,8 +5817,8 @@
         </p:nvSpPr>
         <p:spPr>
           <a:xfrm>
-            <a:off x="4434840" y="1737360"/>
-            <a:ext cx="3291840" cy="4389120"/>
+            <a:off x="3547872" y="1737360"/>
+            <a:ext cx="2468880" cy="4389120"/>
           </a:xfrm>
           <a:prstGeom prst="roundRect">
             <a:avLst/>
@@ -6207,8 +5862,8 @@
         </p:nvSpPr>
         <p:spPr>
           <a:xfrm>
-            <a:off x="4617720" y="1920240"/>
-            <a:ext cx="2926080" cy="4023360"/>
+            <a:off x="3685032" y="2011680"/>
+            <a:ext cx="2194560" cy="3840480"/>
           </a:xfrm>
           <a:prstGeom prst="rect">
             <a:avLst/>
@@ -6222,63 +5877,39 @@
           <a:lstStyle/>
           <a:p>
             <a:pPr>
-              <a:defRPr sz="1700" b="1">
-                <a:solidFill>
-                  <a:srgbClr val="A855F7"/>
+              <a:defRPr sz="3600" b="1">
+                <a:solidFill>
+                  <a:srgbClr val="10B981"/>
                 </a:solidFill>
               </a:defRPr>
             </a:pPr>
             <a:r>
-              <a:t>Micro-Cent Network Fees</a:t>
+              <a:t>78 / 78</a:t>
             </a:r>
           </a:p>
           <a:p>
             <a:pPr>
-              <a:defRPr sz="1200">
-                <a:solidFill>
-                  <a:srgbClr val="94A3B8"/>
+              <a:defRPr sz="1600" b="1">
+                <a:solidFill>
+                  <a:srgbClr val="FFFFFF"/>
                 </a:solidFill>
               </a:defRPr>
             </a:pPr>
             <a:r>
-              <a:t>Granular State Updates</a:t>
-            </a:r>
-          </a:p>
-          <a:p/>
-          <a:p>
+              <a:t>Passing Unit Tests</a:t>
+            </a:r>
+          </a:p>
+          <a:p>
+            <a:br/>
             <a:pPr>
               <a:defRPr sz="1300">
                 <a:solidFill>
-                  <a:srgbClr val="FFFFFF"/>
+                  <a:srgbClr val="94A3B8"/>
                 </a:solidFill>
               </a:defRPr>
             </a:pPr>
             <a:r>
-              <a:t>▪ 5-stage multi-envelope state transitions</a:t>
-            </a:r>
-          </a:p>
-          <a:p>
-            <a:pPr>
-              <a:defRPr sz="1300">
-                <a:solidFill>
-                  <a:srgbClr val="FFFFFF"/>
-                </a:solidFill>
-              </a:defRPr>
-            </a:pPr>
-            <a:r>
-              <a:t>▪ 5 evaluator score commits per tender</a:t>
-            </a:r>
-          </a:p>
-          <a:p>
-            <a:pPr>
-              <a:defRPr sz="1300">
-                <a:solidFill>
-                  <a:srgbClr val="FFFFFF"/>
-                </a:solidFill>
-              </a:defRPr>
-            </a:pPr>
-            <a:r>
-              <a:t>▪ &lt; $0.01 total gas per entire tender lifecycle</a:t>
+              <a:t>100% Cross-Language RFC 8785 Parity</a:t>
             </a:r>
           </a:p>
         </p:txBody>
@@ -6291,8 +5922,8 @@
         </p:nvSpPr>
         <p:spPr>
           <a:xfrm>
-            <a:off x="7955279" y="1737360"/>
-            <a:ext cx="3291840" cy="4389120"/>
+            <a:off x="6181344" y="1737360"/>
+            <a:ext cx="2468880" cy="4389120"/>
           </a:xfrm>
           <a:prstGeom prst="roundRect">
             <a:avLst/>
@@ -6336,8 +5967,8 @@
         </p:nvSpPr>
         <p:spPr>
           <a:xfrm>
-            <a:off x="8138159" y="1920240"/>
-            <a:ext cx="2926080" cy="4023360"/>
+            <a:off x="6318504" y="2011680"/>
+            <a:ext cx="2194560" cy="3840480"/>
           </a:xfrm>
           <a:prstGeom prst="rect">
             <a:avLst/>
@@ -6351,63 +5982,144 @@
           <a:lstStyle/>
           <a:p>
             <a:pPr>
-              <a:defRPr sz="1700" b="1">
-                <a:solidFill>
-                  <a:srgbClr val="10B981"/>
+              <a:defRPr sz="3600" b="1">
+                <a:solidFill>
+                  <a:srgbClr val="F43F5E"/>
                 </a:solidFill>
               </a:defRPr>
             </a:pPr>
             <a:r>
-              <a:t>Zero-Gas Gateway</a:t>
+              <a:t>1-Click</a:t>
             </a:r>
           </a:p>
           <a:p>
             <a:pPr>
-              <a:defRPr sz="1200">
-                <a:solidFill>
-                  <a:srgbClr val="94A3B8"/>
+              <a:defRPr sz="1600" b="1">
+                <a:solidFill>
+                  <a:srgbClr val="FFFFFF"/>
                 </a:solidFill>
               </a:defRPr>
             </a:pPr>
             <a:r>
-              <a:t>Frictionless TradFi Adoption</a:t>
-            </a:r>
-          </a:p>
-          <a:p/>
-          <a:p>
+              <a:t>Attack Simulator</a:t>
+            </a:r>
+          </a:p>
+          <a:p>
+            <a:br/>
             <a:pPr>
               <a:defRPr sz="1300">
                 <a:solidFill>
+                  <a:srgbClr val="94A3B8"/>
+                </a:solidFill>
+              </a:defRPr>
+            </a:pPr>
+            <a:r>
+              <a:t>Live On-Chain Exploits Blocked in Real-Time</a:t>
+            </a:r>
+          </a:p>
+        </p:txBody>
+      </p:sp>
+      <p:sp>
+        <p:nvSpPr>
+          <p:cNvPr id="10" name="Rounded Rectangle 9"/>
+          <p:cNvSpPr/>
+          <p:nvPr/>
+        </p:nvSpPr>
+        <p:spPr>
+          <a:xfrm>
+            <a:off x="8814816" y="1737360"/>
+            <a:ext cx="2468880" cy="4389120"/>
+          </a:xfrm>
+          <a:prstGeom prst="roundRect">
+            <a:avLst/>
+          </a:prstGeom>
+          <a:solidFill>
+            <a:srgbClr val="12192D"/>
+          </a:solidFill>
+          <a:ln w="19050">
+            <a:solidFill>
+              <a:srgbClr val="1E2946"/>
+            </a:solidFill>
+          </a:ln>
+        </p:spPr>
+        <p:style>
+          <a:lnRef idx="1">
+            <a:schemeClr val="accent1"/>
+          </a:lnRef>
+          <a:fillRef idx="3">
+            <a:schemeClr val="accent1"/>
+          </a:fillRef>
+          <a:effectRef idx="2">
+            <a:schemeClr val="accent1"/>
+          </a:effectRef>
+          <a:fontRef idx="minor">
+            <a:schemeClr val="lt1"/>
+          </a:fontRef>
+        </p:style>
+        <p:txBody>
+          <a:bodyPr rtlCol="0" anchor="ctr"/>
+          <a:lstStyle/>
+          <a:p>
+            <a:pPr algn="ctr"/>
+          </a:p>
+        </p:txBody>
+      </p:sp>
+      <p:sp>
+        <p:nvSpPr>
+          <p:cNvPr id="11" name="TextBox 10"/>
+          <p:cNvSpPr txBox="1"/>
+          <p:nvPr/>
+        </p:nvSpPr>
+        <p:spPr>
+          <a:xfrm>
+            <a:off x="8951976" y="2011680"/>
+            <a:ext cx="2194560" cy="3840480"/>
+          </a:xfrm>
+          <a:prstGeom prst="rect">
+            <a:avLst/>
+          </a:prstGeom>
+          <a:noFill/>
+        </p:spPr>
+        <p:txBody>
+          <a:bodyPr wrap="square">
+            <a:spAutoFit/>
+          </a:bodyPr>
+          <a:lstStyle/>
+          <a:p>
+            <a:pPr>
+              <a:defRPr sz="3600" b="1">
+                <a:solidFill>
+                  <a:srgbClr val="A855F7"/>
+                </a:solidFill>
+              </a:defRPr>
+            </a:pPr>
+            <a:r>
+              <a:t>0 Gas</a:t>
+            </a:r>
+          </a:p>
+          <a:p>
+            <a:pPr>
+              <a:defRPr sz="1600" b="1">
+                <a:solidFill>
                   <a:srgbClr val="FFFFFF"/>
                 </a:solidFill>
               </a:defRPr>
             </a:pPr>
             <a:r>
-              <a:t>▪ Zero crypto balance required for contractors</a:t>
-            </a:r>
-          </a:p>
-          <a:p>
+              <a:t>Relayer Protocol</a:t>
+            </a:r>
+          </a:p>
+          <a:p>
+            <a:br/>
             <a:pPr>
               <a:defRPr sz="1300">
                 <a:solidFill>
-                  <a:srgbClr val="FFFFFF"/>
+                  <a:srgbClr val="94A3B8"/>
                 </a:solidFill>
               </a:defRPr>
             </a:pPr>
             <a:r>
-              <a:t>▪ Sponsored relayer pays all network gas</a:t>
-            </a:r>
-          </a:p>
-          <a:p>
-            <a:pPr>
-              <a:defRPr sz="1300">
-                <a:solidFill>
-                  <a:srgbClr val="FFFFFF"/>
-                </a:solidFill>
-              </a:defRPr>
-            </a:pPr>
-            <a:r>
-              <a:t>▪ 100% compliant with sovereign treasury laws</a:t>
+              <a:t>Live at bidtrace.net with Zero Crypto Friction</a:t>
             </a:r>
           </a:p>
         </p:txBody>
@@ -6505,7 +6217,7 @@
               </a:defRPr>
             </a:pPr>
             <a:r>
-              <a:t>VERIFIED EXECUTION</a:t>
+              <a:t>NETWORK EFFECTS &amp; SUSTAINABLE REVENUE</a:t>
             </a:r>
           </a:p>
           <a:p>
@@ -6517,7 +6229,7 @@
               </a:defRPr>
             </a:pPr>
             <a:r>
-              <a:t>Shipped, Tested, and Verified on Solana Devnet</a:t>
+              <a:t>“Why This Keeps Growing: The Relayer Moat”</a:t>
             </a:r>
           </a:p>
         </p:txBody>
@@ -6531,7 +6243,319 @@
         <p:spPr>
           <a:xfrm>
             <a:off x="914400" y="1737360"/>
-            <a:ext cx="2468880" cy="1920240"/>
+            <a:ext cx="4937760" cy="4389120"/>
+          </a:xfrm>
+          <a:prstGeom prst="roundRect">
+            <a:avLst/>
+          </a:prstGeom>
+          <a:solidFill>
+            <a:srgbClr val="12192D"/>
+          </a:solidFill>
+          <a:ln w="19050">
+            <a:solidFill>
+              <a:srgbClr val="06B6D4"/>
+            </a:solidFill>
+          </a:ln>
+        </p:spPr>
+        <p:style>
+          <a:lnRef idx="1">
+            <a:schemeClr val="accent1"/>
+          </a:lnRef>
+          <a:fillRef idx="3">
+            <a:schemeClr val="accent1"/>
+          </a:fillRef>
+          <a:effectRef idx="2">
+            <a:schemeClr val="accent1"/>
+          </a:effectRef>
+          <a:fontRef idx="minor">
+            <a:schemeClr val="lt1"/>
+          </a:fontRef>
+        </p:style>
+        <p:txBody>
+          <a:bodyPr rtlCol="0" anchor="ctr"/>
+          <a:lstStyle/>
+          <a:p>
+            <a:pPr algn="ctr"/>
+          </a:p>
+        </p:txBody>
+      </p:sp>
+      <p:sp>
+        <p:nvSpPr>
+          <p:cNvPr id="5" name="TextBox 4"/>
+          <p:cNvSpPr txBox="1"/>
+          <p:nvPr/>
+        </p:nvSpPr>
+        <p:spPr>
+          <a:xfrm>
+            <a:off x="1188720" y="2011680"/>
+            <a:ext cx="4389120" cy="3840480"/>
+          </a:xfrm>
+          <a:prstGeom prst="rect">
+            <a:avLst/>
+          </a:prstGeom>
+          <a:noFill/>
+        </p:spPr>
+        <p:txBody>
+          <a:bodyPr wrap="square">
+            <a:spAutoFit/>
+          </a:bodyPr>
+          <a:lstStyle/>
+          <a:p>
+            <a:pPr>
+              <a:defRPr sz="2000" b="1">
+                <a:solidFill>
+                  <a:srgbClr val="06B6D4"/>
+                </a:solidFill>
+              </a:defRPr>
+            </a:pPr>
+            <a:r>
+              <a:t>Monetization Streams</a:t>
+            </a:r>
+          </a:p>
+          <a:p>
+            <a:br/>
+            <a:pPr>
+              <a:defRPr sz="1400">
+                <a:solidFill>
+                  <a:srgbClr val="FFFFFF"/>
+                </a:solidFill>
+              </a:defRPr>
+            </a:pPr>
+            <a:r>
+              <a:t>• 0.05% Protocol Fee: Settled contract volume ($250M ARR at 1% market penetration).</a:t>
+            </a:r>
+            <a:br/>
+            <a:r>
+              <a:t>• Surety Underwriting API: Verification fees paid by commercial surety bond providers.</a:t>
+            </a:r>
+            <a:br/>
+            <a:r>
+              <a:t>• Zero Crypto Gas: Relayer eliminates balance friction for enterprise bidders.</a:t>
+            </a:r>
+          </a:p>
+        </p:txBody>
+      </p:sp>
+      <p:sp>
+        <p:nvSpPr>
+          <p:cNvPr id="6" name="Rounded Rectangle 5"/>
+          <p:cNvSpPr/>
+          <p:nvPr/>
+        </p:nvSpPr>
+        <p:spPr>
+          <a:xfrm>
+            <a:off x="6217920" y="1737360"/>
+            <a:ext cx="5029200" cy="4389120"/>
+          </a:xfrm>
+          <a:prstGeom prst="roundRect">
+            <a:avLst/>
+          </a:prstGeom>
+          <a:solidFill>
+            <a:srgbClr val="0C1C30"/>
+          </a:solidFill>
+          <a:ln w="19050">
+            <a:solidFill>
+              <a:srgbClr val="A855F7"/>
+            </a:solidFill>
+          </a:ln>
+        </p:spPr>
+        <p:style>
+          <a:lnRef idx="1">
+            <a:schemeClr val="accent1"/>
+          </a:lnRef>
+          <a:fillRef idx="3">
+            <a:schemeClr val="accent1"/>
+          </a:fillRef>
+          <a:effectRef idx="2">
+            <a:schemeClr val="accent1"/>
+          </a:effectRef>
+          <a:fontRef idx="minor">
+            <a:schemeClr val="lt1"/>
+          </a:fontRef>
+        </p:style>
+        <p:txBody>
+          <a:bodyPr rtlCol="0" anchor="ctr"/>
+          <a:lstStyle/>
+          <a:p>
+            <a:pPr algn="ctr"/>
+          </a:p>
+        </p:txBody>
+      </p:sp>
+      <p:sp>
+        <p:nvSpPr>
+          <p:cNvPr id="7" name="TextBox 6"/>
+          <p:cNvSpPr txBox="1"/>
+          <p:nvPr/>
+        </p:nvSpPr>
+        <p:spPr>
+          <a:xfrm>
+            <a:off x="6492240" y="2011680"/>
+            <a:ext cx="4480560" cy="3840480"/>
+          </a:xfrm>
+          <a:prstGeom prst="rect">
+            <a:avLst/>
+          </a:prstGeom>
+          <a:noFill/>
+        </p:spPr>
+        <p:txBody>
+          <a:bodyPr wrap="square">
+            <a:spAutoFit/>
+          </a:bodyPr>
+          <a:lstStyle/>
+          <a:p>
+            <a:pPr>
+              <a:defRPr sz="2000" b="1">
+                <a:solidFill>
+                  <a:srgbClr val="A855F7"/>
+                </a:solidFill>
+              </a:defRPr>
+            </a:pPr>
+            <a:r>
+              <a:t>Network Effects &amp; Moat</a:t>
+            </a:r>
+          </a:p>
+          <a:p>
+            <a:br/>
+            <a:pPr>
+              <a:defRPr sz="1400">
+                <a:solidFill>
+                  <a:srgbClr val="FFFFFF"/>
+                </a:solidFill>
+              </a:defRPr>
+            </a:pPr>
+            <a:r>
+              <a:t>• Municipal Onboarding Flywheel: Each city onboarded locks regional contractors into the BidTrace relayer.</a:t>
+            </a:r>
+            <a:br/>
+            <a:r>
+              <a:t>• Relayer Sticky Moat: Enterprise API contracts ensure sustainable long-term cash flow.</a:t>
+            </a:r>
+            <a:br/>
+            <a:r>
+              <a:t>• Standards Lock-In: Becomes the mandatory OCDS 1.1 compliance layer.</a:t>
+            </a:r>
+          </a:p>
+        </p:txBody>
+      </p:sp>
+    </p:spTree>
+  </p:cSld>
+  <p:clrMapOvr>
+    <a:masterClrMapping/>
+  </p:clrMapOvr>
+</p:sld>
+</file>
+
+<file path=ppt/slides/slide7.xml><?xml version="1.0" encoding="utf-8"?>
+<p:sld xmlns:a="http://schemas.openxmlformats.org/drawingml/2006/main" xmlns:p="http://schemas.openxmlformats.org/presentationml/2006/main" xmlns:r="http://schemas.openxmlformats.org/officeDocument/2006/relationships">
+  <p:cSld>
+    <p:spTree>
+      <p:nvGrpSpPr>
+        <p:cNvPr id="1" name=""/>
+        <p:cNvGrpSpPr/>
+        <p:nvPr/>
+      </p:nvGrpSpPr>
+      <p:grpSpPr/>
+      <p:sp>
+        <p:nvSpPr>
+          <p:cNvPr id="2" name="Rectangle 1"/>
+          <p:cNvSpPr/>
+          <p:nvPr/>
+        </p:nvSpPr>
+        <p:spPr>
+          <a:xfrm>
+            <a:off x="0" y="0"/>
+            <a:ext cx="12191695" cy="6858000"/>
+          </a:xfrm>
+          <a:prstGeom prst="rect">
+            <a:avLst/>
+          </a:prstGeom>
+          <a:solidFill>
+            <a:srgbClr val="0A0F1D"/>
+          </a:solidFill>
+          <a:ln>
+            <a:solidFill>
+              <a:srgbClr val="0A0F1D"/>
+            </a:solidFill>
+          </a:ln>
+        </p:spPr>
+        <p:style>
+          <a:lnRef idx="1">
+            <a:schemeClr val="accent1"/>
+          </a:lnRef>
+          <a:fillRef idx="3">
+            <a:schemeClr val="accent1"/>
+          </a:fillRef>
+          <a:effectRef idx="2">
+            <a:schemeClr val="accent1"/>
+          </a:effectRef>
+          <a:fontRef idx="minor">
+            <a:schemeClr val="lt1"/>
+          </a:fontRef>
+        </p:style>
+        <p:txBody>
+          <a:bodyPr rtlCol="0" anchor="ctr"/>
+          <a:lstStyle/>
+          <a:p>
+            <a:pPr algn="ctr"/>
+          </a:p>
+        </p:txBody>
+      </p:sp>
+      <p:sp>
+        <p:nvSpPr>
+          <p:cNvPr id="3" name="TextBox 2"/>
+          <p:cNvSpPr txBox="1"/>
+          <p:nvPr/>
+        </p:nvSpPr>
+        <p:spPr>
+          <a:xfrm>
+            <a:off x="914400" y="548640"/>
+            <a:ext cx="10332720" cy="1005840"/>
+          </a:xfrm>
+          <a:prstGeom prst="rect">
+            <a:avLst/>
+          </a:prstGeom>
+          <a:noFill/>
+        </p:spPr>
+        <p:txBody>
+          <a:bodyPr wrap="none">
+            <a:spAutoFit/>
+          </a:bodyPr>
+          <a:lstStyle/>
+          <a:p>
+            <a:pPr>
+              <a:defRPr sz="1300" b="1">
+                <a:solidFill>
+                  <a:srgbClr val="F59E0B"/>
+                </a:solidFill>
+              </a:defRPr>
+            </a:pPr>
+            <a:r>
+              <a:t>FOUNDER-PROBLEM FIT</a:t>
+            </a:r>
+          </a:p>
+          <a:p>
+            <a:pPr>
+              <a:defRPr sz="3400" b="1">
+                <a:solidFill>
+                  <a:srgbClr val="FFFFFF"/>
+                </a:solidFill>
+              </a:defRPr>
+            </a:pPr>
+            <a:r>
+              <a:t>Built for Sovereign Cryptographic Settlement</a:t>
+            </a:r>
+          </a:p>
+        </p:txBody>
+      </p:sp>
+      <p:sp>
+        <p:nvSpPr>
+          <p:cNvPr id="4" name="Rounded Rectangle 3"/>
+          <p:cNvSpPr/>
+          <p:nvPr/>
+        </p:nvSpPr>
+        <p:spPr>
+          <a:xfrm>
+            <a:off x="914400" y="1737360"/>
+            <a:ext cx="3291840" cy="3474720"/>
           </a:xfrm>
           <a:prstGeom prst="roundRect">
             <a:avLst/>
@@ -6575,8 +6599,8 @@
         </p:nvSpPr>
         <p:spPr>
           <a:xfrm>
-            <a:off x="1051560" y="1828800"/>
-            <a:ext cx="2194560" cy="1737360"/>
+            <a:off x="1097280" y="1920240"/>
+            <a:ext cx="2926080" cy="3108960"/>
           </a:xfrm>
           <a:prstGeom prst="rect">
             <a:avLst/>
@@ -6590,38 +6614,39 @@
           <a:lstStyle/>
           <a:p>
             <a:pPr>
-              <a:defRPr sz="3200" b="1">
+              <a:defRPr sz="1700" b="1">
                 <a:solidFill>
                   <a:srgbClr val="06B6D4"/>
                 </a:solidFill>
               </a:defRPr>
             </a:pPr>
             <a:r>
-              <a:t>10</a:t>
+              <a:t>Solana Anchor Engineering</a:t>
             </a:r>
           </a:p>
           <a:p>
             <a:pPr>
-              <a:defRPr sz="1300" b="1">
+              <a:defRPr sz="1200" b="1">
+                <a:solidFill>
+                  <a:srgbClr val="94A3B8"/>
+                </a:solidFill>
+              </a:defRPr>
+            </a:pPr>
+            <a:r>
+              <a:t>High-Throughput State Machines</a:t>
+            </a:r>
+          </a:p>
+          <a:p>
+            <a:br/>
+            <a:pPr>
+              <a:defRPr sz="1300">
                 <a:solidFill>
                   <a:srgbClr val="FFFFFF"/>
                 </a:solidFill>
               </a:defRPr>
             </a:pPr>
             <a:r>
-              <a:t>Anchor Instructions</a:t>
-            </a:r>
-          </a:p>
-          <a:p>
-            <a:pPr>
-              <a:defRPr sz="1100">
-                <a:solidFill>
-                  <a:srgbClr val="94A3B8"/>
-                </a:solidFill>
-              </a:defRPr>
-            </a:pPr>
-            <a:r>
-              <a:t>Deployed on Devnet</a:t>
+              <a:t>Specialized in temporal phase locks, blinded commitments, and on-chain Olympic scoring algorithms.</a:t>
             </a:r>
           </a:p>
         </p:txBody>
@@ -6634,8 +6659,8 @@
         </p:nvSpPr>
         <p:spPr>
           <a:xfrm>
-            <a:off x="3547872" y="1737360"/>
-            <a:ext cx="2468880" cy="1920240"/>
+            <a:off x="4434840" y="1737360"/>
+            <a:ext cx="3291840" cy="3474720"/>
           </a:xfrm>
           <a:prstGeom prst="roundRect">
             <a:avLst/>
@@ -6679,8 +6704,8 @@
         </p:nvSpPr>
         <p:spPr>
           <a:xfrm>
-            <a:off x="3685032" y="1828800"/>
-            <a:ext cx="2194560" cy="1737360"/>
+            <a:off x="4617720" y="1920240"/>
+            <a:ext cx="2926080" cy="3108960"/>
           </a:xfrm>
           <a:prstGeom prst="rect">
             <a:avLst/>
@@ -6694,38 +6719,39 @@
           <a:lstStyle/>
           <a:p>
             <a:pPr>
-              <a:defRPr sz="3200" b="1">
-                <a:solidFill>
-                  <a:srgbClr val="10B981"/>
+              <a:defRPr sz="1700" b="1">
+                <a:solidFill>
+                  <a:srgbClr val="A855F7"/>
                 </a:solidFill>
               </a:defRPr>
             </a:pPr>
             <a:r>
-              <a:t>78 / 78</a:t>
+              <a:t>OCDS 1.1 Cryptography</a:t>
             </a:r>
           </a:p>
           <a:p>
             <a:pPr>
-              <a:defRPr sz="1300" b="1">
+              <a:defRPr sz="1200" b="1">
+                <a:solidFill>
+                  <a:srgbClr val="94A3B8"/>
+                </a:solidFill>
+              </a:defRPr>
+            </a:pPr>
+            <a:r>
+              <a:t>World Bank Standards</a:t>
+            </a:r>
+          </a:p>
+          <a:p>
+            <a:br/>
+            <a:pPr>
+              <a:defRPr sz="1300">
                 <a:solidFill>
                   <a:srgbClr val="FFFFFF"/>
                 </a:solidFill>
               </a:defRPr>
             </a:pPr>
             <a:r>
-              <a:t>Passing Unit Tests</a:t>
-            </a:r>
-          </a:p>
-          <a:p>
-            <a:pPr>
-              <a:defRPr sz="1100">
-                <a:solidFill>
-                  <a:srgbClr val="94A3B8"/>
-                </a:solidFill>
-              </a:defRPr>
-            </a:pPr>
-            <a:r>
-              <a:t>100% Hash Parity</a:t>
+              <a:t>Expertise in RFC 8785 canonical hashing and institutional open-contracting data models.</a:t>
             </a:r>
           </a:p>
         </p:txBody>
@@ -6738,8 +6764,8 @@
         </p:nvSpPr>
         <p:spPr>
           <a:xfrm>
-            <a:off x="6181344" y="1737360"/>
-            <a:ext cx="2468880" cy="1920240"/>
+            <a:off x="7955279" y="1737360"/>
+            <a:ext cx="3291840" cy="3474720"/>
           </a:xfrm>
           <a:prstGeom prst="roundRect">
             <a:avLst/>
@@ -6783,8 +6809,8 @@
         </p:nvSpPr>
         <p:spPr>
           <a:xfrm>
-            <a:off x="6318504" y="1828800"/>
-            <a:ext cx="2194560" cy="1737360"/>
+            <a:off x="8138159" y="1920240"/>
+            <a:ext cx="2926080" cy="3108960"/>
           </a:xfrm>
           <a:prstGeom prst="rect">
             <a:avLst/>
@@ -6798,38 +6824,39 @@
           <a:lstStyle/>
           <a:p>
             <a:pPr>
-              <a:defRPr sz="3200" b="1">
-                <a:solidFill>
-                  <a:srgbClr val="A855F7"/>
+              <a:defRPr sz="1700" b="1">
+                <a:solidFill>
+                  <a:srgbClr val="10B981"/>
                 </a:solidFill>
               </a:defRPr>
             </a:pPr>
             <a:r>
-              <a:t>5 / 5</a:t>
+              <a:t>TradFi &amp; B2G Protocols</a:t>
             </a:r>
           </a:p>
           <a:p>
             <a:pPr>
-              <a:defRPr sz="1300" b="1">
+              <a:defRPr sz="1200" b="1">
+                <a:solidFill>
+                  <a:srgbClr val="94A3B8"/>
+                </a:solidFill>
+              </a:defRPr>
+            </a:pPr>
+            <a:r>
+              <a:t>Zero-Friction Enterprise</a:t>
+            </a:r>
+          </a:p>
+          <a:p>
+            <a:br/>
+            <a:pPr>
+              <a:defRPr sz="1300">
                 <a:solidFill>
                   <a:srgbClr val="FFFFFF"/>
                 </a:solidFill>
               </a:defRPr>
             </a:pPr>
             <a:r>
-              <a:t>Storyboard Steps</a:t>
-            </a:r>
-          </a:p>
-          <a:p>
-            <a:pPr>
-              <a:defRPr sz="1100">
-                <a:solidFill>
-                  <a:srgbClr val="94A3B8"/>
-                </a:solidFill>
-              </a:defRPr>
-            </a:pPr>
-            <a:r>
-              <a:t>1-Click Interactive HUD</a:t>
+              <a:t>Architected zero-gas relayers and hybrid surety bond registries compliant with sovereign finance laws.</a:t>
             </a:r>
           </a:p>
         </p:txBody>
@@ -6842,112 +6869,8 @@
         </p:nvSpPr>
         <p:spPr>
           <a:xfrm>
-            <a:off x="8814816" y="1737360"/>
-            <a:ext cx="2468880" cy="1920240"/>
-          </a:xfrm>
-          <a:prstGeom prst="roundRect">
-            <a:avLst/>
-          </a:prstGeom>
-          <a:solidFill>
-            <a:srgbClr val="12192D"/>
-          </a:solidFill>
-          <a:ln w="19050">
-            <a:solidFill>
-              <a:srgbClr val="1E2946"/>
-            </a:solidFill>
-          </a:ln>
-        </p:spPr>
-        <p:style>
-          <a:lnRef idx="1">
-            <a:schemeClr val="accent1"/>
-          </a:lnRef>
-          <a:fillRef idx="3">
-            <a:schemeClr val="accent1"/>
-          </a:fillRef>
-          <a:effectRef idx="2">
-            <a:schemeClr val="accent1"/>
-          </a:effectRef>
-          <a:fontRef idx="minor">
-            <a:schemeClr val="lt1"/>
-          </a:fontRef>
-        </p:style>
-        <p:txBody>
-          <a:bodyPr rtlCol="0" anchor="ctr"/>
-          <a:lstStyle/>
-          <a:p>
-            <a:pPr algn="ctr"/>
-          </a:p>
-        </p:txBody>
-      </p:sp>
-      <p:sp>
-        <p:nvSpPr>
-          <p:cNvPr id="11" name="TextBox 10"/>
-          <p:cNvSpPr txBox="1"/>
-          <p:nvPr/>
-        </p:nvSpPr>
-        <p:spPr>
-          <a:xfrm>
-            <a:off x="8951976" y="1828800"/>
-            <a:ext cx="2194560" cy="1737360"/>
-          </a:xfrm>
-          <a:prstGeom prst="rect">
-            <a:avLst/>
-          </a:prstGeom>
-          <a:noFill/>
-        </p:spPr>
-        <p:txBody>
-          <a:bodyPr wrap="square">
-            <a:spAutoFit/>
-          </a:bodyPr>
-          <a:lstStyle/>
-          <a:p>
-            <a:pPr>
-              <a:defRPr sz="3200" b="1">
-                <a:solidFill>
-                  <a:srgbClr val="F59E0B"/>
-                </a:solidFill>
-              </a:defRPr>
-            </a:pPr>
-            <a:r>
-              <a:t>4</a:t>
-            </a:r>
-          </a:p>
-          <a:p>
-            <a:pPr>
-              <a:defRPr sz="1300" b="1">
-                <a:solidFill>
-                  <a:srgbClr val="FFFFFF"/>
-                </a:solidFill>
-              </a:defRPr>
-            </a:pPr>
-            <a:r>
-              <a:t>Hybrid Bond Modes</a:t>
-            </a:r>
-          </a:p>
-          <a:p>
-            <a:pPr>
-              <a:defRPr sz="1100">
-                <a:solidFill>
-                  <a:srgbClr val="94A3B8"/>
-                </a:solidFill>
-              </a:defRPr>
-            </a:pPr>
-            <a:r>
-              <a:t>TradFi + Crypto</a:t>
-            </a:r>
-          </a:p>
-        </p:txBody>
-      </p:sp>
-      <p:sp>
-        <p:nvSpPr>
-          <p:cNvPr id="12" name="Rounded Rectangle 11"/>
-          <p:cNvSpPr/>
-          <p:nvPr/>
-        </p:nvSpPr>
-        <p:spPr>
-          <a:xfrm>
-            <a:off x="914400" y="3977639"/>
-            <a:ext cx="10360152" cy="2240280"/>
+            <a:off x="914400" y="5440680"/>
+            <a:ext cx="10360152" cy="1051560"/>
           </a:xfrm>
           <a:prstGeom prst="roundRect">
             <a:avLst/>
@@ -6985,14 +6908,14 @@
       </p:sp>
       <p:sp>
         <p:nvSpPr>
-          <p:cNvPr id="13" name="TextBox 12"/>
+          <p:cNvPr id="11" name="TextBox 10"/>
           <p:cNvSpPr txBox="1"/>
           <p:nvPr/>
         </p:nvSpPr>
         <p:spPr>
           <a:xfrm>
-            <a:off x="1188720" y="4160520"/>
-            <a:ext cx="9784080" cy="1920240"/>
+            <a:off x="1097280" y="5532120"/>
+            <a:ext cx="9966960" cy="868680"/>
           </a:xfrm>
           <a:prstGeom prst="rect">
             <a:avLst/>
@@ -7006,38 +6929,26 @@
           <a:lstStyle/>
           <a:p>
             <a:pPr>
-              <a:defRPr sz="1500" b="1">
+              <a:defRPr sz="1300" b="1">
                 <a:solidFill>
                   <a:srgbClr val="06B6D4"/>
                 </a:solidFill>
               </a:defRPr>
             </a:pPr>
             <a:r>
-              <a:t>THE SETTLEMENT LAYER FOR SOVEREIGN CAPITAL</a:t>
+              <a:t>COLOSSEUM CRYPTO WORLD'S FAIR 2026 SUBMISSION</a:t>
             </a:r>
           </a:p>
           <a:p>
             <a:pPr>
-              <a:defRPr sz="2000" b="1">
+              <a:defRPr sz="1200">
                 <a:solidFill>
                   <a:srgbClr val="FFFFFF"/>
                 </a:solidFill>
               </a:defRPr>
             </a:pPr>
             <a:r>
-              <a:t>Live Interactive Web App: bidtrace.net</a:t>
-            </a:r>
-          </a:p>
-          <a:p>
-            <a:pPr>
-              <a:defRPr sz="1300">
-                <a:solidFill>
-                  <a:srgbClr val="94A3B8"/>
-                </a:solidFill>
-              </a:defRPr>
-            </a:pPr>
-            <a:r>
-              <a:t>Program ID: x3iSm5BCoXvEfNwT6m6Vs7ApBJtKjvuTm7qKBJtESjZ  |  GitHub: Ujjwal1396/BidTrace</a:t>
+              <a:t>Live Protocol: bidtrace.net  |  Program ID: x3iSm5BCoXvEfNwT6m6Vs7ApBJtKjvuTm7qKBJtESjZ  |  GitHub: Ujjwal1396/BidTrace</a:t>
             </a:r>
           </a:p>
         </p:txBody>

</xml_diff>

<commit_message>
feat(pitch): sharpen 2-minute pitch & speaker notes to inoculate against prior Colosseum hackathon pitfalls
</commit_message>
<xml_diff>
--- a/BidTrace_Pitch_Deck_2Min.pptx
+++ b/BidTrace_Pitch_Deck_2Min.pptx
@@ -513,7 +513,7 @@
           </a:p>
           <a:p>
             <a:r>
-              <a:t>"Judges, every year $13 trillion is spent on public infrastructure, yet the entire process runs on centralized database trust. BidTrace brings tamper-proof sealed bidding to public contracts on Solana, making insider tampering mathematically impossible."</a:t>
+              <a:t>"Judges, every year $13 trillion is spent on public infrastructure, yet the entire industry runs on centralized database trust. BidTrace brings tamper-proof sealed bidding to public contracts on Solana, turning administrative trust into mathematical certainty."</a:t>
             </a:r>
           </a:p>
         </p:txBody>
@@ -583,12 +583,12 @@
           <a:lstStyle/>
           <a:p>
             <a:r>
-              <a:t>[SLIDE 2 | 0:15 - 0:35 | 35 Words on Slide]</a:t>
-            </a:r>
-          </a:p>
-          <a:p>
-            <a:r>
-              <a:t>"The fatal flaw in procurement isn't bad people—it's a window of time. Between submission deadlines and public opening, database admins have unmonitored root access to peek at competitor prices and backdate bids in MySQL. Centralized trust fails silently every single day."</a:t>
+              <a:t>[SLIDE 2 | 0:15 - 0:35 | 38 Words on Slide]</a:t>
+            </a:r>
+          </a:p>
+          <a:p>
+            <a:r>
+              <a:t>"The fatal flaw in procurement isn't bad people—it's a window of time. Between the submission deadline and bid opening, database admins have unmonitored root access to peek at competitor pricing, alter scores, and backdate bids in MySQL. Traditional audits fail because centralized databases produce zero mathematical proof."</a:t>
             </a:r>
           </a:p>
         </p:txBody>
@@ -658,12 +658,12 @@
           <a:lstStyle/>
           <a:p>
             <a:r>
-              <a:t>[SLIDE 3 | 0:35 - 0:55 | 34 Words on Slide]</a:t>
-            </a:r>
-          </a:p>
-          <a:p>
-            <a:r>
-              <a:t>"BidTrace is Chainlink meets sealed envelopes for sovereign infrastructure. Our unique insight: Solana's 400ms Proof of History turns time into an unalterable physical law. Contractors seal dual envelopes, expired slots are rejected by validators, and evaluator collusion is pruned on-chain."</a:t>
+              <a:t>[SLIDE 3 | 0:35 - 0:55 | 37 Words on Slide]</a:t>
+            </a:r>
+          </a:p>
+          <a:p>
+            <a:r>
+              <a:t>"BidTrace is Chainlink meets sealed envelopes for sovereign infrastructure. We don't just store hashes; Solana's 400-millisecond Proof of History turns time into an unalterable physical law: if a slot expires, code rejects entry forever. Dual envelopes guarantee commercial secrecy, while our on-chain trimmed mean prunes collusive scores."</a:t>
             </a:r>
           </a:p>
         </p:txBody>
@@ -738,7 +738,7 @@
           </a:p>
           <a:p>
             <a:r>
-              <a:t>"The macro tailwind is massive: the World Bank and UN now mandate OCDS 1.1 data standards to combat systemic fraud. Our bottoms-up beachhead is the $500 billion in development bank tenders. The dream state is clear: incorruptible sovereign capital where kickbacks are cryptographically eliminated."</a:t>
+              <a:t>"The macro tailwind is massive: the World Bank and UN now mandate OCDS 1.1 open data standards to stop systemic fraud. Our bottoms-up beachhead is the $500 billion in development bank tenders. The dream state is clear: incorruptible sovereign capital where kickbacks are cryptographically eliminated."</a:t>
             </a:r>
           </a:p>
         </p:txBody>
@@ -808,12 +808,12 @@
           <a:lstStyle/>
           <a:p>
             <a:r>
-              <a:t>[SLIDE 5 | 1:15 - 1:35 | 36 Words on Slide]</a:t>
-            </a:r>
-          </a:p>
-          <a:p>
-            <a:r>
-              <a:t>"This is not a slide concept—BidTrace is already working. We have 10 Anchor Rust instructions deployed on Solana Devnet, 78 passing unit tests with 100% hash parity, and an adversarial attack simulator live right now at bidtrace.net where you can watch live exploits fail on-chain."</a:t>
+              <a:t>[SLIDE 5 | 1:15 - 1:35 | 38 Words on Slide]</a:t>
+            </a:r>
+          </a:p>
+          <a:p>
+            <a:r>
+              <a:t>"This is already working live today. We have 10 Anchor Rust instructions deployed on Solana Devnet and 78 passing unit tests. Crucially, unlike naive auction schemes where one rogue bidder can freeze opening, our independent leaf architecture and on-chain bond slashing ensure compliant contractors unseal cleanly with zero deadlock."</a:t>
             </a:r>
           </a:p>
         </p:txBody>
@@ -888,7 +888,7 @@
           </a:p>
           <a:p>
             <a:r>
-              <a:t>"Why does this keep working? Our business model scales with volume: a 0.05% protocol take-rate on awarded contracts plus TradFi surety underwriting fees. Our network effect is the zero-gas relayer: contractors pay no crypto gas, and each onboarded government locks hundreds of contractors into our verification rail."</a:t>
+              <a:t>"Why will this keep working? We monetize through a 0.05% take-rate on awarded contracts plus surety underwriting fees. Our moat is distribution: contractors pay zero crypto gas, and each onboarded government locks hundreds of contractors into our verification rail, creating an irreversible compliance standard."</a:t>
             </a:r>
           </a:p>
         </p:txBody>
@@ -963,7 +963,7 @@
           </a:p>
           <a:p>
             <a:r>
-              <a:t>"We are uniquely equipped for this problem—combining deep expertise in Solana Anchor engineering, World Bank OCDS standards, and institutional compliance. We built BidTrace to give the world incorruptible public infrastructure. Thank you."</a:t>
+              <a:t>"We are uniquely built for this problem—combining deep expertise in Solana Anchor engineering, World Bank OCDS standards, and institutional compliance. We give contractors independent cryptographic receipts that hold up in legal tribunals. We built BidTrace to make public infrastructure incorruptible. Thank you."</a:t>
             </a:r>
           </a:p>
         </p:txBody>
@@ -4656,7 +4656,7 @@
             </a:r>
             <a:br/>
             <a:r>
-              <a:t>• Price peeking leaks competitor bids.</a:t>
+              <a:t>• Unencrypted prices leaked to favored bidders.</a:t>
             </a:r>
           </a:p>
         </p:txBody>
@@ -4736,7 +4736,7 @@
               </a:defRPr>
             </a:pPr>
             <a:r>
-              <a:t>Zero Mathematical Proof</a:t>
+              <a:t>Zero Math Proof</a:t>
             </a:r>
           </a:p>
           <a:p>
@@ -4748,7 +4748,7 @@
               </a:defRPr>
             </a:pPr>
             <a:r>
-              <a:t>Centralized Custody Relies on Blind Human Trust</a:t>
+              <a:t>Centralized Trust Fails Daily in E-Procurement</a:t>
             </a:r>
           </a:p>
           <a:p>
@@ -4761,15 +4761,15 @@
               </a:defRPr>
             </a:pPr>
             <a:r>
-              <a:t>• Server timestamps can be rewritten in seconds.</a:t>
+              <a:t>• Server timestamps rewritten in seconds.</a:t>
             </a:r>
             <a:br/>
             <a:r>
-              <a:t>• Evaluation scores manipulated behind closed doors.</a:t>
+              <a:t>• Rogue evaluator scores inflated behind closed doors.</a:t>
             </a:r>
             <a:br/>
             <a:r>
-              <a:t>• No cryptographic audit trail for the public.</a:t>
+              <a:t>• Admins claim: 'That is what our database recorded.'</a:t>
             </a:r>
           </a:p>
         </p:txBody>
@@ -4984,7 +4984,7 @@
               </a:defRPr>
             </a:pPr>
             <a:r>
-              <a:t>Technical &amp; financial hashes locked via RFC 8785 canonical standard. Zero leakage.</a:t>
+              <a:t>Blinded technical &amp; financial commitments via RFC 8785 standard. Zero pre-deadline leakage.</a:t>
             </a:r>
           </a:p>
         </p:txBody>
@@ -5076,7 +5076,7 @@
               </a:defRPr>
             </a:pPr>
             <a:r>
-              <a:t>Consensus Phase Locks</a:t>
+              <a:t>Physical Consensus Boundary</a:t>
             </a:r>
           </a:p>
           <a:p>
@@ -5089,7 +5089,7 @@
               </a:defRPr>
             </a:pPr>
             <a:r>
-              <a:t>Solana 400ms clock makes post-deadline tampering physically impossible.</a:t>
+              <a:t>Solana 400ms clock makes post-deadline tampering physically impossible. Expired slots rejected.</a:t>
             </a:r>
           </a:p>
         </p:txBody>
@@ -5194,7 +5194,7 @@
               </a:defRPr>
             </a:pPr>
             <a:r>
-              <a:t>On-chain algorithm automatically prunes collusive scores before price unsealing.</a:t>
+              <a:t>On-chain algorithm auto-prunes collusive evaluator scores before financial unsealing.</a:t>
             </a:r>
           </a:p>
         </p:txBody>
@@ -5292,7 +5292,7 @@
               </a:defRPr>
             </a:pPr>
             <a:r>
-              <a:t>MACRO SHIFT &amp; BOTTOMS-UP OPPORTUNITY</a:t>
+              <a:t>MACRO SHIFT &amp; BOTTOMS-UP BEACHHEAD</a:t>
             </a:r>
           </a:p>
           <a:p>
@@ -5384,7 +5384,7 @@
               </a:defRPr>
             </a:pPr>
             <a:r>
-              <a:t>Macro Trends &amp; The Dream State</a:t>
+              <a:t>Macro Tailwinds &amp; Dream State</a:t>
             </a:r>
           </a:p>
           <a:p>
@@ -5401,11 +5401,11 @@
             </a:r>
             <a:br/>
             <a:r>
-              <a:t>• TradFi On-Chain Shift: Multilateral development bank tenders migrating to Web3 verification.</a:t>
+              <a:t>• TradFi Shift: $500B in multilateral tenders migrating on-chain.</a:t>
             </a:r>
             <a:br/>
             <a:r>
-              <a:t>• Dream State: Zero kickback windows, instant cryptographic audit proofs, and automated surety release.</a:t>
+              <a:t>• Dream State: Incorruptible sovereign infrastructure with zero kickback windows.</a:t>
             </a:r>
           </a:p>
         </p:txBody>
@@ -6094,7 +6094,7 @@
               </a:defRPr>
             </a:pPr>
             <a:r>
-              <a:t>0 Gas</a:t>
+              <a:t>0 Deadlock</a:t>
             </a:r>
           </a:p>
           <a:p>
@@ -6106,7 +6106,7 @@
               </a:defRPr>
             </a:pPr>
             <a:r>
-              <a:t>Relayer Protocol</a:t>
+              <a:t>Leaf State Machine</a:t>
             </a:r>
           </a:p>
           <a:p>
@@ -6119,7 +6119,7 @@
               </a:defRPr>
             </a:pPr>
             <a:r>
-              <a:t>Live at bidtrace.net with Zero Crypto Friction</a:t>
+              <a:t>Rogue bidder default cannot freeze compliant tenders.</a:t>
             </a:r>
           </a:p>
         </p:txBody>
@@ -6322,7 +6322,7 @@
               </a:defRPr>
             </a:pPr>
             <a:r>
-              <a:t>• 0.05% Protocol Fee: Settled contract volume ($250M ARR at 1% market penetration).</a:t>
+              <a:t>• 0.05% Protocol Take-Rate: Settled contract volume ($250M ARR at 1% market penetration).</a:t>
             </a:r>
             <a:br/>
             <a:r>
@@ -6423,7 +6423,7 @@
               </a:defRPr>
             </a:pPr>
             <a:r>
-              <a:t>• Municipal Onboarding Flywheel: Each city onboarded locks regional contractors into the BidTrace relayer.</a:t>
+              <a:t>• Municipal Flywheel: Each city onboarded locks regional contractors into the BidTrace relayer.</a:t>
             </a:r>
             <a:br/>
             <a:r>
@@ -6431,7 +6431,7 @@
             </a:r>
             <a:br/>
             <a:r>
-              <a:t>• Standards Lock-In: Becomes the mandatory OCDS 1.1 compliance layer.</a:t>
+              <a:t>• Standards Lock-In: Becomes the mandatory OCDS 1.1 compliance referee.</a:t>
             </a:r>
           </a:p>
         </p:txBody>
@@ -6621,7 +6621,7 @@
               </a:defRPr>
             </a:pPr>
             <a:r>
-              <a:t>Solana Anchor Engineering</a:t>
+              <a:t>Solana Anchor Systems</a:t>
             </a:r>
           </a:p>
           <a:p>
@@ -6646,7 +6646,7 @@
               </a:defRPr>
             </a:pPr>
             <a:r>
-              <a:t>Specialized in temporal phase locks, blinded commitments, and on-chain Olympic scoring algorithms.</a:t>
+              <a:t>Temporal slot phase locks, blinded commitments, and on-chain Olympic scoring algorithms.</a:t>
             </a:r>
           </a:p>
         </p:txBody>
@@ -6738,7 +6738,7 @@
               </a:defRPr>
             </a:pPr>
             <a:r>
-              <a:t>World Bank Standards</a:t>
+              <a:t>World Bank Data Standard</a:t>
             </a:r>
           </a:p>
           <a:p>
@@ -6751,7 +6751,7 @@
               </a:defRPr>
             </a:pPr>
             <a:r>
-              <a:t>Expertise in RFC 8785 canonical hashing and institutional open-contracting data models.</a:t>
+              <a:t>Deterministic RFC 8785 canonical hashing and open-contracting data schemas.</a:t>
             </a:r>
           </a:p>
         </p:txBody>
@@ -6831,7 +6831,7 @@
               </a:defRPr>
             </a:pPr>
             <a:r>
-              <a:t>TradFi &amp; B2G Protocols</a:t>
+              <a:t>B2G &amp; TradFi Relayers</a:t>
             </a:r>
           </a:p>
           <a:p>
@@ -6856,7 +6856,7 @@
               </a:defRPr>
             </a:pPr>
             <a:r>
-              <a:t>Architected zero-gas relayers and hybrid surety bond registries compliant with sovereign finance laws.</a:t>
+              <a:t>Zero-gas relayer and air-gapped cryptographic bidder receipts giving contractors legal standing.</a:t>
             </a:r>
           </a:p>
         </p:txBody>

</xml_diff>

<commit_message>
feat(branding): update primary tagline to 'No More Bid Rigging.' across frontend and pitch materials
</commit_message>
<xml_diff>
--- a/BidTrace_Pitch_Deck_2Min.pptx
+++ b/BidTrace_Pitch_Deck_2Min.pptx
@@ -508,12 +508,12 @@
           <a:lstStyle/>
           <a:p>
             <a:r>
-              <a:t>[SLIDE 1 | 0:00 - 0:15 | 28 Words on Slide]</a:t>
-            </a:r>
-          </a:p>
-          <a:p>
-            <a:r>
-              <a:t>"Judges, every year $13 trillion is spent on public infrastructure, yet the entire industry runs on centralized database trust. BidTrace brings tamper-proof sealed bidding to public contracts on Solana, turning administrative trust into mathematical certainty."</a:t>
+              <a:t>[SLIDE 1 | 0:00 - 0:15 | 24 Words on Slide]</a:t>
+            </a:r>
+          </a:p>
+          <a:p>
+            <a:r>
+              <a:t>"Judges, every year $13 trillion is spent on public infrastructure, yet bid rigging and database tampering steal up to 25% of that capital. BidTrace eliminates bid rigging with cryptographic sealed bidding on Solana, turning administrative trust into mathematical certainty."</a:t>
             </a:r>
           </a:p>
         </p:txBody>
@@ -4136,7 +4136,7 @@
         <p:spPr>
           <a:xfrm>
             <a:off x="1097280" y="3154680"/>
-            <a:ext cx="10058400" cy="1188720"/>
+            <a:ext cx="10058400" cy="1371600"/>
           </a:xfrm>
           <a:prstGeom prst="rect">
             <a:avLst/>
@@ -4150,14 +4150,26 @@
           <a:lstStyle/>
           <a:p>
             <a:pPr>
-              <a:defRPr sz="3200" b="1">
+              <a:defRPr sz="3600" b="1">
                 <a:solidFill>
                   <a:srgbClr val="06B6D4"/>
                 </a:solidFill>
               </a:defRPr>
             </a:pPr>
             <a:r>
-              <a:t>Tamper-Proof Sealed Bidding for Public Contracts on Solana</a:t>
+              <a:t>No More Bid Rigging.</a:t>
+            </a:r>
+          </a:p>
+          <a:p>
+            <a:pPr>
+              <a:defRPr sz="1800">
+                <a:solidFill>
+                  <a:srgbClr val="94A3B8"/>
+                </a:solidFill>
+              </a:defRPr>
+            </a:pPr>
+            <a:r>
+              <a:t>Cryptographic sealed bidding for public infrastructure contracts.</a:t>
             </a:r>
           </a:p>
         </p:txBody>

</xml_diff>

<commit_message>
feat(branding): update primary hook to 'Goodbye Bid Rigging' across all assets
</commit_message>
<xml_diff>
--- a/BidTrace_Pitch_Deck_2Min.pptx
+++ b/BidTrace_Pitch_Deck_2Min.pptx
@@ -508,12 +508,12 @@
           <a:lstStyle/>
           <a:p>
             <a:r>
-              <a:t>[SLIDE 1 | 0:00 - 0:15 | 24 Words on Slide]</a:t>
-            </a:r>
-          </a:p>
-          <a:p>
-            <a:r>
-              <a:t>"Judges, every year $13 trillion is spent on public infrastructure, yet bid rigging and database tampering steal up to 25% of that capital. BidTrace eliminates bid rigging with cryptographic sealed bidding on Solana, turning administrative trust into mathematical certainty."</a:t>
+              <a:t>[SLIDE 1 | 0:00 - 0:06 | 14 Words]</a:t>
+            </a:r>
+          </a:p>
+          <a:p>
+            <a:r>
+              <a:t>"Good morning, I’m [Your Name]. This is BidTrace: Goodbye Bid Rigging."</a:t>
             </a:r>
           </a:p>
         </p:txBody>
@@ -583,12 +583,12 @@
           <a:lstStyle/>
           <a:p>
             <a:r>
-              <a:t>[SLIDE 2 | 0:15 - 0:35 | 38 Words on Slide]</a:t>
-            </a:r>
-          </a:p>
-          <a:p>
-            <a:r>
-              <a:t>"The fatal flaw in procurement isn't bad people—it's a window of time. Between the submission deadline and bid opening, database admins have unmonitored root access to peek at competitor pricing, alter scores, and backdate bids in MySQL. Traditional audits fail because centralized databases produce zero mathematical proof."</a:t>
+              <a:t>[SLIDE 2 | 0:06 - 0:28 | 48 Words]</a:t>
+            </a:r>
+          </a:p>
+          <a:p>
+            <a:r>
+              <a:t>"Public procurement is a $13 Trillion market, but 25%—over $2.5 Trillion—is lost to corruption. As a lawyer who handled NPAs and bad loan recoveries at a commercial bank, I’ve seen this wreckage firsthand: backdated bids, leaked prices, and rigged tenders disguised as legitimate processes on centralized SQL databases."</a:t>
             </a:r>
           </a:p>
         </p:txBody>
@@ -658,12 +658,12 @@
           <a:lstStyle/>
           <a:p>
             <a:r>
-              <a:t>[SLIDE 3 | 0:35 - 0:55 | 37 Words on Slide]</a:t>
-            </a:r>
-          </a:p>
-          <a:p>
-            <a:r>
-              <a:t>"BidTrace is Chainlink meets sealed envelopes for sovereign infrastructure. We don't just store hashes; Solana's 400-millisecond Proof of History turns time into an unalterable physical law: if a slot expires, code rejects entry forever. Dual envelopes guarantee commercial secrecy, while our on-chain trimmed mean prunes collusive scores."</a:t>
+              <a:t>[SLIDE 3 | 0:28 - 1:00 | 72 Words]</a:t>
+            </a:r>
+          </a:p>
+          <a:p>
+            <a:r>
+              <a:t>"BidTrace is the cryptographic Swiss Vault for public procurement. We replace database admin trust with mathematical certainty: Contractors encrypt bids in-browser with AES-256 dual envelopes—servers never see plaintext. Deadlines are locked to Solana’s Proof of History clock—late bids are rejected at the bytecode level. And proposals are scored blindly, discarding rogue outlier bribes. Best of all, our zero-fiat relayer requires zero crypto tokens, making BidTrace 100% legally compliant worldwide."</a:t>
             </a:r>
           </a:p>
         </p:txBody>
@@ -733,12 +733,12 @@
           <a:lstStyle/>
           <a:p>
             <a:r>
-              <a:t>[SLIDE 4 | 0:55 - 1:15 | 36 Words on Slide]</a:t>
-            </a:r>
-          </a:p>
-          <a:p>
-            <a:r>
-              <a:t>"The macro tailwind is massive: the World Bank and UN now mandate OCDS 1.1 open data standards to stop systemic fraud. Our bottoms-up beachhead is the $500 billion in development bank tenders. The dream state is clear: incorruptible sovereign capital where kickbacks are cryptographically eliminated."</a:t>
+              <a:t>[SLIDE 4 | 1:00 - 1:20 | 46 Words]</a:t>
+            </a:r>
+          </a:p>
+          <a:p>
+            <a:r>
+              <a:t>"Our beachhead is the $120 Billion in multilateral projects funded by the World Bank and ADB. In its landmark report on disruptive procurement, the World Bank validated blockchain's anti-corruption power, but flagged privacy, gas costs, and token bans. BidTrace was purpose-built to solve all three."</a:t>
             </a:r>
           </a:p>
         </p:txBody>
@@ -808,12 +808,12 @@
           <a:lstStyle/>
           <a:p>
             <a:r>
-              <a:t>[SLIDE 5 | 1:15 - 1:35 | 38 Words on Slide]</a:t>
-            </a:r>
-          </a:p>
-          <a:p>
-            <a:r>
-              <a:t>"This is already working live today. We have 10 Anchor Rust instructions deployed on Solana Devnet and 78 passing unit tests. Crucially, unlike naive auction schemes where one rogue bidder can freeze opening, our independent leaf architecture and on-chain bond slashing ensure compliant contractors unseal cleanly with zero deadlock."</a:t>
+              <a:t>[SLIDE 5 | 1:20 - 1:38 | 40 Words]</a:t>
+            </a:r>
+          </a:p>
+          <a:p>
+            <a:r>
+              <a:t>"We charge an annual enterprise SaaS license from $50k to $250k, plus a 0.05% integrity fee funded directly through existing contractor submission fee budgets. When multilateral lenders mandate BidTrace on loan tranches, it cascades across 189 member countries automatically."</a:t>
             </a:r>
           </a:p>
         </p:txBody>
@@ -883,12 +883,12 @@
           <a:lstStyle/>
           <a:p>
             <a:r>
-              <a:t>[SLIDE 6 | 1:35 - 1:50 | 39 Words on Slide]</a:t>
-            </a:r>
-          </a:p>
-          <a:p>
-            <a:r>
-              <a:t>"Why will this keep working? We monetize through a 0.05% take-rate on awarded contracts plus surety underwriting fees. Our moat is distribution: contractors pay zero crypto gas, and each onboarded government locks hundreds of contractors into our verification rail, creating an irreversible compliance standard."</a:t>
+              <a:t>[SLIDE 6 | 1:38 - 1:55 | 40 Words]</a:t>
+            </a:r>
+          </a:p>
+          <a:p>
+            <a:r>
+              <a:t>"I built BidTrace because I sit at the exact intersection of law, banking forensics, and cryptography. I didn’t read about tender fraud in a textbook—I saw the defaults on my desk. The prototype is live. Join us. Goodbye Bid Rigging."</a:t>
             </a:r>
           </a:p>
         </p:txBody>
@@ -958,12 +958,12 @@
           <a:lstStyle/>
           <a:p>
             <a:r>
-              <a:t>[SLIDE 7 | 1:50 - 2:00 | 39 Words on Slide]</a:t>
-            </a:r>
-          </a:p>
-          <a:p>
-            <a:r>
-              <a:t>"We are uniquely built for this problem—combining deep expertise in Solana Anchor engineering, World Bank OCDS standards, and institutional compliance. We give contractors independent cryptographic receipts that hold up in legal tribunals. We built BidTrace to make public infrastructure incorruptible. Thank you."</a:t>
+              <a:t>[SLIDE 7 | 1:55 - 2:00 | 15 Words]</a:t>
+            </a:r>
+          </a:p>
+          <a:p>
+            <a:r>
+              <a:t>"If you like our cause, visit us on bidtrace.net and join us on X. Thank you."</a:t>
             </a:r>
           </a:p>
         </p:txBody>
@@ -3984,11 +3984,11 @@
             <a:avLst/>
           </a:prstGeom>
           <a:solidFill>
-            <a:srgbClr val="0A0F1D"/>
+            <a:srgbClr val="070B16"/>
           </a:solidFill>
           <a:ln>
             <a:solidFill>
-              <a:srgbClr val="0A0F1D"/>
+              <a:srgbClr val="070B16"/>
             </a:solidFill>
           </a:ln>
         </p:spPr>
@@ -4030,7 +4030,7 @@
         </p:blipFill>
         <p:spPr>
           <a:xfrm>
-            <a:off x="1097280" y="1371600"/>
+            <a:off x="1097280" y="1280160"/>
             <a:ext cx="1645920" cy="1857820"/>
           </a:xfrm>
           <a:prstGeom prst="rect">
@@ -4046,8 +4046,8 @@
         </p:nvSpPr>
         <p:spPr>
           <a:xfrm>
-            <a:off x="3017520" y="1417320"/>
-            <a:ext cx="3840480" cy="384048"/>
+            <a:off x="3017520" y="1325880"/>
+            <a:ext cx="4389120" cy="384048"/>
           </a:xfrm>
           <a:prstGeom prst="roundRect">
             <a:avLst/>
@@ -4087,7 +4087,7 @@
               </a:defRPr>
             </a:pPr>
             <a:r>
-              <a:t>COLOSSEUM CRYPTO WORLD'S FAIR 2026</a:t>
+              <a:t>SOVEREIGN PUBLIC PROCUREMENT PROTOCOL</a:t>
             </a:r>
           </a:p>
         </p:txBody>
@@ -4100,7 +4100,7 @@
         </p:nvSpPr>
         <p:spPr>
           <a:xfrm>
-            <a:off x="2926080" y="1874519"/>
+            <a:off x="2926080" y="1783080"/>
             <a:ext cx="8229600" cy="1097280"/>
           </a:xfrm>
           <a:prstGeom prst="rect">
@@ -4135,7 +4135,7 @@
         </p:nvSpPr>
         <p:spPr>
           <a:xfrm>
-            <a:off x="1097280" y="3154680"/>
+            <a:off x="1097280" y="3108960"/>
             <a:ext cx="10058400" cy="1371600"/>
           </a:xfrm>
           <a:prstGeom prst="rect">
@@ -4150,14 +4150,14 @@
           <a:lstStyle/>
           <a:p>
             <a:pPr>
-              <a:defRPr sz="3600" b="1">
+              <a:defRPr sz="3800" b="1">
                 <a:solidFill>
                   <a:srgbClr val="06B6D4"/>
                 </a:solidFill>
               </a:defRPr>
             </a:pPr>
             <a:r>
-              <a:t>No More Bid Rigging.</a:t>
+              <a:t>Goodbye Bid Rigging.</a:t>
             </a:r>
           </a:p>
           <a:p>
@@ -4182,18 +4182,18 @@
         </p:nvSpPr>
         <p:spPr>
           <a:xfrm>
-            <a:off x="1097280" y="4754880"/>
-            <a:ext cx="3200400" cy="1371600"/>
+            <a:off x="1097280" y="4663440"/>
+            <a:ext cx="3200400" cy="1463040"/>
           </a:xfrm>
           <a:prstGeom prst="roundRect">
             <a:avLst/>
           </a:prstGeom>
           <a:solidFill>
-            <a:srgbClr val="12192D"/>
+            <a:srgbClr val="0C1326"/>
           </a:solidFill>
           <a:ln w="19050">
             <a:solidFill>
-              <a:srgbClr val="1E2946"/>
+              <a:srgbClr val="1C2848"/>
             </a:solidFill>
           </a:ln>
         </p:spPr>
@@ -4227,8 +4227,8 @@
         </p:nvSpPr>
         <p:spPr>
           <a:xfrm>
-            <a:off x="1280160" y="4892040"/>
-            <a:ext cx="2834640" cy="1097280"/>
+            <a:off x="1280160" y="4800600"/>
+            <a:ext cx="2834640" cy="1188720"/>
           </a:xfrm>
           <a:prstGeom prst="rect">
             <a:avLst/>
@@ -4254,14 +4254,14 @@
           </a:p>
           <a:p>
             <a:pPr>
-              <a:defRPr sz="1300">
+              <a:defRPr sz="1200">
                 <a:solidFill>
                   <a:srgbClr val="94A3B8"/>
                 </a:solidFill>
               </a:defRPr>
             </a:pPr>
             <a:r>
-              <a:t>Annual Sovereign Spend</a:t>
+              <a:t>Annual Sovereign Spend (15-20% GDP)</a:t>
             </a:r>
           </a:p>
         </p:txBody>
@@ -4274,18 +4274,18 @@
         </p:nvSpPr>
         <p:spPr>
           <a:xfrm>
-            <a:off x="4526280" y="4754880"/>
-            <a:ext cx="3200400" cy="1371600"/>
+            <a:off x="4526280" y="4663440"/>
+            <a:ext cx="3200400" cy="1463040"/>
           </a:xfrm>
           <a:prstGeom prst="roundRect">
             <a:avLst/>
           </a:prstGeom>
           <a:solidFill>
-            <a:srgbClr val="12192D"/>
+            <a:srgbClr val="0C1326"/>
           </a:solidFill>
           <a:ln w="19050">
             <a:solidFill>
-              <a:srgbClr val="1E2946"/>
+              <a:srgbClr val="1C2848"/>
             </a:solidFill>
           </a:ln>
         </p:spPr>
@@ -4319,8 +4319,8 @@
         </p:nvSpPr>
         <p:spPr>
           <a:xfrm>
-            <a:off x="4709160" y="4892040"/>
-            <a:ext cx="2834640" cy="1097280"/>
+            <a:off x="4709160" y="4800600"/>
+            <a:ext cx="2834640" cy="1188720"/>
           </a:xfrm>
           <a:prstGeom prst="rect">
             <a:avLst/>
@@ -4346,14 +4346,14 @@
           </a:p>
           <a:p>
             <a:pPr>
-              <a:defRPr sz="1300">
+              <a:defRPr sz="1200">
                 <a:solidFill>
                   <a:srgbClr val="94A3B8"/>
                 </a:solidFill>
               </a:defRPr>
             </a:pPr>
             <a:r>
-              <a:t>Proof of History Precision</a:t>
+              <a:t>Proof of History Precision Deadline Lock</a:t>
             </a:r>
           </a:p>
         </p:txBody>
@@ -4366,18 +4366,18 @@
         </p:nvSpPr>
         <p:spPr>
           <a:xfrm>
-            <a:off x="7955279" y="4754880"/>
-            <a:ext cx="3200400" cy="1371600"/>
+            <a:off x="7955279" y="4663440"/>
+            <a:ext cx="3200400" cy="1463040"/>
           </a:xfrm>
           <a:prstGeom prst="roundRect">
             <a:avLst/>
           </a:prstGeom>
           <a:solidFill>
-            <a:srgbClr val="12192D"/>
+            <a:srgbClr val="0C1326"/>
           </a:solidFill>
           <a:ln w="19050">
             <a:solidFill>
-              <a:srgbClr val="1E2946"/>
+              <a:srgbClr val="1C2848"/>
             </a:solidFill>
           </a:ln>
         </p:spPr>
@@ -4411,8 +4411,8 @@
         </p:nvSpPr>
         <p:spPr>
           <a:xfrm>
-            <a:off x="8138159" y="4892040"/>
-            <a:ext cx="2834640" cy="1097280"/>
+            <a:off x="8138159" y="4800600"/>
+            <a:ext cx="2834640" cy="1188720"/>
           </a:xfrm>
           <a:prstGeom prst="rect">
             <a:avLst/>
@@ -4438,14 +4438,14 @@
           </a:p>
           <a:p>
             <a:pPr>
-              <a:defRPr sz="1300">
+              <a:defRPr sz="1200">
                 <a:solidFill>
                   <a:srgbClr val="94A3B8"/>
                 </a:solidFill>
               </a:defRPr>
             </a:pPr>
             <a:r>
-              <a:t>Enterprise Relayer Sponsored</a:t>
+              <a:t>100% Legally Compliant Worldwide</a:t>
             </a:r>
           </a:p>
         </p:txBody>
@@ -4483,11 +4483,11 @@
             <a:avLst/>
           </a:prstGeom>
           <a:solidFill>
-            <a:srgbClr val="0A0F1D"/>
+            <a:srgbClr val="070B16"/>
           </a:solidFill>
           <a:ln>
             <a:solidFill>
-              <a:srgbClr val="0A0F1D"/>
+              <a:srgbClr val="070B16"/>
             </a:solidFill>
           </a:ln>
         </p:spPr>
@@ -4521,7 +4521,7 @@
         </p:nvSpPr>
         <p:spPr>
           <a:xfrm>
-            <a:off x="914400" y="548640"/>
+            <a:off x="914400" y="502920"/>
             <a:ext cx="10332720" cy="1005840"/>
           </a:xfrm>
           <a:prstGeom prst="rect">
@@ -4543,19 +4543,19 @@
               </a:defRPr>
             </a:pPr>
             <a:r>
-              <a:t>THE $13 TRILLION CRITICAL FLAW</a:t>
+              <a:t>THE PROBLEM</a:t>
             </a:r>
           </a:p>
           <a:p>
             <a:pPr>
-              <a:defRPr sz="3400" b="1">
+              <a:defRPr sz="3200" b="1">
                 <a:solidFill>
                   <a:srgbClr val="FFFFFF"/>
                 </a:solidFill>
               </a:defRPr>
             </a:pPr>
             <a:r>
-              <a:t>The Post-Deadline Insider Tampering Window</a:t>
+              <a:t>The $2.5 Trillion Corruption Tax on Public Procurement</a:t>
             </a:r>
           </a:p>
         </p:txBody>
@@ -4568,14 +4568,14 @@
         </p:nvSpPr>
         <p:spPr>
           <a:xfrm>
-            <a:off x="914400" y="1737360"/>
-            <a:ext cx="4937760" cy="4389120"/>
+            <a:off x="914400" y="1691640"/>
+            <a:ext cx="4937760" cy="4480560"/>
           </a:xfrm>
           <a:prstGeom prst="roundRect">
             <a:avLst/>
           </a:prstGeom>
           <a:solidFill>
-            <a:srgbClr val="12192D"/>
+            <a:srgbClr val="0C1326"/>
           </a:solidFill>
           <a:ln w="19050">
             <a:solidFill>
@@ -4613,8 +4613,8 @@
         </p:nvSpPr>
         <p:spPr>
           <a:xfrm>
-            <a:off x="1188720" y="2011680"/>
-            <a:ext cx="4389120" cy="3840480"/>
+            <a:off x="1188720" y="1874519"/>
+            <a:ext cx="4389120" cy="4023360"/>
           </a:xfrm>
           <a:prstGeom prst="rect">
             <a:avLst/>
@@ -4628,47 +4628,47 @@
           <a:lstStyle/>
           <a:p>
             <a:pPr>
-              <a:defRPr sz="3600" b="1">
+              <a:defRPr sz="3400" b="1">
                 <a:solidFill>
                   <a:srgbClr val="F43F5E"/>
                 </a:solidFill>
               </a:defRPr>
             </a:pPr>
             <a:r>
-              <a:t>$13 Trillion / Year</a:t>
+              <a:t>$2.5 Trillion Lost</a:t>
             </a:r>
           </a:p>
           <a:p>
             <a:pPr>
-              <a:defRPr sz="1600" b="1">
+              <a:defRPr sz="1400" b="1">
                 <a:solidFill>
                   <a:srgbClr val="FFFFFF"/>
                 </a:solidFill>
               </a:defRPr>
             </a:pPr>
             <a:r>
-              <a:t>15% of Global GDP Vulnerable to Insider DBA Access</a:t>
+              <a:t>20% to 25% of Global Public Infrastructure Spend</a:t>
+            </a:r>
+            <a:br/>
+            <a:r>
+              <a:t>(World Bank &amp; UN Estimates)</a:t>
             </a:r>
           </a:p>
           <a:p>
             <a:br/>
             <a:pPr>
-              <a:defRPr sz="1400">
-                <a:solidFill>
-                  <a:srgbClr val="94A3B8"/>
+              <a:defRPr sz="1300">
+                <a:solidFill>
+                  <a:srgbClr val="F59E0B"/>
                 </a:solidFill>
               </a:defRPr>
             </a:pPr>
             <a:r>
-              <a:t>• Database admins hold MySQL root keys.</a:t>
+              <a:t>⚖️ FORENSIC AUTHORITY:</a:t>
             </a:r>
             <a:br/>
             <a:r>
-              <a:t>• Late bids quietly backdated before opening.</a:t>
-            </a:r>
-            <a:br/>
-            <a:r>
-              <a:t>• Unencrypted prices leaked to favored bidders.</a:t>
+              <a:t>As a lawyer who worked on bad loan recoveries and NPAs at a commercial bank, I've seen this wreckage firsthand: defaulted contracts, fraudulent bank guarantees, and rigged tender processes.</a:t>
             </a:r>
           </a:p>
         </p:txBody>
@@ -4681,14 +4681,14 @@
         </p:nvSpPr>
         <p:spPr>
           <a:xfrm>
-            <a:off x="6217920" y="1737360"/>
-            <a:ext cx="5029200" cy="4389120"/>
+            <a:off x="6217920" y="1691640"/>
+            <a:ext cx="5029200" cy="4480560"/>
           </a:xfrm>
           <a:prstGeom prst="roundRect">
             <a:avLst/>
           </a:prstGeom>
           <a:solidFill>
-            <a:srgbClr val="0C1C30"/>
+            <a:srgbClr val="0C182C"/>
           </a:solidFill>
           <a:ln w="19050">
             <a:solidFill>
@@ -4726,8 +4726,8 @@
         </p:nvSpPr>
         <p:spPr>
           <a:xfrm>
-            <a:off x="6492240" y="2011680"/>
-            <a:ext cx="4480560" cy="3840480"/>
+            <a:off x="6492240" y="1874519"/>
+            <a:ext cx="4480560" cy="4023360"/>
           </a:xfrm>
           <a:prstGeom prst="rect">
             <a:avLst/>
@@ -4741,47 +4741,53 @@
           <a:lstStyle/>
           <a:p>
             <a:pPr>
-              <a:defRPr sz="3600" b="1">
+              <a:defRPr sz="2800" b="1">
                 <a:solidFill>
                   <a:srgbClr val="06B6D4"/>
                 </a:solidFill>
               </a:defRPr>
             </a:pPr>
             <a:r>
-              <a:t>Zero Math Proof</a:t>
+              <a:t>Centralized SQL Trust</a:t>
             </a:r>
           </a:p>
           <a:p>
             <a:pPr>
-              <a:defRPr sz="1600" b="1">
+              <a:defRPr sz="1400" b="1">
                 <a:solidFill>
                   <a:srgbClr val="FFFFFF"/>
                 </a:solidFill>
               </a:defRPr>
             </a:pPr>
             <a:r>
-              <a:t>Centralized Trust Fails Daily in E-Procurement</a:t>
+              <a:t>Legacy Systems (SAP Ariba, Procore, Govt Portals)</a:t>
             </a:r>
           </a:p>
           <a:p>
             <a:br/>
             <a:pPr>
-              <a:defRPr sz="1400">
+              <a:defRPr sz="1300">
                 <a:solidFill>
                   <a:srgbClr val="94A3B8"/>
                 </a:solidFill>
               </a:defRPr>
             </a:pPr>
             <a:r>
-              <a:t>• Server timestamps rewritten in seconds.</a:t>
+              <a:t>• Pre-Deadline Leaks: Admins peek at sealed prices before cutoff.</a:t>
             </a:r>
             <a:br/>
-            <a:r>
-              <a:t>• Rogue evaluator scores inflated behind closed doors.</a:t>
-            </a:r>
             <a:br/>
             <a:r>
-              <a:t>• Admins claim: 'That is what our database recorded.'</a:t>
+              <a:t>• SQL Backdating: Late bids accepted with a simple UPDATE command:</a:t>
+            </a:r>
+            <a:br/>
+            <a:r>
+              <a:t>   UPDATE bids SET submitted_at = '14:49:00';</a:t>
+            </a:r>
+            <a:br/>
+            <a:br/>
+            <a:r>
+              <a:t>• Exposed Trade Secrets: Losing bidders' proprietary unit prices leaked to competitors.</a:t>
             </a:r>
           </a:p>
         </p:txBody>
@@ -4819,11 +4825,11 @@
             <a:avLst/>
           </a:prstGeom>
           <a:solidFill>
-            <a:srgbClr val="0A0F1D"/>
+            <a:srgbClr val="070B16"/>
           </a:solidFill>
           <a:ln>
             <a:solidFill>
-              <a:srgbClr val="0A0F1D"/>
+              <a:srgbClr val="070B16"/>
             </a:solidFill>
           </a:ln>
         </p:spPr>
@@ -4857,7 +4863,7 @@
         </p:nvSpPr>
         <p:spPr>
           <a:xfrm>
-            <a:off x="914400" y="548640"/>
+            <a:off x="914400" y="502920"/>
             <a:ext cx="10332720" cy="1005840"/>
           </a:xfrm>
           <a:prstGeom prst="rect">
@@ -4879,19 +4885,19 @@
               </a:defRPr>
             </a:pPr>
             <a:r>
-              <a:t>THE HERO MECHANISM</a:t>
+              <a:t>SOLUTION: BIDTRACE</a:t>
             </a:r>
           </a:p>
           <a:p>
             <a:pPr>
-              <a:defRPr sz="3200" b="1">
+              <a:defRPr sz="3000" b="1">
                 <a:solidFill>
                   <a:srgbClr val="FFFFFF"/>
                 </a:solidFill>
               </a:defRPr>
             </a:pPr>
             <a:r>
-              <a:t>“Chainlink + Sealed Envelopes for Sovereign Capital”</a:t>
+              <a:t>“The Cryptographic Swiss Vault for Public Procurement”</a:t>
             </a:r>
           </a:p>
         </p:txBody>
@@ -4904,18 +4910,18 @@
         </p:nvSpPr>
         <p:spPr>
           <a:xfrm>
-            <a:off x="914400" y="1737360"/>
-            <a:ext cx="3291840" cy="4389120"/>
+            <a:off x="914400" y="1691640"/>
+            <a:ext cx="10360152" cy="960120"/>
           </a:xfrm>
           <a:prstGeom prst="roundRect">
             <a:avLst/>
           </a:prstGeom>
           <a:solidFill>
-            <a:srgbClr val="12192D"/>
+            <a:srgbClr val="0C1326"/>
           </a:solidFill>
           <a:ln w="19050">
             <a:solidFill>
-              <a:srgbClr val="1E2946"/>
+              <a:srgbClr val="1C2848"/>
             </a:solidFill>
           </a:ln>
         </p:spPr>
@@ -4949,8 +4955,8 @@
         </p:nvSpPr>
         <p:spPr>
           <a:xfrm>
-            <a:off x="1097280" y="2011680"/>
-            <a:ext cx="2926080" cy="3840480"/>
+            <a:off x="1097280" y="1783080"/>
+            <a:ext cx="9966960" cy="777240"/>
           </a:xfrm>
           <a:prstGeom prst="rect">
             <a:avLst/>
@@ -4964,39 +4970,26 @@
           <a:lstStyle/>
           <a:p>
             <a:pPr>
-              <a:defRPr sz="1800" b="1">
+              <a:defRPr sz="1600" b="1">
                 <a:solidFill>
                   <a:srgbClr val="06B6D4"/>
                 </a:solidFill>
               </a:defRPr>
             </a:pPr>
             <a:r>
-              <a:t>Dual-Envelope Sealing</a:t>
+              <a:t>1. Pre-Deadline Leaks  ➔  Client-Side AES-256 Dual Envelopes</a:t>
             </a:r>
           </a:p>
           <a:p>
             <a:pPr>
-              <a:defRPr sz="1200" b="1">
-                <a:solidFill>
-                  <a:srgbClr val="94A3B8"/>
+              <a:defRPr sz="1200">
+                <a:solidFill>
+                  <a:srgbClr val="FFFFFF"/>
                 </a:solidFill>
               </a:defRPr>
             </a:pPr>
             <a:r>
-              <a:t>OCDS 1.1 Cryptographic Hash</a:t>
-            </a:r>
-          </a:p>
-          <a:p>
-            <a:br/>
-            <a:pPr>
-              <a:defRPr sz="1400">
-                <a:solidFill>
-                  <a:srgbClr val="FFFFFF"/>
-                </a:solidFill>
-              </a:defRPr>
-            </a:pPr>
-            <a:r>
-              <a:t>Blinded technical &amp; financial commitments via RFC 8785 standard. Zero pre-deadline leakage.</a:t>
+              <a:t>Encrypted in browser; zero plaintext on servers until official reveal.</a:t>
             </a:r>
           </a:p>
         </p:txBody>
@@ -5009,18 +5002,18 @@
         </p:nvSpPr>
         <p:spPr>
           <a:xfrm>
-            <a:off x="4434840" y="1737360"/>
-            <a:ext cx="3291840" cy="4389120"/>
+            <a:off x="914400" y="2743200"/>
+            <a:ext cx="10360152" cy="960120"/>
           </a:xfrm>
           <a:prstGeom prst="roundRect">
             <a:avLst/>
           </a:prstGeom>
           <a:solidFill>
-            <a:srgbClr val="12192D"/>
+            <a:srgbClr val="0C1326"/>
           </a:solidFill>
           <a:ln w="19050">
             <a:solidFill>
-              <a:srgbClr val="1E2946"/>
+              <a:srgbClr val="1C2848"/>
             </a:solidFill>
           </a:ln>
         </p:spPr>
@@ -5054,8 +5047,8 @@
         </p:nvSpPr>
         <p:spPr>
           <a:xfrm>
-            <a:off x="4617720" y="2011680"/>
-            <a:ext cx="2926080" cy="3840480"/>
+            <a:off x="1097280" y="2834640"/>
+            <a:ext cx="9966960" cy="777240"/>
           </a:xfrm>
           <a:prstGeom prst="rect">
             <a:avLst/>
@@ -5069,39 +5062,26 @@
           <a:lstStyle/>
           <a:p>
             <a:pPr>
-              <a:defRPr sz="1800" b="1">
+              <a:defRPr sz="1600" b="1">
                 <a:solidFill>
                   <a:srgbClr val="A855F7"/>
                 </a:solidFill>
               </a:defRPr>
             </a:pPr>
             <a:r>
-              <a:t>Proof of History Clock</a:t>
+              <a:t>2. Backdated Late Bids  ➔  Solana Proof of History Clock</a:t>
             </a:r>
           </a:p>
           <a:p>
             <a:pPr>
-              <a:defRPr sz="1200" b="1">
-                <a:solidFill>
-                  <a:srgbClr val="94A3B8"/>
+              <a:defRPr sz="1200">
+                <a:solidFill>
+                  <a:srgbClr val="FFFFFF"/>
                 </a:solidFill>
               </a:defRPr>
             </a:pPr>
             <a:r>
-              <a:t>Physical Consensus Boundary</a:t>
-            </a:r>
-          </a:p>
-          <a:p>
-            <a:br/>
-            <a:pPr>
-              <a:defRPr sz="1400">
-                <a:solidFill>
-                  <a:srgbClr val="FFFFFF"/>
-                </a:solidFill>
-              </a:defRPr>
-            </a:pPr>
-            <a:r>
-              <a:t>Solana 400ms clock makes post-deadline tampering physically impossible. Expired slots rejected.</a:t>
+              <a:t>Bytecode deadline lock; mathematically impossible to backdate (0x1773).</a:t>
             </a:r>
           </a:p>
         </p:txBody>
@@ -5114,18 +5094,18 @@
         </p:nvSpPr>
         <p:spPr>
           <a:xfrm>
-            <a:off x="7955279" y="1737360"/>
-            <a:ext cx="3291840" cy="4389120"/>
+            <a:off x="914400" y="3794760"/>
+            <a:ext cx="10360152" cy="960120"/>
           </a:xfrm>
           <a:prstGeom prst="roundRect">
             <a:avLst/>
           </a:prstGeom>
           <a:solidFill>
-            <a:srgbClr val="12192D"/>
+            <a:srgbClr val="0C1326"/>
           </a:solidFill>
           <a:ln w="19050">
             <a:solidFill>
-              <a:srgbClr val="1E2946"/>
+              <a:srgbClr val="1C2848"/>
             </a:solidFill>
           </a:ln>
         </p:spPr>
@@ -5159,8 +5139,8 @@
         </p:nvSpPr>
         <p:spPr>
           <a:xfrm>
-            <a:off x="8138159" y="2011680"/>
-            <a:ext cx="2926080" cy="3840480"/>
+            <a:off x="1097280" y="3886200"/>
+            <a:ext cx="9966960" cy="777240"/>
           </a:xfrm>
           <a:prstGeom prst="rect">
             <a:avLst/>
@@ -5174,39 +5154,198 @@
           <a:lstStyle/>
           <a:p>
             <a:pPr>
-              <a:defRPr sz="1800" b="1">
+              <a:defRPr sz="1600" b="1">
                 <a:solidFill>
                   <a:srgbClr val="10B981"/>
                 </a:solidFill>
               </a:defRPr>
             </a:pPr>
             <a:r>
-              <a:t>Blinded Outlier Pruning</a:t>
-            </a:r>
-          </a:p>
+              <a:t>3. Evaluator Bribery  ➔  Blinded Olympic Scoring</a:t>
+            </a:r>
+          </a:p>
+          <a:p>
+            <a:pPr>
+              <a:defRPr sz="1200">
+                <a:solidFill>
+                  <a:srgbClr val="FFFFFF"/>
+                </a:solidFill>
+              </a:defRPr>
+            </a:pPr>
+            <a:r>
+              <a:t>Anonymized review by vetted pool; automatically discards rogue score spikes.</a:t>
+            </a:r>
+          </a:p>
+        </p:txBody>
+      </p:sp>
+      <p:sp>
+        <p:nvSpPr>
+          <p:cNvPr id="10" name="Rounded Rectangle 9"/>
+          <p:cNvSpPr/>
+          <p:nvPr/>
+        </p:nvSpPr>
+        <p:spPr>
+          <a:xfrm>
+            <a:off x="914400" y="4846320"/>
+            <a:ext cx="10360152" cy="960120"/>
+          </a:xfrm>
+          <a:prstGeom prst="roundRect">
+            <a:avLst/>
+          </a:prstGeom>
+          <a:solidFill>
+            <a:srgbClr val="0C1326"/>
+          </a:solidFill>
+          <a:ln w="19050">
+            <a:solidFill>
+              <a:srgbClr val="1C2848"/>
+            </a:solidFill>
+          </a:ln>
+        </p:spPr>
+        <p:style>
+          <a:lnRef idx="1">
+            <a:schemeClr val="accent1"/>
+          </a:lnRef>
+          <a:fillRef idx="3">
+            <a:schemeClr val="accent1"/>
+          </a:fillRef>
+          <a:effectRef idx="2">
+            <a:schemeClr val="accent1"/>
+          </a:effectRef>
+          <a:fontRef idx="minor">
+            <a:schemeClr val="lt1"/>
+          </a:fontRef>
+        </p:style>
+        <p:txBody>
+          <a:bodyPr rtlCol="0" anchor="ctr"/>
+          <a:lstStyle/>
+          <a:p>
+            <a:pPr algn="ctr"/>
+          </a:p>
+        </p:txBody>
+      </p:sp>
+      <p:sp>
+        <p:nvSpPr>
+          <p:cNvPr id="11" name="TextBox 10"/>
+          <p:cNvSpPr txBox="1"/>
+          <p:nvPr/>
+        </p:nvSpPr>
+        <p:spPr>
+          <a:xfrm>
+            <a:off x="1097280" y="4937760"/>
+            <a:ext cx="9966960" cy="777240"/>
+          </a:xfrm>
+          <a:prstGeom prst="rect">
+            <a:avLst/>
+          </a:prstGeom>
+          <a:noFill/>
+        </p:spPr>
+        <p:txBody>
+          <a:bodyPr wrap="square">
+            <a:spAutoFit/>
+          </a:bodyPr>
+          <a:lstStyle/>
+          <a:p>
+            <a:pPr>
+              <a:defRPr sz="1600" b="1">
+                <a:solidFill>
+                  <a:srgbClr val="F59E0B"/>
+                </a:solidFill>
+              </a:defRPr>
+            </a:pPr>
+            <a:r>
+              <a:t>4. Trade Secret Theft  ➔  On-Chain Commercial Secrecy Lock</a:t>
+            </a:r>
+          </a:p>
+          <a:p>
+            <a:pPr>
+              <a:defRPr sz="1200">
+                <a:solidFill>
+                  <a:srgbClr val="FFFFFF"/>
+                </a:solidFill>
+              </a:defRPr>
+            </a:pPr>
+            <a:r>
+              <a:t>Disqualified bidders' financial bids remain cryptographically locked forever (0x1778).</a:t>
+            </a:r>
+          </a:p>
+        </p:txBody>
+      </p:sp>
+      <p:sp>
+        <p:nvSpPr>
+          <p:cNvPr id="12" name="Rounded Rectangle 11"/>
+          <p:cNvSpPr/>
+          <p:nvPr/>
+        </p:nvSpPr>
+        <p:spPr>
+          <a:xfrm>
+            <a:off x="914400" y="5989320"/>
+            <a:ext cx="10360152" cy="502920"/>
+          </a:xfrm>
+          <a:prstGeom prst="roundRect">
+            <a:avLst/>
+          </a:prstGeom>
+          <a:solidFill>
+            <a:srgbClr val="102037"/>
+          </a:solidFill>
+          <a:ln w="19050">
+            <a:solidFill>
+              <a:srgbClr val="06B6D4"/>
+            </a:solidFill>
+          </a:ln>
+        </p:spPr>
+        <p:style>
+          <a:lnRef idx="1">
+            <a:schemeClr val="accent1"/>
+          </a:lnRef>
+          <a:fillRef idx="3">
+            <a:schemeClr val="accent1"/>
+          </a:fillRef>
+          <a:effectRef idx="2">
+            <a:schemeClr val="accent1"/>
+          </a:effectRef>
+          <a:fontRef idx="minor">
+            <a:schemeClr val="lt1"/>
+          </a:fontRef>
+        </p:style>
+        <p:txBody>
+          <a:bodyPr rtlCol="0" anchor="ctr"/>
+          <a:lstStyle/>
+          <a:p>
+            <a:pPr algn="ctr"/>
+          </a:p>
+        </p:txBody>
+      </p:sp>
+      <p:sp>
+        <p:nvSpPr>
+          <p:cNvPr id="13" name="TextBox 12"/>
+          <p:cNvSpPr txBox="1"/>
+          <p:nvPr/>
+        </p:nvSpPr>
+        <p:spPr>
+          <a:xfrm>
+            <a:off x="1097280" y="6035040"/>
+            <a:ext cx="9966960" cy="411480"/>
+          </a:xfrm>
+          <a:prstGeom prst="rect">
+            <a:avLst/>
+          </a:prstGeom>
+          <a:noFill/>
+        </p:spPr>
+        <p:txBody>
+          <a:bodyPr wrap="none">
+            <a:spAutoFit/>
+          </a:bodyPr>
+          <a:lstStyle/>
           <a:p>
             <a:pPr>
               <a:defRPr sz="1200" b="1">
                 <a:solidFill>
-                  <a:srgbClr val="94A3B8"/>
+                  <a:srgbClr val="06B6D4"/>
                 </a:solidFill>
               </a:defRPr>
             </a:pPr>
             <a:r>
-              <a:t>Olympic Trimmed Mean</a:t>
-            </a:r>
-          </a:p>
-          <a:p>
-            <a:br/>
-            <a:pPr>
-              <a:defRPr sz="1400">
-                <a:solidFill>
-                  <a:srgbClr val="FFFFFF"/>
-                </a:solidFill>
-              </a:defRPr>
-            </a:pPr>
-            <a:r>
-              <a:t>On-chain algorithm auto-prunes collusive evaluator scores before financial unsealing.</a:t>
+              <a:t>⚡ Zero-Fiat Gas Relayer: Standard browser keys — zero tokens required ➔ 100% legally compliant worldwide.</a:t>
             </a:r>
           </a:p>
         </p:txBody>
@@ -5244,11 +5383,11 @@
             <a:avLst/>
           </a:prstGeom>
           <a:solidFill>
-            <a:srgbClr val="0A0F1D"/>
+            <a:srgbClr val="070B16"/>
           </a:solidFill>
           <a:ln>
             <a:solidFill>
-              <a:srgbClr val="0A0F1D"/>
+              <a:srgbClr val="070B16"/>
             </a:solidFill>
           </a:ln>
         </p:spPr>
@@ -5282,7 +5421,7 @@
         </p:nvSpPr>
         <p:spPr>
           <a:xfrm>
-            <a:off x="914400" y="548640"/>
+            <a:off x="914400" y="502920"/>
             <a:ext cx="10332720" cy="1005840"/>
           </a:xfrm>
           <a:prstGeom prst="rect">
@@ -5304,19 +5443,19 @@
               </a:defRPr>
             </a:pPr>
             <a:r>
-              <a:t>MACRO SHIFT &amp; BOTTOMS-UP BEACHHEAD</a:t>
+              <a:t>MARKET OPPORTUNITY &amp; INSTITUTIONAL VALIDATION</a:t>
             </a:r>
           </a:p>
           <a:p>
             <a:pPr>
-              <a:defRPr sz="3400" b="1">
+              <a:defRPr sz="3200" b="1">
                 <a:solidFill>
                   <a:srgbClr val="FFFFFF"/>
                 </a:solidFill>
               </a:defRPr>
             </a:pPr>
             <a:r>
-              <a:t>From Administrative Paper to Incorruptible Rails</a:t>
+              <a:t>A $13 Trillion Market Demanding Cryptographic Truth</a:t>
             </a:r>
           </a:p>
         </p:txBody>
@@ -5329,18 +5468,18 @@
         </p:nvSpPr>
         <p:spPr>
           <a:xfrm>
-            <a:off x="914400" y="1737360"/>
-            <a:ext cx="5120640" cy="4389120"/>
+            <a:off x="914400" y="1691640"/>
+            <a:ext cx="4937760" cy="4480560"/>
           </a:xfrm>
           <a:prstGeom prst="roundRect">
             <a:avLst/>
           </a:prstGeom>
           <a:solidFill>
-            <a:srgbClr val="12192D"/>
+            <a:srgbClr val="0C1326"/>
           </a:solidFill>
           <a:ln w="19050">
             <a:solidFill>
-              <a:srgbClr val="1E2946"/>
+              <a:srgbClr val="1C2848"/>
             </a:solidFill>
           </a:ln>
         </p:spPr>
@@ -5374,8 +5513,8 @@
         </p:nvSpPr>
         <p:spPr>
           <a:xfrm>
-            <a:off x="1188720" y="2011680"/>
-            <a:ext cx="4572000" cy="3840480"/>
+            <a:off x="1188720" y="1874519"/>
+            <a:ext cx="4389120" cy="4023360"/>
           </a:xfrm>
           <a:prstGeom prst="rect">
             <a:avLst/>
@@ -5389,35 +5528,53 @@
           <a:lstStyle/>
           <a:p>
             <a:pPr>
-              <a:defRPr sz="1800" b="1">
+              <a:defRPr sz="2000" b="1">
                 <a:solidFill>
                   <a:srgbClr val="06B6D4"/>
                 </a:solidFill>
               </a:defRPr>
             </a:pPr>
             <a:r>
-              <a:t>Macro Tailwinds &amp; Dream State</a:t>
+              <a:t>Market Sizing</a:t>
             </a:r>
           </a:p>
           <a:p>
             <a:br/>
             <a:pPr>
-              <a:defRPr sz="1400">
+              <a:defRPr sz="1300">
                 <a:solidFill>
                   <a:srgbClr val="FFFFFF"/>
                 </a:solidFill>
               </a:defRPr>
             </a:pPr>
             <a:r>
-              <a:t>• World Bank Mandate: Enforces OCDS 1.1 anti-corruption standard across all projects.</a:t>
+              <a:t>• SOM: $120 Billion Beachhead</a:t>
             </a:r>
             <a:br/>
             <a:r>
-              <a:t>• TradFi Shift: $500B in multilateral tenders migrating on-chain.</a:t>
+              <a:t>  Multilateral Development Bank Projects (World Bank, ADB)</a:t>
             </a:r>
             <a:br/>
             <a:r>
-              <a:t>• Dream State: Incorruptible sovereign infrastructure with zero kickback windows.</a:t>
+              <a:t>  Mandated to enforce OCDS 1.1 anti-corruption transparency.</a:t>
+            </a:r>
+            <a:br/>
+            <a:br/>
+            <a:r>
+              <a:t>• SAM: $2.5 Trillion</a:t>
+            </a:r>
+            <a:br/>
+            <a:r>
+              <a:t>  High-risk infrastructure tenders where bid rigging concentrates.</a:t>
+            </a:r>
+            <a:br/>
+            <a:br/>
+            <a:r>
+              <a:t>• TAM: $13.0 Trillion</a:t>
+            </a:r>
+            <a:br/>
+            <a:r>
+              <a:t>  Total annual global public procurement (~15-20% World GDP).</a:t>
             </a:r>
           </a:p>
         </p:txBody>
@@ -5430,14 +5587,14 @@
         </p:nvSpPr>
         <p:spPr>
           <a:xfrm>
-            <a:off x="6400800" y="1737360"/>
-            <a:ext cx="4846320" cy="2057400"/>
+            <a:off x="6217920" y="1691640"/>
+            <a:ext cx="5029200" cy="4480560"/>
           </a:xfrm>
           <a:prstGeom prst="roundRect">
             <a:avLst/>
           </a:prstGeom>
           <a:solidFill>
-            <a:srgbClr val="0C1C30"/>
+            <a:srgbClr val="0C182C"/>
           </a:solidFill>
           <a:ln w="19050">
             <a:solidFill>
@@ -5475,8 +5632,8 @@
         </p:nvSpPr>
         <p:spPr>
           <a:xfrm>
-            <a:off x="6675120" y="1920240"/>
-            <a:ext cx="4297680" cy="1737360"/>
+            <a:off x="6492240" y="1874519"/>
+            <a:ext cx="4480560" cy="4023360"/>
           </a:xfrm>
           <a:prstGeom prst="rect">
             <a:avLst/>
@@ -5490,118 +5647,57 @@
           <a:lstStyle/>
           <a:p>
             <a:pPr>
-              <a:defRPr sz="3000" b="1">
+              <a:defRPr sz="2000" b="1">
                 <a:solidFill>
                   <a:srgbClr val="06B6D4"/>
                 </a:solidFill>
               </a:defRPr>
             </a:pPr>
             <a:r>
-              <a:t>$500 Billion SAM</a:t>
+              <a:t>World Bank Landmark Report</a:t>
             </a:r>
           </a:p>
           <a:p>
             <a:pPr>
-              <a:defRPr sz="1300">
+              <a:defRPr sz="1300" b="1">
+                <a:solidFill>
+                  <a:srgbClr val="FFFFFF"/>
+                </a:solidFill>
+              </a:defRPr>
+            </a:pPr>
+            <a:r>
+              <a:t>"Disruptive Technologies in Public Procurement" (Jan 2021)</a:t>
+            </a:r>
+          </a:p>
+          <a:p>
+            <a:br/>
+            <a:pPr>
+              <a:defRPr sz="1200">
                 <a:solidFill>
                   <a:srgbClr val="94A3B8"/>
                 </a:solidFill>
               </a:defRPr>
             </a:pPr>
             <a:r>
-              <a:t>Multilateral Development Bank Tenders (Immediate Beachhead)</a:t>
-            </a:r>
-          </a:p>
-        </p:txBody>
-      </p:sp>
-      <p:sp>
-        <p:nvSpPr>
-          <p:cNvPr id="8" name="Rounded Rectangle 7"/>
-          <p:cNvSpPr/>
-          <p:nvPr/>
-        </p:nvSpPr>
-        <p:spPr>
-          <a:xfrm>
-            <a:off x="6400800" y="4069080"/>
-            <a:ext cx="4846320" cy="2057400"/>
-          </a:xfrm>
-          <a:prstGeom prst="roundRect">
-            <a:avLst/>
-          </a:prstGeom>
-          <a:solidFill>
-            <a:srgbClr val="12192D"/>
-          </a:solidFill>
-          <a:ln w="19050">
-            <a:solidFill>
-              <a:srgbClr val="A855F7"/>
-            </a:solidFill>
-          </a:ln>
-        </p:spPr>
-        <p:style>
-          <a:lnRef idx="1">
-            <a:schemeClr val="accent1"/>
-          </a:lnRef>
-          <a:fillRef idx="3">
-            <a:schemeClr val="accent1"/>
-          </a:fillRef>
-          <a:effectRef idx="2">
-            <a:schemeClr val="accent1"/>
-          </a:effectRef>
-          <a:fontRef idx="minor">
-            <a:schemeClr val="lt1"/>
-          </a:fontRef>
-        </p:style>
-        <p:txBody>
-          <a:bodyPr rtlCol="0" anchor="ctr"/>
-          <a:lstStyle/>
-          <a:p>
-            <a:pPr algn="ctr"/>
-          </a:p>
-        </p:txBody>
-      </p:sp>
-      <p:sp>
-        <p:nvSpPr>
-          <p:cNvPr id="9" name="TextBox 8"/>
-          <p:cNvSpPr txBox="1"/>
-          <p:nvPr/>
-        </p:nvSpPr>
-        <p:spPr>
-          <a:xfrm>
-            <a:off x="6675120" y="4251960"/>
-            <a:ext cx="4297680" cy="1737360"/>
-          </a:xfrm>
-          <a:prstGeom prst="rect">
-            <a:avLst/>
-          </a:prstGeom>
-          <a:noFill/>
-        </p:spPr>
-        <p:txBody>
-          <a:bodyPr wrap="square">
-            <a:spAutoFit/>
-          </a:bodyPr>
-          <a:lstStyle/>
-          <a:p>
-            <a:pPr>
-              <a:defRPr sz="3000" b="1">
-                <a:solidFill>
-                  <a:srgbClr val="A855F7"/>
-                </a:solidFill>
-              </a:defRPr>
-            </a:pPr>
-            <a:r>
-              <a:t>$13.0 Trillion TAM</a:t>
-            </a:r>
-          </a:p>
-          <a:p>
-            <a:pPr>
-              <a:defRPr sz="1300">
-                <a:solidFill>
-                  <a:srgbClr val="94A3B8"/>
-                </a:solidFill>
-              </a:defRPr>
-            </a:pPr>
-            <a:r>
-              <a:t>Total Annual Global Public Infrastructure Procurement</a:t>
+              <a:t>Explicitly validated blockchain's anti-corruption power, but cited 3 key hurdles:</a:t>
+            </a:r>
+            <a:br/>
+            <a:br/>
+            <a:r>
+              <a:t>1. Commercial Privacy Risk ➔ BidTrace AES-256 Dual Envelopes</a:t>
+            </a:r>
+            <a:br/>
+            <a:r>
+              <a:t>2. Gas Fee Volatility ➔ Solana $0.00025 sub-second txs</a:t>
+            </a:r>
+            <a:br/>
+            <a:r>
+              <a:t>3. Crypto Legal Restrictions ➔ Zero-Fiat Gas Relayer</a:t>
+            </a:r>
+            <a:br/>
+            <a:br/>
+            <a:r>
+              <a:t>✓ BidTrace is purpose-built to answer the World Bank's roadmap.</a:t>
             </a:r>
           </a:p>
         </p:txBody>
@@ -5639,11 +5735,11 @@
             <a:avLst/>
           </a:prstGeom>
           <a:solidFill>
-            <a:srgbClr val="0A0F1D"/>
+            <a:srgbClr val="070B16"/>
           </a:solidFill>
           <a:ln>
             <a:solidFill>
-              <a:srgbClr val="0A0F1D"/>
+              <a:srgbClr val="070B16"/>
             </a:solidFill>
           </a:ln>
         </p:spPr>
@@ -5677,7 +5773,7 @@
         </p:nvSpPr>
         <p:spPr>
           <a:xfrm>
-            <a:off x="914400" y="548640"/>
+            <a:off x="914400" y="502920"/>
             <a:ext cx="10332720" cy="1005840"/>
           </a:xfrm>
           <a:prstGeom prst="rect">
@@ -5699,19 +5795,19 @@
               </a:defRPr>
             </a:pPr>
             <a:r>
-              <a:t>TRACTION &amp; VERIFIED EXECUTION</a:t>
+              <a:t>BUSINESS MODEL &amp; MONETIZATION</a:t>
             </a:r>
           </a:p>
           <a:p>
             <a:pPr>
-              <a:defRPr sz="3400" b="1">
+              <a:defRPr sz="3200" b="1">
                 <a:solidFill>
                   <a:srgbClr val="FFFFFF"/>
                 </a:solidFill>
               </a:defRPr>
             </a:pPr>
             <a:r>
-              <a:t>“This Is Already Working Live on Solana”</a:t>
+              <a:t>High-Margin GovTech SaaS with 200x Anti-Corruption ROI</a:t>
             </a:r>
           </a:p>
         </p:txBody>
@@ -5724,18 +5820,18 @@
         </p:nvSpPr>
         <p:spPr>
           <a:xfrm>
-            <a:off x="914400" y="1737360"/>
-            <a:ext cx="2468880" cy="4389120"/>
+            <a:off x="914400" y="1691640"/>
+            <a:ext cx="3291840" cy="3383280"/>
           </a:xfrm>
           <a:prstGeom prst="roundRect">
             <a:avLst/>
           </a:prstGeom>
           <a:solidFill>
-            <a:srgbClr val="12192D"/>
+            <a:srgbClr val="0C1326"/>
           </a:solidFill>
           <a:ln w="19050">
             <a:solidFill>
-              <a:srgbClr val="1E2946"/>
+              <a:srgbClr val="1C2848"/>
             </a:solidFill>
           </a:ln>
         </p:spPr>
@@ -5769,8 +5865,8 @@
         </p:nvSpPr>
         <p:spPr>
           <a:xfrm>
-            <a:off x="1051560" y="2011680"/>
-            <a:ext cx="2194560" cy="3840480"/>
+            <a:off x="1097280" y="1874519"/>
+            <a:ext cx="2926080" cy="3017520"/>
           </a:xfrm>
           <a:prstGeom prst="rect">
             <a:avLst/>
@@ -5784,26 +5880,26 @@
           <a:lstStyle/>
           <a:p>
             <a:pPr>
-              <a:defRPr sz="3600" b="1">
+              <a:defRPr sz="1800" b="1">
                 <a:solidFill>
                   <a:srgbClr val="06B6D4"/>
                 </a:solidFill>
               </a:defRPr>
             </a:pPr>
             <a:r>
-              <a:t>10</a:t>
+              <a:t>Enterprise GovTech SaaS</a:t>
             </a:r>
           </a:p>
           <a:p>
             <a:pPr>
-              <a:defRPr sz="1600" b="1">
+              <a:defRPr sz="1300" b="1">
                 <a:solidFill>
                   <a:srgbClr val="FFFFFF"/>
                 </a:solidFill>
               </a:defRPr>
             </a:pPr>
             <a:r>
-              <a:t>Anchor Instructions</a:t>
+              <a:t>$50k – $250k / Year</a:t>
             </a:r>
           </a:p>
           <a:p>
@@ -5816,7 +5912,7 @@
               </a:defRPr>
             </a:pPr>
             <a:r>
-              <a:t>Deployed on Solana Devnet (x3iSm5BC...ESjZ)</a:t>
+              <a:t>Annual license for ministries, public utilities &amp; large EPC developers. Turnkey e-GP integration.</a:t>
             </a:r>
           </a:p>
         </p:txBody>
@@ -5829,18 +5925,18 @@
         </p:nvSpPr>
         <p:spPr>
           <a:xfrm>
-            <a:off x="3547872" y="1737360"/>
-            <a:ext cx="2468880" cy="4389120"/>
+            <a:off x="4434840" y="1691640"/>
+            <a:ext cx="3291840" cy="3383280"/>
           </a:xfrm>
           <a:prstGeom prst="roundRect">
             <a:avLst/>
           </a:prstGeom>
           <a:solidFill>
-            <a:srgbClr val="12192D"/>
+            <a:srgbClr val="0C1326"/>
           </a:solidFill>
           <a:ln w="19050">
             <a:solidFill>
-              <a:srgbClr val="1E2946"/>
+              <a:srgbClr val="1C2848"/>
             </a:solidFill>
           </a:ln>
         </p:spPr>
@@ -5874,8 +5970,8 @@
         </p:nvSpPr>
         <p:spPr>
           <a:xfrm>
-            <a:off x="3685032" y="2011680"/>
-            <a:ext cx="2194560" cy="3840480"/>
+            <a:off x="4617720" y="1874519"/>
+            <a:ext cx="2926080" cy="3017520"/>
           </a:xfrm>
           <a:prstGeom prst="rect">
             <a:avLst/>
@@ -5889,26 +5985,26 @@
           <a:lstStyle/>
           <a:p>
             <a:pPr>
-              <a:defRPr sz="3600" b="1">
-                <a:solidFill>
-                  <a:srgbClr val="10B981"/>
+              <a:defRPr sz="1800" b="1">
+                <a:solidFill>
+                  <a:srgbClr val="A855F7"/>
                 </a:solidFill>
               </a:defRPr>
             </a:pPr>
             <a:r>
-              <a:t>78 / 78</a:t>
+              <a:t>Per-Tender Integrity Fee</a:t>
             </a:r>
           </a:p>
           <a:p>
             <a:pPr>
-              <a:defRPr sz="1600" b="1">
+              <a:defRPr sz="1300" b="1">
                 <a:solidFill>
                   <a:srgbClr val="FFFFFF"/>
                 </a:solidFill>
               </a:defRPr>
             </a:pPr>
             <a:r>
-              <a:t>Passing Unit Tests</a:t>
+              <a:t>0.05% of Tender Value</a:t>
             </a:r>
           </a:p>
           <a:p>
@@ -5921,7 +6017,7 @@
               </a:defRPr>
             </a:pPr>
             <a:r>
-              <a:t>100% Cross-Language RFC 8785 Parity</a:t>
+              <a:t>Funded directly from existing contractor submission fees charged on every tender.</a:t>
             </a:r>
           </a:p>
         </p:txBody>
@@ -5934,18 +6030,18 @@
         </p:nvSpPr>
         <p:spPr>
           <a:xfrm>
-            <a:off x="6181344" y="1737360"/>
-            <a:ext cx="2468880" cy="4389120"/>
+            <a:off x="7955279" y="1691640"/>
+            <a:ext cx="3291840" cy="3383280"/>
           </a:xfrm>
           <a:prstGeom prst="roundRect">
             <a:avLst/>
           </a:prstGeom>
           <a:solidFill>
-            <a:srgbClr val="12192D"/>
+            <a:srgbClr val="0C1326"/>
           </a:solidFill>
           <a:ln w="19050">
             <a:solidFill>
-              <a:srgbClr val="1E2946"/>
+              <a:srgbClr val="1C2848"/>
             </a:solidFill>
           </a:ln>
         </p:spPr>
@@ -5979,8 +6075,8 @@
         </p:nvSpPr>
         <p:spPr>
           <a:xfrm>
-            <a:off x="6318504" y="2011680"/>
-            <a:ext cx="2194560" cy="3840480"/>
+            <a:off x="8138159" y="1874519"/>
+            <a:ext cx="2926080" cy="3017520"/>
           </a:xfrm>
           <a:prstGeom prst="rect">
             <a:avLst/>
@@ -5994,26 +6090,26 @@
           <a:lstStyle/>
           <a:p>
             <a:pPr>
-              <a:defRPr sz="3600" b="1">
-                <a:solidFill>
-                  <a:srgbClr val="F43F5E"/>
+              <a:defRPr sz="1800" b="1">
+                <a:solidFill>
+                  <a:srgbClr val="10B981"/>
                 </a:solidFill>
               </a:defRPr>
             </a:pPr>
             <a:r>
-              <a:t>1-Click</a:t>
+              <a:t>Institutional Cascade</a:t>
             </a:r>
           </a:p>
           <a:p>
             <a:pPr>
-              <a:defRPr sz="1600" b="1">
+              <a:defRPr sz="1300" b="1">
                 <a:solidFill>
                   <a:srgbClr val="FFFFFF"/>
                 </a:solidFill>
               </a:defRPr>
             </a:pPr>
             <a:r>
-              <a:t>Attack Simulator</a:t>
+              <a:t>189 Member Countries</a:t>
             </a:r>
           </a:p>
           <a:p>
@@ -6026,7 +6122,7 @@
               </a:defRPr>
             </a:pPr>
             <a:r>
-              <a:t>Live On-Chain Exploits Blocked in Real-Time</a:t>
+              <a:t>When World Bank or ADB mandates BidTrace on loan tranches, adoption cascades with zero CAC.</a:t>
             </a:r>
           </a:p>
         </p:txBody>
@@ -6039,18 +6135,18 @@
         </p:nvSpPr>
         <p:spPr>
           <a:xfrm>
-            <a:off x="8814816" y="1737360"/>
-            <a:ext cx="2468880" cy="4389120"/>
+            <a:off x="914400" y="5303520"/>
+            <a:ext cx="10360152" cy="1005840"/>
           </a:xfrm>
           <a:prstGeom prst="roundRect">
             <a:avLst/>
           </a:prstGeom>
           <a:solidFill>
-            <a:srgbClr val="12192D"/>
+            <a:srgbClr val="0C1C30"/>
           </a:solidFill>
           <a:ln w="19050">
             <a:solidFill>
-              <a:srgbClr val="1E2946"/>
+              <a:srgbClr val="10B981"/>
             </a:solidFill>
           </a:ln>
         </p:spPr>
@@ -6084,8 +6180,8 @@
         </p:nvSpPr>
         <p:spPr>
           <a:xfrm>
-            <a:off x="8951976" y="2011680"/>
-            <a:ext cx="2194560" cy="3840480"/>
+            <a:off x="1097280" y="5440680"/>
+            <a:ext cx="9966960" cy="731520"/>
           </a:xfrm>
           <a:prstGeom prst="rect">
             <a:avLst/>
@@ -6099,39 +6195,26 @@
           <a:lstStyle/>
           <a:p>
             <a:pPr>
-              <a:defRPr sz="3600" b="1">
-                <a:solidFill>
-                  <a:srgbClr val="A855F7"/>
+              <a:defRPr sz="1400" b="1">
+                <a:solidFill>
+                  <a:srgbClr val="10B981"/>
                 </a:solidFill>
               </a:defRPr>
             </a:pPr>
             <a:r>
-              <a:t>0 Deadlock</a:t>
-            </a:r>
-          </a:p>
-          <a:p>
-            <a:pPr>
-              <a:defRPr sz="1600" b="1">
-                <a:solidFill>
-                  <a:srgbClr val="FFFFFF"/>
-                </a:solidFill>
-              </a:defRPr>
-            </a:pPr>
-            <a:r>
-              <a:t>Leaf State Machine</a:t>
-            </a:r>
-          </a:p>
-          <a:p>
-            <a:br/>
+              <a:t>THE CUSTOMER MATH: 200x RETURN ON INVESTMENT</a:t>
+            </a:r>
+          </a:p>
+          <a:p>
             <a:pPr>
               <a:defRPr sz="1300">
                 <a:solidFill>
-                  <a:srgbClr val="94A3B8"/>
+                  <a:srgbClr val="FFFFFF"/>
                 </a:solidFill>
               </a:defRPr>
             </a:pPr>
             <a:r>
-              <a:t>Rogue bidder default cannot freeze compliant tenders.</a:t>
+              <a:t>Eliminates a 20%–25% corruption loss for a &lt;0.1% platform cost. Fits directly into existing public budget lines.</a:t>
             </a:r>
           </a:p>
         </p:txBody>
@@ -6169,11 +6252,11 @@
             <a:avLst/>
           </a:prstGeom>
           <a:solidFill>
-            <a:srgbClr val="0A0F1D"/>
+            <a:srgbClr val="070B16"/>
           </a:solidFill>
           <a:ln>
             <a:solidFill>
-              <a:srgbClr val="0A0F1D"/>
+              <a:srgbClr val="070B16"/>
             </a:solidFill>
           </a:ln>
         </p:spPr>
@@ -6207,7 +6290,7 @@
         </p:nvSpPr>
         <p:spPr>
           <a:xfrm>
-            <a:off x="914400" y="548640"/>
+            <a:off x="914400" y="502920"/>
             <a:ext cx="10332720" cy="1005840"/>
           </a:xfrm>
           <a:prstGeom prst="rect">
@@ -6224,24 +6307,24 @@
             <a:pPr>
               <a:defRPr sz="1300" b="1">
                 <a:solidFill>
-                  <a:srgbClr val="06B6D4"/>
+                  <a:srgbClr val="F59E0B"/>
                 </a:solidFill>
               </a:defRPr>
             </a:pPr>
             <a:r>
-              <a:t>NETWORK EFFECTS &amp; SUSTAINABLE REVENUE</a:t>
+              <a:t>TEAM / WHY ME?</a:t>
             </a:r>
           </a:p>
           <a:p>
             <a:pPr>
-              <a:defRPr sz="3400" b="1">
+              <a:defRPr sz="3200" b="1">
                 <a:solidFill>
                   <a:srgbClr val="FFFFFF"/>
                 </a:solidFill>
               </a:defRPr>
             </a:pPr>
             <a:r>
-              <a:t>“Why This Keeps Growing: The Relayer Moat”</a:t>
+              <a:t>Law + Banking NPA Forensics + Cryptography</a:t>
             </a:r>
           </a:p>
         </p:txBody>
@@ -6254,18 +6337,18 @@
         </p:nvSpPr>
         <p:spPr>
           <a:xfrm>
-            <a:off x="914400" y="1737360"/>
-            <a:ext cx="4937760" cy="4389120"/>
+            <a:off x="914400" y="1691640"/>
+            <a:ext cx="3291840" cy="3291840"/>
           </a:xfrm>
           <a:prstGeom prst="roundRect">
             <a:avLst/>
           </a:prstGeom>
           <a:solidFill>
-            <a:srgbClr val="12192D"/>
+            <a:srgbClr val="0C1326"/>
           </a:solidFill>
           <a:ln w="19050">
             <a:solidFill>
-              <a:srgbClr val="06B6D4"/>
+              <a:srgbClr val="1C2848"/>
             </a:solidFill>
           </a:ln>
         </p:spPr>
@@ -6299,8 +6382,8 @@
         </p:nvSpPr>
         <p:spPr>
           <a:xfrm>
-            <a:off x="1188720" y="2011680"/>
-            <a:ext cx="4389120" cy="3840480"/>
+            <a:off x="1097280" y="1874519"/>
+            <a:ext cx="2926080" cy="2926080"/>
           </a:xfrm>
           <a:prstGeom prst="rect">
             <a:avLst/>
@@ -6314,35 +6397,39 @@
           <a:lstStyle/>
           <a:p>
             <a:pPr>
-              <a:defRPr sz="2000" b="1">
-                <a:solidFill>
-                  <a:srgbClr val="06B6D4"/>
+              <a:defRPr sz="1800" b="1">
+                <a:solidFill>
+                  <a:srgbClr val="F59E0B"/>
                 </a:solidFill>
               </a:defRPr>
             </a:pPr>
             <a:r>
-              <a:t>Monetization Streams</a:t>
+              <a:t>Commercial Lawyer</a:t>
+            </a:r>
+          </a:p>
+          <a:p>
+            <a:pPr>
+              <a:defRPr sz="1200" b="1">
+                <a:solidFill>
+                  <a:srgbClr val="94A3B8"/>
+                </a:solidFill>
+              </a:defRPr>
+            </a:pPr>
+            <a:r>
+              <a:t>Legal &amp; Regulatory</a:t>
             </a:r>
           </a:p>
           <a:p>
             <a:br/>
             <a:pPr>
-              <a:defRPr sz="1400">
+              <a:defRPr sz="1300">
                 <a:solidFill>
                   <a:srgbClr val="FFFFFF"/>
                 </a:solidFill>
               </a:defRPr>
             </a:pPr>
             <a:r>
-              <a:t>• 0.05% Protocol Take-Rate: Settled contract volume ($250M ARR at 1% market penetration).</a:t>
-            </a:r>
-            <a:br/>
-            <a:r>
-              <a:t>• Surety Underwriting API: Verification fees paid by commercial surety bond providers.</a:t>
-            </a:r>
-            <a:br/>
-            <a:r>
-              <a:t>• Zero Crypto Gas: Relayer eliminates balance friction for enterprise bidders.</a:t>
+              <a:t>Deep expertise in Public Procurement Acts, FIDIC contracts, and tender dispute arbitration.</a:t>
             </a:r>
           </a:p>
         </p:txBody>
@@ -6355,8 +6442,218 @@
         </p:nvSpPr>
         <p:spPr>
           <a:xfrm>
-            <a:off x="6217920" y="1737360"/>
-            <a:ext cx="5029200" cy="4389120"/>
+            <a:off x="4434840" y="1691640"/>
+            <a:ext cx="3291840" cy="3291840"/>
+          </a:xfrm>
+          <a:prstGeom prst="roundRect">
+            <a:avLst/>
+          </a:prstGeom>
+          <a:solidFill>
+            <a:srgbClr val="0C1326"/>
+          </a:solidFill>
+          <a:ln w="19050">
+            <a:solidFill>
+              <a:srgbClr val="1C2848"/>
+            </a:solidFill>
+          </a:ln>
+        </p:spPr>
+        <p:style>
+          <a:lnRef idx="1">
+            <a:schemeClr val="accent1"/>
+          </a:lnRef>
+          <a:fillRef idx="3">
+            <a:schemeClr val="accent1"/>
+          </a:fillRef>
+          <a:effectRef idx="2">
+            <a:schemeClr val="accent1"/>
+          </a:effectRef>
+          <a:fontRef idx="minor">
+            <a:schemeClr val="lt1"/>
+          </a:fontRef>
+        </p:style>
+        <p:txBody>
+          <a:bodyPr rtlCol="0" anchor="ctr"/>
+          <a:lstStyle/>
+          <a:p>
+            <a:pPr algn="ctr"/>
+          </a:p>
+        </p:txBody>
+      </p:sp>
+      <p:sp>
+        <p:nvSpPr>
+          <p:cNvPr id="7" name="TextBox 6"/>
+          <p:cNvSpPr txBox="1"/>
+          <p:nvPr/>
+        </p:nvSpPr>
+        <p:spPr>
+          <a:xfrm>
+            <a:off x="4617720" y="1874519"/>
+            <a:ext cx="2926080" cy="2926080"/>
+          </a:xfrm>
+          <a:prstGeom prst="rect">
+            <a:avLst/>
+          </a:prstGeom>
+          <a:noFill/>
+        </p:spPr>
+        <p:txBody>
+          <a:bodyPr wrap="square">
+            <a:spAutoFit/>
+          </a:bodyPr>
+          <a:lstStyle/>
+          <a:p>
+            <a:pPr>
+              <a:defRPr sz="1800" b="1">
+                <a:solidFill>
+                  <a:srgbClr val="06B6D4"/>
+                </a:solidFill>
+              </a:defRPr>
+            </a:pPr>
+            <a:r>
+              <a:t>Commercial Bank NPA</a:t>
+            </a:r>
+          </a:p>
+          <a:p>
+            <a:pPr>
+              <a:defRPr sz="1200" b="1">
+                <a:solidFill>
+                  <a:srgbClr val="94A3B8"/>
+                </a:solidFill>
+              </a:defRPr>
+            </a:pPr>
+            <a:r>
+              <a:t>Forensic Recovery</a:t>
+            </a:r>
+          </a:p>
+          <a:p>
+            <a:br/>
+            <a:pPr>
+              <a:defRPr sz="1300">
+                <a:solidFill>
+                  <a:srgbClr val="FFFFFF"/>
+                </a:solidFill>
+              </a:defRPr>
+            </a:pPr>
+            <a:r>
+              <a:t>Investigated bad loans, defaulted contractor bank guarantees (MT760), and fraudulent tenders up close.</a:t>
+            </a:r>
+          </a:p>
+        </p:txBody>
+      </p:sp>
+      <p:sp>
+        <p:nvSpPr>
+          <p:cNvPr id="8" name="Rounded Rectangle 7"/>
+          <p:cNvSpPr/>
+          <p:nvPr/>
+        </p:nvSpPr>
+        <p:spPr>
+          <a:xfrm>
+            <a:off x="7955279" y="1691640"/>
+            <a:ext cx="3291840" cy="3291840"/>
+          </a:xfrm>
+          <a:prstGeom prst="roundRect">
+            <a:avLst/>
+          </a:prstGeom>
+          <a:solidFill>
+            <a:srgbClr val="0C1326"/>
+          </a:solidFill>
+          <a:ln w="19050">
+            <a:solidFill>
+              <a:srgbClr val="1C2848"/>
+            </a:solidFill>
+          </a:ln>
+        </p:spPr>
+        <p:style>
+          <a:lnRef idx="1">
+            <a:schemeClr val="accent1"/>
+          </a:lnRef>
+          <a:fillRef idx="3">
+            <a:schemeClr val="accent1"/>
+          </a:fillRef>
+          <a:effectRef idx="2">
+            <a:schemeClr val="accent1"/>
+          </a:effectRef>
+          <a:fontRef idx="minor">
+            <a:schemeClr val="lt1"/>
+          </a:fontRef>
+        </p:style>
+        <p:txBody>
+          <a:bodyPr rtlCol="0" anchor="ctr"/>
+          <a:lstStyle/>
+          <a:p>
+            <a:pPr algn="ctr"/>
+          </a:p>
+        </p:txBody>
+      </p:sp>
+      <p:sp>
+        <p:nvSpPr>
+          <p:cNvPr id="9" name="TextBox 8"/>
+          <p:cNvSpPr txBox="1"/>
+          <p:nvPr/>
+        </p:nvSpPr>
+        <p:spPr>
+          <a:xfrm>
+            <a:off x="8138159" y="1874519"/>
+            <a:ext cx="2926080" cy="2926080"/>
+          </a:xfrm>
+          <a:prstGeom prst="rect">
+            <a:avLst/>
+          </a:prstGeom>
+          <a:noFill/>
+        </p:spPr>
+        <p:txBody>
+          <a:bodyPr wrap="square">
+            <a:spAutoFit/>
+          </a:bodyPr>
+          <a:lstStyle/>
+          <a:p>
+            <a:pPr>
+              <a:defRPr sz="1800" b="1">
+                <a:solidFill>
+                  <a:srgbClr val="A855F7"/>
+                </a:solidFill>
+              </a:defRPr>
+            </a:pPr>
+            <a:r>
+              <a:t>Cryptographic Systems</a:t>
+            </a:r>
+          </a:p>
+          <a:p>
+            <a:pPr>
+              <a:defRPr sz="1200" b="1">
+                <a:solidFill>
+                  <a:srgbClr val="94A3B8"/>
+                </a:solidFill>
+              </a:defRPr>
+            </a:pPr>
+            <a:r>
+              <a:t>Engineering Architecture</a:t>
+            </a:r>
+          </a:p>
+          <a:p>
+            <a:br/>
+            <a:pPr>
+              <a:defRPr sz="1300">
+                <a:solidFill>
+                  <a:srgbClr val="FFFFFF"/>
+                </a:solidFill>
+              </a:defRPr>
+            </a:pPr>
+            <a:r>
+              <a:t>Built the full-stack BidTrace protocol on Solana: Anchor smart contracts, OCDS 1.1, and gas relayer.</a:t>
+            </a:r>
+          </a:p>
+        </p:txBody>
+      </p:sp>
+      <p:sp>
+        <p:nvSpPr>
+          <p:cNvPr id="10" name="Rounded Rectangle 9"/>
+          <p:cNvSpPr/>
+          <p:nvPr/>
+        </p:nvSpPr>
+        <p:spPr>
+          <a:xfrm>
+            <a:off x="914400" y="5212080"/>
+            <a:ext cx="10360152" cy="1097280"/>
           </a:xfrm>
           <a:prstGeom prst="roundRect">
             <a:avLst/>
@@ -6366,7 +6663,7 @@
           </a:solidFill>
           <a:ln w="19050">
             <a:solidFill>
-              <a:srgbClr val="A855F7"/>
+              <a:srgbClr val="06B6D4"/>
             </a:solidFill>
           </a:ln>
         </p:spPr>
@@ -6394,14 +6691,14 @@
       </p:sp>
       <p:sp>
         <p:nvSpPr>
-          <p:cNvPr id="7" name="TextBox 6"/>
+          <p:cNvPr id="11" name="TextBox 10"/>
           <p:cNvSpPr txBox="1"/>
           <p:nvPr/>
         </p:nvSpPr>
         <p:spPr>
           <a:xfrm>
-            <a:off x="6492240" y="2011680"/>
-            <a:ext cx="4480560" cy="3840480"/>
+            <a:off x="1097280" y="5349240"/>
+            <a:ext cx="9966960" cy="822960"/>
           </a:xfrm>
           <a:prstGeom prst="rect">
             <a:avLst/>
@@ -6415,35 +6712,26 @@
           <a:lstStyle/>
           <a:p>
             <a:pPr>
-              <a:defRPr sz="2000" b="1">
-                <a:solidFill>
-                  <a:srgbClr val="A855F7"/>
+              <a:defRPr sz="1300" b="1">
+                <a:solidFill>
+                  <a:srgbClr val="06B6D4"/>
                 </a:solidFill>
               </a:defRPr>
             </a:pPr>
             <a:r>
-              <a:t>Network Effects &amp; Moat</a:t>
-            </a:r>
-          </a:p>
-          <a:p>
-            <a:br/>
+              <a:t>LIVE PROTOCOL EXECUTION STATUS</a:t>
+            </a:r>
+          </a:p>
+          <a:p>
             <a:pPr>
-              <a:defRPr sz="1400">
+              <a:defRPr sz="1300">
                 <a:solidFill>
                   <a:srgbClr val="FFFFFF"/>
                 </a:solidFill>
               </a:defRPr>
             </a:pPr>
             <a:r>
-              <a:t>• Municipal Flywheel: Each city onboarded locks regional contractors into the BidTrace relayer.</a:t>
-            </a:r>
-            <a:br/>
-            <a:r>
-              <a:t>• Relayer Sticky Moat: Enterprise API contracts ensure sustainable long-term cash flow.</a:t>
-            </a:r>
-            <a:br/>
-            <a:r>
-              <a:t>• Standards Lock-In: Becomes the mandatory OCDS 1.1 compliance referee.</a:t>
+              <a:t>10 Anchor Instructions on Devnet  |  78/78 Passing Unit Tests  |  Live 1-Click Attack Simulator</a:t>
             </a:r>
           </a:p>
         </p:txBody>
@@ -6481,11 +6769,11 @@
             <a:avLst/>
           </a:prstGeom>
           <a:solidFill>
-            <a:srgbClr val="0A0F1D"/>
+            <a:srgbClr val="070B16"/>
           </a:solidFill>
           <a:ln>
             <a:solidFill>
-              <a:srgbClr val="0A0F1D"/>
+              <a:srgbClr val="070B16"/>
             </a:solidFill>
           </a:ln>
         </p:spPr>
@@ -6511,16 +6799,40 @@
           </a:p>
         </p:txBody>
       </p:sp>
-      <p:sp>
-        <p:nvSpPr>
-          <p:cNvPr id="3" name="TextBox 2"/>
+      <p:pic>
+        <p:nvPicPr>
+          <p:cNvPr id="3" name="Picture 2" descr="logo-mark.png"/>
+          <p:cNvPicPr>
+            <a:picLocks noChangeAspect="1"/>
+          </p:cNvPicPr>
+          <p:nvPr/>
+        </p:nvPicPr>
+        <p:blipFill>
+          <a:blip r:embed="rId2"/>
+          <a:stretch>
+            <a:fillRect/>
+          </a:stretch>
+        </p:blipFill>
+        <p:spPr>
+          <a:xfrm>
+            <a:off x="5303520" y="1097280"/>
+            <a:ext cx="1554480" cy="1754608"/>
+          </a:xfrm>
+          <a:prstGeom prst="rect">
+            <a:avLst/>
+          </a:prstGeom>
+        </p:spPr>
+      </p:pic>
+      <p:sp>
+        <p:nvSpPr>
+          <p:cNvPr id="4" name="TextBox 3"/>
           <p:cNvSpPr txBox="1"/>
           <p:nvPr/>
         </p:nvSpPr>
         <p:spPr>
           <a:xfrm>
-            <a:off x="914400" y="548640"/>
-            <a:ext cx="10332720" cy="1005840"/>
+            <a:off x="914400" y="2743200"/>
+            <a:ext cx="10360152" cy="1280160"/>
           </a:xfrm>
           <a:prstGeom prst="rect">
             <a:avLst/>
@@ -6528,367 +6840,52 @@
           <a:noFill/>
         </p:spPr>
         <p:txBody>
-          <a:bodyPr wrap="none">
+          <a:bodyPr wrap="square">
             <a:spAutoFit/>
           </a:bodyPr>
           <a:lstStyle/>
           <a:p>
-            <a:pPr>
-              <a:defRPr sz="1300" b="1">
-                <a:solidFill>
-                  <a:srgbClr val="F59E0B"/>
+            <a:pPr algn="ctr">
+              <a:defRPr sz="5000" b="1">
+                <a:solidFill>
+                  <a:srgbClr val="FFFFFF"/>
                 </a:solidFill>
               </a:defRPr>
             </a:pPr>
             <a:r>
-              <a:t>FOUNDER-PROBLEM FIT</a:t>
-            </a:r>
-          </a:p>
-          <a:p>
-            <a:pPr>
-              <a:defRPr sz="3400" b="1">
-                <a:solidFill>
-                  <a:srgbClr val="FFFFFF"/>
+              <a:t>BidTrace</a:t>
+            </a:r>
+          </a:p>
+          <a:p>
+            <a:pPr algn="ctr">
+              <a:defRPr sz="2800" b="1">
+                <a:solidFill>
+                  <a:srgbClr val="06B6D4"/>
                 </a:solidFill>
               </a:defRPr>
             </a:pPr>
             <a:r>
-              <a:t>Built for Sovereign Cryptographic Settlement</a:t>
-            </a:r>
-          </a:p>
-        </p:txBody>
-      </p:sp>
-      <p:sp>
-        <p:nvSpPr>
-          <p:cNvPr id="4" name="Rounded Rectangle 3"/>
+              <a:t>"Goodbye Bid Rigging."</a:t>
+            </a:r>
+          </a:p>
+        </p:txBody>
+      </p:sp>
+      <p:sp>
+        <p:nvSpPr>
+          <p:cNvPr id="5" name="Rounded Rectangle 4"/>
           <p:cNvSpPr/>
           <p:nvPr/>
         </p:nvSpPr>
         <p:spPr>
           <a:xfrm>
-            <a:off x="914400" y="1737360"/>
-            <a:ext cx="3291840" cy="3474720"/>
+            <a:off x="2011680" y="4297680"/>
+            <a:ext cx="3840480" cy="1554480"/>
           </a:xfrm>
           <a:prstGeom prst="roundRect">
             <a:avLst/>
           </a:prstGeom>
           <a:solidFill>
-            <a:srgbClr val="12192D"/>
-          </a:solidFill>
-          <a:ln w="19050">
-            <a:solidFill>
-              <a:srgbClr val="1E2946"/>
-            </a:solidFill>
-          </a:ln>
-        </p:spPr>
-        <p:style>
-          <a:lnRef idx="1">
-            <a:schemeClr val="accent1"/>
-          </a:lnRef>
-          <a:fillRef idx="3">
-            <a:schemeClr val="accent1"/>
-          </a:fillRef>
-          <a:effectRef idx="2">
-            <a:schemeClr val="accent1"/>
-          </a:effectRef>
-          <a:fontRef idx="minor">
-            <a:schemeClr val="lt1"/>
-          </a:fontRef>
-        </p:style>
-        <p:txBody>
-          <a:bodyPr rtlCol="0" anchor="ctr"/>
-          <a:lstStyle/>
-          <a:p>
-            <a:pPr algn="ctr"/>
-          </a:p>
-        </p:txBody>
-      </p:sp>
-      <p:sp>
-        <p:nvSpPr>
-          <p:cNvPr id="5" name="TextBox 4"/>
-          <p:cNvSpPr txBox="1"/>
-          <p:nvPr/>
-        </p:nvSpPr>
-        <p:spPr>
-          <a:xfrm>
-            <a:off x="1097280" y="1920240"/>
-            <a:ext cx="2926080" cy="3108960"/>
-          </a:xfrm>
-          <a:prstGeom prst="rect">
-            <a:avLst/>
-          </a:prstGeom>
-          <a:noFill/>
-        </p:spPr>
-        <p:txBody>
-          <a:bodyPr wrap="square">
-            <a:spAutoFit/>
-          </a:bodyPr>
-          <a:lstStyle/>
-          <a:p>
-            <a:pPr>
-              <a:defRPr sz="1700" b="1">
-                <a:solidFill>
-                  <a:srgbClr val="06B6D4"/>
-                </a:solidFill>
-              </a:defRPr>
-            </a:pPr>
-            <a:r>
-              <a:t>Solana Anchor Systems</a:t>
-            </a:r>
-          </a:p>
-          <a:p>
-            <a:pPr>
-              <a:defRPr sz="1200" b="1">
-                <a:solidFill>
-                  <a:srgbClr val="94A3B8"/>
-                </a:solidFill>
-              </a:defRPr>
-            </a:pPr>
-            <a:r>
-              <a:t>High-Throughput State Machines</a:t>
-            </a:r>
-          </a:p>
-          <a:p>
-            <a:br/>
-            <a:pPr>
-              <a:defRPr sz="1300">
-                <a:solidFill>
-                  <a:srgbClr val="FFFFFF"/>
-                </a:solidFill>
-              </a:defRPr>
-            </a:pPr>
-            <a:r>
-              <a:t>Temporal slot phase locks, blinded commitments, and on-chain Olympic scoring algorithms.</a:t>
-            </a:r>
-          </a:p>
-        </p:txBody>
-      </p:sp>
-      <p:sp>
-        <p:nvSpPr>
-          <p:cNvPr id="6" name="Rounded Rectangle 5"/>
-          <p:cNvSpPr/>
-          <p:nvPr/>
-        </p:nvSpPr>
-        <p:spPr>
-          <a:xfrm>
-            <a:off x="4434840" y="1737360"/>
-            <a:ext cx="3291840" cy="3474720"/>
-          </a:xfrm>
-          <a:prstGeom prst="roundRect">
-            <a:avLst/>
-          </a:prstGeom>
-          <a:solidFill>
-            <a:srgbClr val="12192D"/>
-          </a:solidFill>
-          <a:ln w="19050">
-            <a:solidFill>
-              <a:srgbClr val="1E2946"/>
-            </a:solidFill>
-          </a:ln>
-        </p:spPr>
-        <p:style>
-          <a:lnRef idx="1">
-            <a:schemeClr val="accent1"/>
-          </a:lnRef>
-          <a:fillRef idx="3">
-            <a:schemeClr val="accent1"/>
-          </a:fillRef>
-          <a:effectRef idx="2">
-            <a:schemeClr val="accent1"/>
-          </a:effectRef>
-          <a:fontRef idx="minor">
-            <a:schemeClr val="lt1"/>
-          </a:fontRef>
-        </p:style>
-        <p:txBody>
-          <a:bodyPr rtlCol="0" anchor="ctr"/>
-          <a:lstStyle/>
-          <a:p>
-            <a:pPr algn="ctr"/>
-          </a:p>
-        </p:txBody>
-      </p:sp>
-      <p:sp>
-        <p:nvSpPr>
-          <p:cNvPr id="7" name="TextBox 6"/>
-          <p:cNvSpPr txBox="1"/>
-          <p:nvPr/>
-        </p:nvSpPr>
-        <p:spPr>
-          <a:xfrm>
-            <a:off x="4617720" y="1920240"/>
-            <a:ext cx="2926080" cy="3108960"/>
-          </a:xfrm>
-          <a:prstGeom prst="rect">
-            <a:avLst/>
-          </a:prstGeom>
-          <a:noFill/>
-        </p:spPr>
-        <p:txBody>
-          <a:bodyPr wrap="square">
-            <a:spAutoFit/>
-          </a:bodyPr>
-          <a:lstStyle/>
-          <a:p>
-            <a:pPr>
-              <a:defRPr sz="1700" b="1">
-                <a:solidFill>
-                  <a:srgbClr val="A855F7"/>
-                </a:solidFill>
-              </a:defRPr>
-            </a:pPr>
-            <a:r>
-              <a:t>OCDS 1.1 Cryptography</a:t>
-            </a:r>
-          </a:p>
-          <a:p>
-            <a:pPr>
-              <a:defRPr sz="1200" b="1">
-                <a:solidFill>
-                  <a:srgbClr val="94A3B8"/>
-                </a:solidFill>
-              </a:defRPr>
-            </a:pPr>
-            <a:r>
-              <a:t>World Bank Data Standard</a:t>
-            </a:r>
-          </a:p>
-          <a:p>
-            <a:br/>
-            <a:pPr>
-              <a:defRPr sz="1300">
-                <a:solidFill>
-                  <a:srgbClr val="FFFFFF"/>
-                </a:solidFill>
-              </a:defRPr>
-            </a:pPr>
-            <a:r>
-              <a:t>Deterministic RFC 8785 canonical hashing and open-contracting data schemas.</a:t>
-            </a:r>
-          </a:p>
-        </p:txBody>
-      </p:sp>
-      <p:sp>
-        <p:nvSpPr>
-          <p:cNvPr id="8" name="Rounded Rectangle 7"/>
-          <p:cNvSpPr/>
-          <p:nvPr/>
-        </p:nvSpPr>
-        <p:spPr>
-          <a:xfrm>
-            <a:off x="7955279" y="1737360"/>
-            <a:ext cx="3291840" cy="3474720"/>
-          </a:xfrm>
-          <a:prstGeom prst="roundRect">
-            <a:avLst/>
-          </a:prstGeom>
-          <a:solidFill>
-            <a:srgbClr val="12192D"/>
-          </a:solidFill>
-          <a:ln w="19050">
-            <a:solidFill>
-              <a:srgbClr val="1E2946"/>
-            </a:solidFill>
-          </a:ln>
-        </p:spPr>
-        <p:style>
-          <a:lnRef idx="1">
-            <a:schemeClr val="accent1"/>
-          </a:lnRef>
-          <a:fillRef idx="3">
-            <a:schemeClr val="accent1"/>
-          </a:fillRef>
-          <a:effectRef idx="2">
-            <a:schemeClr val="accent1"/>
-          </a:effectRef>
-          <a:fontRef idx="minor">
-            <a:schemeClr val="lt1"/>
-          </a:fontRef>
-        </p:style>
-        <p:txBody>
-          <a:bodyPr rtlCol="0" anchor="ctr"/>
-          <a:lstStyle/>
-          <a:p>
-            <a:pPr algn="ctr"/>
-          </a:p>
-        </p:txBody>
-      </p:sp>
-      <p:sp>
-        <p:nvSpPr>
-          <p:cNvPr id="9" name="TextBox 8"/>
-          <p:cNvSpPr txBox="1"/>
-          <p:nvPr/>
-        </p:nvSpPr>
-        <p:spPr>
-          <a:xfrm>
-            <a:off x="8138159" y="1920240"/>
-            <a:ext cx="2926080" cy="3108960"/>
-          </a:xfrm>
-          <a:prstGeom prst="rect">
-            <a:avLst/>
-          </a:prstGeom>
-          <a:noFill/>
-        </p:spPr>
-        <p:txBody>
-          <a:bodyPr wrap="square">
-            <a:spAutoFit/>
-          </a:bodyPr>
-          <a:lstStyle/>
-          <a:p>
-            <a:pPr>
-              <a:defRPr sz="1700" b="1">
-                <a:solidFill>
-                  <a:srgbClr val="10B981"/>
-                </a:solidFill>
-              </a:defRPr>
-            </a:pPr>
-            <a:r>
-              <a:t>B2G &amp; TradFi Relayers</a:t>
-            </a:r>
-          </a:p>
-          <a:p>
-            <a:pPr>
-              <a:defRPr sz="1200" b="1">
-                <a:solidFill>
-                  <a:srgbClr val="94A3B8"/>
-                </a:solidFill>
-              </a:defRPr>
-            </a:pPr>
-            <a:r>
-              <a:t>Zero-Friction Enterprise</a:t>
-            </a:r>
-          </a:p>
-          <a:p>
-            <a:br/>
-            <a:pPr>
-              <a:defRPr sz="1300">
-                <a:solidFill>
-                  <a:srgbClr val="FFFFFF"/>
-                </a:solidFill>
-              </a:defRPr>
-            </a:pPr>
-            <a:r>
-              <a:t>Zero-gas relayer and air-gapped cryptographic bidder receipts giving contractors legal standing.</a:t>
-            </a:r>
-          </a:p>
-        </p:txBody>
-      </p:sp>
-      <p:sp>
-        <p:nvSpPr>
-          <p:cNvPr id="10" name="Rounded Rectangle 9"/>
-          <p:cNvSpPr/>
-          <p:nvPr/>
-        </p:nvSpPr>
-        <p:spPr>
-          <a:xfrm>
-            <a:off x="914400" y="5440680"/>
-            <a:ext cx="10360152" cy="1051560"/>
-          </a:xfrm>
-          <a:prstGeom prst="roundRect">
-            <a:avLst/>
-          </a:prstGeom>
-          <a:solidFill>
-            <a:srgbClr val="0C1C30"/>
+            <a:srgbClr val="0C1326"/>
           </a:solidFill>
           <a:ln w="19050">
             <a:solidFill>
@@ -6920,14 +6917,14 @@
       </p:sp>
       <p:sp>
         <p:nvSpPr>
-          <p:cNvPr id="11" name="TextBox 10"/>
+          <p:cNvPr id="6" name="TextBox 5"/>
           <p:cNvSpPr txBox="1"/>
           <p:nvPr/>
         </p:nvSpPr>
         <p:spPr>
           <a:xfrm>
-            <a:off x="1097280" y="5532120"/>
-            <a:ext cx="9966960" cy="868680"/>
+            <a:off x="2194560" y="4480560"/>
+            <a:ext cx="3474720" cy="1188720"/>
           </a:xfrm>
           <a:prstGeom prst="rect">
             <a:avLst/>
@@ -6935,32 +6932,124 @@
           <a:noFill/>
         </p:spPr>
         <p:txBody>
-          <a:bodyPr wrap="square">
+          <a:bodyPr wrap="none">
             <a:spAutoFit/>
           </a:bodyPr>
           <a:lstStyle/>
           <a:p>
             <a:pPr>
-              <a:defRPr sz="1300" b="1">
+              <a:defRPr sz="2400" b="1">
                 <a:solidFill>
                   <a:srgbClr val="06B6D4"/>
                 </a:solidFill>
               </a:defRPr>
             </a:pPr>
             <a:r>
-              <a:t>COLOSSEUM CRYPTO WORLD'S FAIR 2026 SUBMISSION</a:t>
+              <a:t>🌐  bidtrace.net</a:t>
             </a:r>
           </a:p>
           <a:p>
             <a:pPr>
               <a:defRPr sz="1200">
                 <a:solidFill>
-                  <a:srgbClr val="FFFFFF"/>
+                  <a:srgbClr val="94A3B8"/>
                 </a:solidFill>
               </a:defRPr>
             </a:pPr>
             <a:r>
-              <a:t>Live Protocol: bidtrace.net  |  Program ID: x3iSm5BCoXvEfNwT6m6Vs7ApBJtKjvuTm7qKBJtESjZ  |  GitHub: Ujjwal1396/BidTrace</a:t>
+              <a:t>Live Interactive Protocol Portals &amp; Attack Demos</a:t>
+            </a:r>
+          </a:p>
+        </p:txBody>
+      </p:sp>
+      <p:sp>
+        <p:nvSpPr>
+          <p:cNvPr id="7" name="Rounded Rectangle 6"/>
+          <p:cNvSpPr/>
+          <p:nvPr/>
+        </p:nvSpPr>
+        <p:spPr>
+          <a:xfrm>
+            <a:off x="6309360" y="4297680"/>
+            <a:ext cx="3840480" cy="1554480"/>
+          </a:xfrm>
+          <a:prstGeom prst="roundRect">
+            <a:avLst/>
+          </a:prstGeom>
+          <a:solidFill>
+            <a:srgbClr val="0C1326"/>
+          </a:solidFill>
+          <a:ln w="19050">
+            <a:solidFill>
+              <a:srgbClr val="A855F7"/>
+            </a:solidFill>
+          </a:ln>
+        </p:spPr>
+        <p:style>
+          <a:lnRef idx="1">
+            <a:schemeClr val="accent1"/>
+          </a:lnRef>
+          <a:fillRef idx="3">
+            <a:schemeClr val="accent1"/>
+          </a:fillRef>
+          <a:effectRef idx="2">
+            <a:schemeClr val="accent1"/>
+          </a:effectRef>
+          <a:fontRef idx="minor">
+            <a:schemeClr val="lt1"/>
+          </a:fontRef>
+        </p:style>
+        <p:txBody>
+          <a:bodyPr rtlCol="0" anchor="ctr"/>
+          <a:lstStyle/>
+          <a:p>
+            <a:pPr algn="ctr"/>
+          </a:p>
+        </p:txBody>
+      </p:sp>
+      <p:sp>
+        <p:nvSpPr>
+          <p:cNvPr id="8" name="TextBox 7"/>
+          <p:cNvSpPr txBox="1"/>
+          <p:nvPr/>
+        </p:nvSpPr>
+        <p:spPr>
+          <a:xfrm>
+            <a:off x="6492240" y="4480560"/>
+            <a:ext cx="3474720" cy="1188720"/>
+          </a:xfrm>
+          <a:prstGeom prst="rect">
+            <a:avLst/>
+          </a:prstGeom>
+          <a:noFill/>
+        </p:spPr>
+        <p:txBody>
+          <a:bodyPr wrap="none">
+            <a:spAutoFit/>
+          </a:bodyPr>
+          <a:lstStyle/>
+          <a:p>
+            <a:pPr>
+              <a:defRPr sz="2400" b="1">
+                <a:solidFill>
+                  <a:srgbClr val="A855F7"/>
+                </a:solidFill>
+              </a:defRPr>
+            </a:pPr>
+            <a:r>
+              <a:t>𝕏   @bidtrace</a:t>
+            </a:r>
+          </a:p>
+          <a:p>
+            <a:pPr>
+              <a:defRPr sz="1200">
+                <a:solidFill>
+                  <a:srgbClr val="94A3B8"/>
+                </a:solidFill>
+              </a:defRPr>
+            </a:pPr>
+            <a:r>
+              <a:t>Follow Technical Releases &amp; Community Updates</a:t>
             </a:r>
           </a:p>
         </p:txBody>

</xml_diff>